<commit_message>
fix: add TEXT_TO_FIT_SHAPE auto-size to all text boxes (prevents overlap)
Text boxes now shrink font to fit their boundary instead of overflowing.

Co-Authored-By: Claude Sonnet 4.6 <noreply@anthropic.com>
</commit_message>
<xml_diff>
--- a/content/strategy/TitoAI-ContentBoostPlan-W26-W28.pptx
+++ b/content/strategy/TitoAI-ContentBoostPlan-W26-W28.pptx
@@ -3208,7 +3208,7 @@
         </p:spPr>
         <p:txBody>
           <a:bodyPr wrap="square">
-            <a:spAutoFit/>
+            <a:normAutofit/>
           </a:bodyPr>
           <a:lstStyle/>
           <a:p>
@@ -3243,7 +3243,7 @@
         </p:spPr>
         <p:txBody>
           <a:bodyPr wrap="square">
-            <a:spAutoFit/>
+            <a:normAutofit/>
           </a:bodyPr>
           <a:lstStyle/>
           <a:p>
@@ -3278,7 +3278,7 @@
         </p:spPr>
         <p:txBody>
           <a:bodyPr wrap="square">
-            <a:spAutoFit/>
+            <a:normAutofit/>
           </a:bodyPr>
           <a:lstStyle/>
           <a:p>
@@ -3313,7 +3313,7 @@
         </p:spPr>
         <p:txBody>
           <a:bodyPr wrap="square">
-            <a:spAutoFit/>
+            <a:normAutofit/>
           </a:bodyPr>
           <a:lstStyle/>
           <a:p>
@@ -3477,7 +3477,7 @@
         </p:spPr>
         <p:txBody>
           <a:bodyPr wrap="square">
-            <a:spAutoFit/>
+            <a:normAutofit/>
           </a:bodyPr>
           <a:lstStyle/>
           <a:p>
@@ -3512,7 +3512,7 @@
         </p:spPr>
         <p:txBody>
           <a:bodyPr wrap="square">
-            <a:spAutoFit/>
+            <a:normAutofit/>
           </a:bodyPr>
           <a:lstStyle/>
           <a:p>
@@ -3547,7 +3547,7 @@
         </p:spPr>
         <p:txBody>
           <a:bodyPr wrap="square">
-            <a:spAutoFit/>
+            <a:normAutofit/>
           </a:bodyPr>
           <a:lstStyle/>
           <a:p>
@@ -3668,7 +3668,7 @@
         </p:spPr>
         <p:txBody>
           <a:bodyPr wrap="square">
-            <a:spAutoFit/>
+            <a:normAutofit/>
           </a:bodyPr>
           <a:lstStyle/>
           <a:p>
@@ -3703,7 +3703,7 @@
         </p:spPr>
         <p:txBody>
           <a:bodyPr wrap="square">
-            <a:spAutoFit/>
+            <a:normAutofit/>
           </a:bodyPr>
           <a:lstStyle/>
           <a:p>
@@ -3738,7 +3738,7 @@
         </p:spPr>
         <p:txBody>
           <a:bodyPr wrap="square">
-            <a:spAutoFit/>
+            <a:normAutofit/>
           </a:bodyPr>
           <a:lstStyle/>
           <a:p>
@@ -3859,7 +3859,7 @@
         </p:spPr>
         <p:txBody>
           <a:bodyPr wrap="square">
-            <a:spAutoFit/>
+            <a:normAutofit/>
           </a:bodyPr>
           <a:lstStyle/>
           <a:p>
@@ -3894,7 +3894,7 @@
         </p:spPr>
         <p:txBody>
           <a:bodyPr wrap="square">
-            <a:spAutoFit/>
+            <a:normAutofit/>
           </a:bodyPr>
           <a:lstStyle/>
           <a:p>
@@ -3929,7 +3929,7 @@
         </p:spPr>
         <p:txBody>
           <a:bodyPr wrap="square">
-            <a:spAutoFit/>
+            <a:normAutofit/>
           </a:bodyPr>
           <a:lstStyle/>
           <a:p>
@@ -3964,7 +3964,7 @@
         </p:spPr>
         <p:txBody>
           <a:bodyPr wrap="square">
-            <a:spAutoFit/>
+            <a:normAutofit/>
           </a:bodyPr>
           <a:lstStyle/>
           <a:p>
@@ -3999,7 +3999,7 @@
         </p:spPr>
         <p:txBody>
           <a:bodyPr wrap="square">
-            <a:spAutoFit/>
+            <a:normAutofit/>
           </a:bodyPr>
           <a:lstStyle/>
           <a:p>
@@ -4034,7 +4034,7 @@
         </p:spPr>
         <p:txBody>
           <a:bodyPr wrap="square">
-            <a:spAutoFit/>
+            <a:normAutofit/>
           </a:bodyPr>
           <a:lstStyle/>
           <a:p>
@@ -4069,7 +4069,7 @@
         </p:spPr>
         <p:txBody>
           <a:bodyPr wrap="square">
-            <a:spAutoFit/>
+            <a:normAutofit/>
           </a:bodyPr>
           <a:lstStyle/>
           <a:p>
@@ -4104,7 +4104,7 @@
         </p:spPr>
         <p:txBody>
           <a:bodyPr wrap="square">
-            <a:spAutoFit/>
+            <a:normAutofit/>
           </a:bodyPr>
           <a:lstStyle/>
           <a:p>
@@ -4139,7 +4139,7 @@
         </p:spPr>
         <p:txBody>
           <a:bodyPr wrap="square">
-            <a:spAutoFit/>
+            <a:normAutofit/>
           </a:bodyPr>
           <a:lstStyle/>
           <a:p>
@@ -4217,7 +4217,7 @@
         </p:spPr>
         <p:txBody>
           <a:bodyPr wrap="square">
-            <a:spAutoFit/>
+            <a:normAutofit/>
           </a:bodyPr>
           <a:lstStyle/>
           <a:p>
@@ -4252,7 +4252,7 @@
         </p:spPr>
         <p:txBody>
           <a:bodyPr wrap="square">
-            <a:spAutoFit/>
+            <a:normAutofit/>
           </a:bodyPr>
           <a:lstStyle/>
           <a:p>
@@ -4399,7 +4399,7 @@
         </p:spPr>
         <p:txBody>
           <a:bodyPr wrap="square">
-            <a:spAutoFit/>
+            <a:normAutofit/>
           </a:bodyPr>
           <a:lstStyle/>
           <a:p>
@@ -4434,7 +4434,7 @@
         </p:spPr>
         <p:txBody>
           <a:bodyPr wrap="square">
-            <a:spAutoFit/>
+            <a:normAutofit/>
           </a:bodyPr>
           <a:lstStyle/>
           <a:p>
@@ -4598,7 +4598,7 @@
         </p:spPr>
         <p:txBody>
           <a:bodyPr wrap="square">
-            <a:spAutoFit/>
+            <a:normAutofit/>
           </a:bodyPr>
           <a:lstStyle/>
           <a:p>
@@ -4719,7 +4719,7 @@
         </p:spPr>
         <p:txBody>
           <a:bodyPr wrap="square">
-            <a:spAutoFit/>
+            <a:normAutofit/>
           </a:bodyPr>
           <a:lstStyle/>
           <a:p>
@@ -4754,7 +4754,7 @@
         </p:spPr>
         <p:txBody>
           <a:bodyPr wrap="square">
-            <a:spAutoFit/>
+            <a:normAutofit/>
           </a:bodyPr>
           <a:lstStyle/>
           <a:p>
@@ -4789,7 +4789,7 @@
         </p:spPr>
         <p:txBody>
           <a:bodyPr wrap="square">
-            <a:spAutoFit/>
+            <a:normAutofit/>
           </a:bodyPr>
           <a:lstStyle/>
           <a:p>
@@ -4910,7 +4910,7 @@
         </p:spPr>
         <p:txBody>
           <a:bodyPr wrap="square">
-            <a:spAutoFit/>
+            <a:normAutofit/>
           </a:bodyPr>
           <a:lstStyle/>
           <a:p>
@@ -4945,7 +4945,7 @@
         </p:spPr>
         <p:txBody>
           <a:bodyPr wrap="square">
-            <a:spAutoFit/>
+            <a:normAutofit/>
           </a:bodyPr>
           <a:lstStyle/>
           <a:p>
@@ -4980,7 +4980,7 @@
         </p:spPr>
         <p:txBody>
           <a:bodyPr wrap="square">
-            <a:spAutoFit/>
+            <a:normAutofit/>
           </a:bodyPr>
           <a:lstStyle/>
           <a:p>
@@ -5101,7 +5101,7 @@
         </p:spPr>
         <p:txBody>
           <a:bodyPr wrap="square">
-            <a:spAutoFit/>
+            <a:normAutofit/>
           </a:bodyPr>
           <a:lstStyle/>
           <a:p>
@@ -5136,7 +5136,7 @@
         </p:spPr>
         <p:txBody>
           <a:bodyPr wrap="square">
-            <a:spAutoFit/>
+            <a:normAutofit/>
           </a:bodyPr>
           <a:lstStyle/>
           <a:p>
@@ -5171,7 +5171,7 @@
         </p:spPr>
         <p:txBody>
           <a:bodyPr wrap="square">
-            <a:spAutoFit/>
+            <a:normAutofit/>
           </a:bodyPr>
           <a:lstStyle/>
           <a:p>
@@ -5292,7 +5292,7 @@
         </p:spPr>
         <p:txBody>
           <a:bodyPr wrap="square">
-            <a:spAutoFit/>
+            <a:normAutofit/>
           </a:bodyPr>
           <a:lstStyle/>
           <a:p>
@@ -5327,7 +5327,7 @@
         </p:spPr>
         <p:txBody>
           <a:bodyPr wrap="square">
-            <a:spAutoFit/>
+            <a:normAutofit/>
           </a:bodyPr>
           <a:lstStyle/>
           <a:p>
@@ -5362,7 +5362,7 @@
         </p:spPr>
         <p:txBody>
           <a:bodyPr wrap="square">
-            <a:spAutoFit/>
+            <a:normAutofit/>
           </a:bodyPr>
           <a:lstStyle/>
           <a:p>
@@ -5483,7 +5483,7 @@
         </p:spPr>
         <p:txBody>
           <a:bodyPr wrap="square">
-            <a:spAutoFit/>
+            <a:normAutofit/>
           </a:bodyPr>
           <a:lstStyle/>
           <a:p>
@@ -5518,7 +5518,7 @@
         </p:spPr>
         <p:txBody>
           <a:bodyPr wrap="square">
-            <a:spAutoFit/>
+            <a:normAutofit/>
           </a:bodyPr>
           <a:lstStyle/>
           <a:p>
@@ -5553,7 +5553,7 @@
         </p:spPr>
         <p:txBody>
           <a:bodyPr wrap="square">
-            <a:spAutoFit/>
+            <a:normAutofit/>
           </a:bodyPr>
           <a:lstStyle/>
           <a:p>
@@ -5631,7 +5631,7 @@
         </p:spPr>
         <p:txBody>
           <a:bodyPr wrap="square">
-            <a:spAutoFit/>
+            <a:normAutofit/>
           </a:bodyPr>
           <a:lstStyle/>
           <a:p>
@@ -5709,7 +5709,7 @@
         </p:spPr>
         <p:txBody>
           <a:bodyPr wrap="square">
-            <a:spAutoFit/>
+            <a:normAutofit/>
           </a:bodyPr>
           <a:lstStyle/>
           <a:p>
@@ -5744,7 +5744,7 @@
         </p:spPr>
         <p:txBody>
           <a:bodyPr wrap="square">
-            <a:spAutoFit/>
+            <a:normAutofit/>
           </a:bodyPr>
           <a:lstStyle/>
           <a:p>
@@ -5822,7 +5822,7 @@
         </p:spPr>
         <p:txBody>
           <a:bodyPr wrap="square">
-            <a:spAutoFit/>
+            <a:normAutofit/>
           </a:bodyPr>
           <a:lstStyle/>
           <a:p>
@@ -5857,7 +5857,7 @@
         </p:spPr>
         <p:txBody>
           <a:bodyPr wrap="square">
-            <a:spAutoFit/>
+            <a:normAutofit/>
           </a:bodyPr>
           <a:lstStyle/>
           <a:p>
@@ -5935,7 +5935,7 @@
         </p:spPr>
         <p:txBody>
           <a:bodyPr wrap="square">
-            <a:spAutoFit/>
+            <a:normAutofit/>
           </a:bodyPr>
           <a:lstStyle/>
           <a:p>
@@ -5970,7 +5970,7 @@
         </p:spPr>
         <p:txBody>
           <a:bodyPr wrap="square">
-            <a:spAutoFit/>
+            <a:normAutofit/>
           </a:bodyPr>
           <a:lstStyle/>
           <a:p>
@@ -6048,7 +6048,7 @@
         </p:spPr>
         <p:txBody>
           <a:bodyPr wrap="square">
-            <a:spAutoFit/>
+            <a:normAutofit/>
           </a:bodyPr>
           <a:lstStyle/>
           <a:p>
@@ -6083,7 +6083,7 @@
         </p:spPr>
         <p:txBody>
           <a:bodyPr wrap="square">
-            <a:spAutoFit/>
+            <a:normAutofit/>
           </a:bodyPr>
           <a:lstStyle/>
           <a:p>
@@ -6161,7 +6161,7 @@
         </p:spPr>
         <p:txBody>
           <a:bodyPr wrap="square">
-            <a:spAutoFit/>
+            <a:normAutofit/>
           </a:bodyPr>
           <a:lstStyle/>
           <a:p>
@@ -6196,7 +6196,7 @@
         </p:spPr>
         <p:txBody>
           <a:bodyPr wrap="square">
-            <a:spAutoFit/>
+            <a:normAutofit/>
           </a:bodyPr>
           <a:lstStyle/>
           <a:p>
@@ -6274,7 +6274,7 @@
         </p:spPr>
         <p:txBody>
           <a:bodyPr wrap="square">
-            <a:spAutoFit/>
+            <a:normAutofit/>
           </a:bodyPr>
           <a:lstStyle/>
           <a:p>
@@ -6309,7 +6309,7 @@
         </p:spPr>
         <p:txBody>
           <a:bodyPr wrap="square">
-            <a:spAutoFit/>
+            <a:normAutofit/>
           </a:bodyPr>
           <a:lstStyle/>
           <a:p>
@@ -6387,7 +6387,7 @@
         </p:spPr>
         <p:txBody>
           <a:bodyPr wrap="square">
-            <a:spAutoFit/>
+            <a:normAutofit/>
           </a:bodyPr>
           <a:lstStyle/>
           <a:p>
@@ -6422,7 +6422,7 @@
         </p:spPr>
         <p:txBody>
           <a:bodyPr wrap="square">
-            <a:spAutoFit/>
+            <a:normAutofit/>
           </a:bodyPr>
           <a:lstStyle/>
           <a:p>
@@ -6500,7 +6500,7 @@
         </p:spPr>
         <p:txBody>
           <a:bodyPr wrap="square">
-            <a:spAutoFit/>
+            <a:normAutofit/>
           </a:bodyPr>
           <a:lstStyle/>
           <a:p>
@@ -6578,7 +6578,7 @@
         </p:spPr>
         <p:txBody>
           <a:bodyPr wrap="square">
-            <a:spAutoFit/>
+            <a:normAutofit/>
           </a:bodyPr>
           <a:lstStyle/>
           <a:p>
@@ -6613,7 +6613,7 @@
         </p:spPr>
         <p:txBody>
           <a:bodyPr wrap="square">
-            <a:spAutoFit/>
+            <a:normAutofit/>
           </a:bodyPr>
           <a:lstStyle/>
           <a:p>
@@ -6760,7 +6760,7 @@
         </p:spPr>
         <p:txBody>
           <a:bodyPr wrap="square">
-            <a:spAutoFit/>
+            <a:normAutofit/>
           </a:bodyPr>
           <a:lstStyle/>
           <a:p>
@@ -6795,7 +6795,7 @@
         </p:spPr>
         <p:txBody>
           <a:bodyPr wrap="square">
-            <a:spAutoFit/>
+            <a:normAutofit/>
           </a:bodyPr>
           <a:lstStyle/>
           <a:p>
@@ -6959,7 +6959,7 @@
         </p:spPr>
         <p:txBody>
           <a:bodyPr wrap="square">
-            <a:spAutoFit/>
+            <a:normAutofit/>
           </a:bodyPr>
           <a:lstStyle/>
           <a:p>
@@ -6994,7 +6994,7 @@
         </p:spPr>
         <p:txBody>
           <a:bodyPr wrap="square">
-            <a:spAutoFit/>
+            <a:normAutofit/>
           </a:bodyPr>
           <a:lstStyle/>
           <a:p>
@@ -7115,7 +7115,7 @@
         </p:spPr>
         <p:txBody>
           <a:bodyPr wrap="square">
-            <a:spAutoFit/>
+            <a:normAutofit/>
           </a:bodyPr>
           <a:lstStyle/>
           <a:p>
@@ -7150,7 +7150,7 @@
         </p:spPr>
         <p:txBody>
           <a:bodyPr wrap="square">
-            <a:spAutoFit/>
+            <a:normAutofit/>
           </a:bodyPr>
           <a:lstStyle/>
           <a:p>
@@ -7271,7 +7271,7 @@
         </p:spPr>
         <p:txBody>
           <a:bodyPr wrap="square">
-            <a:spAutoFit/>
+            <a:normAutofit/>
           </a:bodyPr>
           <a:lstStyle/>
           <a:p>
@@ -7306,7 +7306,7 @@
         </p:spPr>
         <p:txBody>
           <a:bodyPr wrap="square">
-            <a:spAutoFit/>
+            <a:normAutofit/>
           </a:bodyPr>
           <a:lstStyle/>
           <a:p>
@@ -7427,7 +7427,7 @@
         </p:spPr>
         <p:txBody>
           <a:bodyPr wrap="square">
-            <a:spAutoFit/>
+            <a:normAutofit/>
           </a:bodyPr>
           <a:lstStyle/>
           <a:p>
@@ -7462,7 +7462,7 @@
         </p:spPr>
         <p:txBody>
           <a:bodyPr wrap="square">
-            <a:spAutoFit/>
+            <a:normAutofit/>
           </a:bodyPr>
           <a:lstStyle/>
           <a:p>
@@ -7583,7 +7583,7 @@
         </p:spPr>
         <p:txBody>
           <a:bodyPr wrap="square">
-            <a:spAutoFit/>
+            <a:normAutofit/>
           </a:bodyPr>
           <a:lstStyle/>
           <a:p>
@@ -7618,7 +7618,7 @@
         </p:spPr>
         <p:txBody>
           <a:bodyPr wrap="square">
-            <a:spAutoFit/>
+            <a:normAutofit/>
           </a:bodyPr>
           <a:lstStyle/>
           <a:p>
@@ -7696,7 +7696,7 @@
         </p:spPr>
         <p:txBody>
           <a:bodyPr wrap="square">
-            <a:spAutoFit/>
+            <a:normAutofit/>
           </a:bodyPr>
           <a:lstStyle/>
           <a:p>
@@ -7817,7 +7817,7 @@
         </p:spPr>
         <p:txBody>
           <a:bodyPr wrap="square">
-            <a:spAutoFit/>
+            <a:normAutofit/>
           </a:bodyPr>
           <a:lstStyle/>
           <a:p>
@@ -7852,7 +7852,7 @@
         </p:spPr>
         <p:txBody>
           <a:bodyPr wrap="square">
-            <a:spAutoFit/>
+            <a:normAutofit/>
           </a:bodyPr>
           <a:lstStyle/>
           <a:p>
@@ -7930,7 +7930,7 @@
         </p:spPr>
         <p:txBody>
           <a:bodyPr wrap="square">
-            <a:spAutoFit/>
+            <a:normAutofit/>
           </a:bodyPr>
           <a:lstStyle/>
           <a:p>
@@ -7965,7 +7965,7 @@
         </p:spPr>
         <p:txBody>
           <a:bodyPr wrap="square">
-            <a:spAutoFit/>
+            <a:normAutofit/>
           </a:bodyPr>
           <a:lstStyle/>
           <a:p>
@@ -8000,7 +8000,7 @@
         </p:spPr>
         <p:txBody>
           <a:bodyPr wrap="square">
-            <a:spAutoFit/>
+            <a:normAutofit/>
           </a:bodyPr>
           <a:lstStyle/>
           <a:p>
@@ -8121,7 +8121,7 @@
         </p:spPr>
         <p:txBody>
           <a:bodyPr wrap="square">
-            <a:spAutoFit/>
+            <a:normAutofit/>
           </a:bodyPr>
           <a:lstStyle/>
           <a:p>
@@ -8156,7 +8156,7 @@
         </p:spPr>
         <p:txBody>
           <a:bodyPr wrap="square">
-            <a:spAutoFit/>
+            <a:normAutofit/>
           </a:bodyPr>
           <a:lstStyle/>
           <a:p>
@@ -8234,7 +8234,7 @@
         </p:spPr>
         <p:txBody>
           <a:bodyPr wrap="square">
-            <a:spAutoFit/>
+            <a:normAutofit/>
           </a:bodyPr>
           <a:lstStyle/>
           <a:p>
@@ -8269,7 +8269,7 @@
         </p:spPr>
         <p:txBody>
           <a:bodyPr wrap="square">
-            <a:spAutoFit/>
+            <a:normAutofit/>
           </a:bodyPr>
           <a:lstStyle/>
           <a:p>
@@ -8304,7 +8304,7 @@
         </p:spPr>
         <p:txBody>
           <a:bodyPr wrap="square">
-            <a:spAutoFit/>
+            <a:normAutofit/>
           </a:bodyPr>
           <a:lstStyle/>
           <a:p>
@@ -8425,7 +8425,7 @@
         </p:spPr>
         <p:txBody>
           <a:bodyPr wrap="square">
-            <a:spAutoFit/>
+            <a:normAutofit/>
           </a:bodyPr>
           <a:lstStyle/>
           <a:p>
@@ -8460,7 +8460,7 @@
         </p:spPr>
         <p:txBody>
           <a:bodyPr wrap="square">
-            <a:spAutoFit/>
+            <a:normAutofit/>
           </a:bodyPr>
           <a:lstStyle/>
           <a:p>
@@ -8538,7 +8538,7 @@
         </p:spPr>
         <p:txBody>
           <a:bodyPr wrap="square">
-            <a:spAutoFit/>
+            <a:normAutofit/>
           </a:bodyPr>
           <a:lstStyle/>
           <a:p>
@@ -8573,7 +8573,7 @@
         </p:spPr>
         <p:txBody>
           <a:bodyPr wrap="square">
-            <a:spAutoFit/>
+            <a:normAutofit/>
           </a:bodyPr>
           <a:lstStyle/>
           <a:p>
@@ -8608,7 +8608,7 @@
         </p:spPr>
         <p:txBody>
           <a:bodyPr wrap="square">
-            <a:spAutoFit/>
+            <a:normAutofit/>
           </a:bodyPr>
           <a:lstStyle/>
           <a:p>
@@ -8686,7 +8686,7 @@
         </p:spPr>
         <p:txBody>
           <a:bodyPr wrap="square">
-            <a:spAutoFit/>
+            <a:normAutofit/>
           </a:bodyPr>
           <a:lstStyle/>
           <a:p>
@@ -8721,7 +8721,7 @@
         </p:spPr>
         <p:txBody>
           <a:bodyPr wrap="square">
-            <a:spAutoFit/>
+            <a:normAutofit/>
           </a:bodyPr>
           <a:lstStyle/>
           <a:p>
@@ -8868,7 +8868,7 @@
         </p:spPr>
         <p:txBody>
           <a:bodyPr wrap="square">
-            <a:spAutoFit/>
+            <a:normAutofit/>
           </a:bodyPr>
           <a:lstStyle/>
           <a:p>
@@ -8903,7 +8903,7 @@
         </p:spPr>
         <p:txBody>
           <a:bodyPr wrap="square">
-            <a:spAutoFit/>
+            <a:normAutofit/>
           </a:bodyPr>
           <a:lstStyle/>
           <a:p>
@@ -9024,7 +9024,7 @@
         </p:spPr>
         <p:txBody>
           <a:bodyPr wrap="square">
-            <a:spAutoFit/>
+            <a:normAutofit/>
           </a:bodyPr>
           <a:lstStyle/>
           <a:p>
@@ -9102,7 +9102,7 @@
         </p:spPr>
         <p:txBody>
           <a:bodyPr wrap="square">
-            <a:spAutoFit/>
+            <a:normAutofit/>
           </a:bodyPr>
           <a:lstStyle/>
           <a:p>
@@ -9180,7 +9180,7 @@
         </p:spPr>
         <p:txBody>
           <a:bodyPr wrap="square">
-            <a:spAutoFit/>
+            <a:normAutofit/>
           </a:bodyPr>
           <a:lstStyle/>
           <a:p>
@@ -9258,7 +9258,7 @@
         </p:spPr>
         <p:txBody>
           <a:bodyPr wrap="square">
-            <a:spAutoFit/>
+            <a:normAutofit/>
           </a:bodyPr>
           <a:lstStyle/>
           <a:p>
@@ -9336,7 +9336,7 @@
         </p:spPr>
         <p:txBody>
           <a:bodyPr wrap="square">
-            <a:spAutoFit/>
+            <a:normAutofit/>
           </a:bodyPr>
           <a:lstStyle/>
           <a:p>
@@ -9414,7 +9414,7 @@
         </p:spPr>
         <p:txBody>
           <a:bodyPr wrap="square">
-            <a:spAutoFit/>
+            <a:normAutofit/>
           </a:bodyPr>
           <a:lstStyle/>
           <a:p>
@@ -9492,7 +9492,7 @@
         </p:spPr>
         <p:txBody>
           <a:bodyPr wrap="square">
-            <a:spAutoFit/>
+            <a:normAutofit/>
           </a:bodyPr>
           <a:lstStyle/>
           <a:p>
@@ -9871,7 +9871,7 @@
         </p:spPr>
         <p:txBody>
           <a:bodyPr wrap="square">
-            <a:spAutoFit/>
+            <a:normAutofit/>
           </a:bodyPr>
           <a:lstStyle/>
           <a:p>
@@ -9906,7 +9906,7 @@
         </p:spPr>
         <p:txBody>
           <a:bodyPr wrap="square">
-            <a:spAutoFit/>
+            <a:normAutofit/>
           </a:bodyPr>
           <a:lstStyle/>
           <a:p>
@@ -9941,7 +9941,7 @@
         </p:spPr>
         <p:txBody>
           <a:bodyPr wrap="square">
-            <a:spAutoFit/>
+            <a:normAutofit/>
           </a:bodyPr>
           <a:lstStyle/>
           <a:p>
@@ -9976,7 +9976,7 @@
         </p:spPr>
         <p:txBody>
           <a:bodyPr wrap="square">
-            <a:spAutoFit/>
+            <a:normAutofit/>
           </a:bodyPr>
           <a:lstStyle/>
           <a:p>
@@ -10054,7 +10054,7 @@
         </p:spPr>
         <p:txBody>
           <a:bodyPr wrap="square">
-            <a:spAutoFit/>
+            <a:normAutofit/>
           </a:bodyPr>
           <a:lstStyle/>
           <a:p>
@@ -10089,7 +10089,7 @@
         </p:spPr>
         <p:txBody>
           <a:bodyPr wrap="square">
-            <a:spAutoFit/>
+            <a:normAutofit/>
           </a:bodyPr>
           <a:lstStyle/>
           <a:p>
@@ -10124,7 +10124,7 @@
         </p:spPr>
         <p:txBody>
           <a:bodyPr wrap="square">
-            <a:spAutoFit/>
+            <a:normAutofit/>
           </a:bodyPr>
           <a:lstStyle/>
           <a:p>
@@ -10503,7 +10503,7 @@
         </p:spPr>
         <p:txBody>
           <a:bodyPr wrap="square">
-            <a:spAutoFit/>
+            <a:normAutofit/>
           </a:bodyPr>
           <a:lstStyle/>
           <a:p>
@@ -10538,7 +10538,7 @@
         </p:spPr>
         <p:txBody>
           <a:bodyPr wrap="square">
-            <a:spAutoFit/>
+            <a:normAutofit/>
           </a:bodyPr>
           <a:lstStyle/>
           <a:p>
@@ -10573,7 +10573,7 @@
         </p:spPr>
         <p:txBody>
           <a:bodyPr wrap="square">
-            <a:spAutoFit/>
+            <a:normAutofit/>
           </a:bodyPr>
           <a:lstStyle/>
           <a:p>
@@ -10608,7 +10608,7 @@
         </p:spPr>
         <p:txBody>
           <a:bodyPr wrap="square">
-            <a:spAutoFit/>
+            <a:normAutofit/>
           </a:bodyPr>
           <a:lstStyle/>
           <a:p>
@@ -10686,7 +10686,7 @@
         </p:spPr>
         <p:txBody>
           <a:bodyPr wrap="square">
-            <a:spAutoFit/>
+            <a:normAutofit/>
           </a:bodyPr>
           <a:lstStyle/>
           <a:p>
@@ -10721,7 +10721,7 @@
         </p:spPr>
         <p:txBody>
           <a:bodyPr wrap="square">
-            <a:spAutoFit/>
+            <a:normAutofit/>
           </a:bodyPr>
           <a:lstStyle/>
           <a:p>
@@ -10756,7 +10756,7 @@
         </p:spPr>
         <p:txBody>
           <a:bodyPr wrap="square">
-            <a:spAutoFit/>
+            <a:normAutofit/>
           </a:bodyPr>
           <a:lstStyle/>
           <a:p>
@@ -11135,7 +11135,7 @@
         </p:spPr>
         <p:txBody>
           <a:bodyPr wrap="square">
-            <a:spAutoFit/>
+            <a:normAutofit/>
           </a:bodyPr>
           <a:lstStyle/>
           <a:p>
@@ -11170,7 +11170,7 @@
         </p:spPr>
         <p:txBody>
           <a:bodyPr wrap="square">
-            <a:spAutoFit/>
+            <a:normAutofit/>
           </a:bodyPr>
           <a:lstStyle/>
           <a:p>
@@ -11205,7 +11205,7 @@
         </p:spPr>
         <p:txBody>
           <a:bodyPr wrap="square">
-            <a:spAutoFit/>
+            <a:normAutofit/>
           </a:bodyPr>
           <a:lstStyle/>
           <a:p>
@@ -11240,7 +11240,7 @@
         </p:spPr>
         <p:txBody>
           <a:bodyPr wrap="square">
-            <a:spAutoFit/>
+            <a:normAutofit/>
           </a:bodyPr>
           <a:lstStyle/>
           <a:p>
@@ -11318,7 +11318,7 @@
         </p:spPr>
         <p:txBody>
           <a:bodyPr wrap="square">
-            <a:spAutoFit/>
+            <a:normAutofit/>
           </a:bodyPr>
           <a:lstStyle/>
           <a:p>
@@ -11353,7 +11353,7 @@
         </p:spPr>
         <p:txBody>
           <a:bodyPr wrap="square">
-            <a:spAutoFit/>
+            <a:normAutofit/>
           </a:bodyPr>
           <a:lstStyle/>
           <a:p>
@@ -11388,7 +11388,7 @@
         </p:spPr>
         <p:txBody>
           <a:bodyPr wrap="square">
-            <a:spAutoFit/>
+            <a:normAutofit/>
           </a:bodyPr>
           <a:lstStyle/>
           <a:p>
@@ -11767,7 +11767,7 @@
         </p:spPr>
         <p:txBody>
           <a:bodyPr wrap="square">
-            <a:spAutoFit/>
+            <a:normAutofit/>
           </a:bodyPr>
           <a:lstStyle/>
           <a:p>
@@ -11802,7 +11802,7 @@
         </p:spPr>
         <p:txBody>
           <a:bodyPr wrap="square">
-            <a:spAutoFit/>
+            <a:normAutofit/>
           </a:bodyPr>
           <a:lstStyle/>
           <a:p>
@@ -11837,7 +11837,7 @@
         </p:spPr>
         <p:txBody>
           <a:bodyPr wrap="square">
-            <a:spAutoFit/>
+            <a:normAutofit/>
           </a:bodyPr>
           <a:lstStyle/>
           <a:p>
@@ -11872,7 +11872,7 @@
         </p:spPr>
         <p:txBody>
           <a:bodyPr wrap="square">
-            <a:spAutoFit/>
+            <a:normAutofit/>
           </a:bodyPr>
           <a:lstStyle/>
           <a:p>
@@ -11950,7 +11950,7 @@
         </p:spPr>
         <p:txBody>
           <a:bodyPr wrap="square">
-            <a:spAutoFit/>
+            <a:normAutofit/>
           </a:bodyPr>
           <a:lstStyle/>
           <a:p>
@@ -11985,7 +11985,7 @@
         </p:spPr>
         <p:txBody>
           <a:bodyPr wrap="square">
-            <a:spAutoFit/>
+            <a:normAutofit/>
           </a:bodyPr>
           <a:lstStyle/>
           <a:p>
@@ -12020,7 +12020,7 @@
         </p:spPr>
         <p:txBody>
           <a:bodyPr wrap="square">
-            <a:spAutoFit/>
+            <a:normAutofit/>
           </a:bodyPr>
           <a:lstStyle/>
           <a:p>
@@ -12399,7 +12399,7 @@
         </p:spPr>
         <p:txBody>
           <a:bodyPr wrap="square">
-            <a:spAutoFit/>
+            <a:normAutofit/>
           </a:bodyPr>
           <a:lstStyle/>
           <a:p>
@@ -12434,7 +12434,7 @@
         </p:spPr>
         <p:txBody>
           <a:bodyPr wrap="square">
-            <a:spAutoFit/>
+            <a:normAutofit/>
           </a:bodyPr>
           <a:lstStyle/>
           <a:p>
@@ -12469,7 +12469,7 @@
         </p:spPr>
         <p:txBody>
           <a:bodyPr wrap="square">
-            <a:spAutoFit/>
+            <a:normAutofit/>
           </a:bodyPr>
           <a:lstStyle/>
           <a:p>
@@ -12504,7 +12504,7 @@
         </p:spPr>
         <p:txBody>
           <a:bodyPr wrap="square">
-            <a:spAutoFit/>
+            <a:normAutofit/>
           </a:bodyPr>
           <a:lstStyle/>
           <a:p>
@@ -12582,7 +12582,7 @@
         </p:spPr>
         <p:txBody>
           <a:bodyPr wrap="square">
-            <a:spAutoFit/>
+            <a:normAutofit/>
           </a:bodyPr>
           <a:lstStyle/>
           <a:p>
@@ -12617,7 +12617,7 @@
         </p:spPr>
         <p:txBody>
           <a:bodyPr wrap="square">
-            <a:spAutoFit/>
+            <a:normAutofit/>
           </a:bodyPr>
           <a:lstStyle/>
           <a:p>
@@ -12652,7 +12652,7 @@
         </p:spPr>
         <p:txBody>
           <a:bodyPr wrap="square">
-            <a:spAutoFit/>
+            <a:normAutofit/>
           </a:bodyPr>
           <a:lstStyle/>
           <a:p>
@@ -13031,7 +13031,7 @@
         </p:spPr>
         <p:txBody>
           <a:bodyPr wrap="square">
-            <a:spAutoFit/>
+            <a:normAutofit/>
           </a:bodyPr>
           <a:lstStyle/>
           <a:p>
@@ -13066,7 +13066,7 @@
         </p:spPr>
         <p:txBody>
           <a:bodyPr wrap="square">
-            <a:spAutoFit/>
+            <a:normAutofit/>
           </a:bodyPr>
           <a:lstStyle/>
           <a:p>
@@ -13101,7 +13101,7 @@
         </p:spPr>
         <p:txBody>
           <a:bodyPr wrap="square">
-            <a:spAutoFit/>
+            <a:normAutofit/>
           </a:bodyPr>
           <a:lstStyle/>
           <a:p>
@@ -13136,7 +13136,7 @@
         </p:spPr>
         <p:txBody>
           <a:bodyPr wrap="square">
-            <a:spAutoFit/>
+            <a:normAutofit/>
           </a:bodyPr>
           <a:lstStyle/>
           <a:p>
@@ -13214,7 +13214,7 @@
         </p:spPr>
         <p:txBody>
           <a:bodyPr wrap="square">
-            <a:spAutoFit/>
+            <a:normAutofit/>
           </a:bodyPr>
           <a:lstStyle/>
           <a:p>
@@ -13249,7 +13249,7 @@
         </p:spPr>
         <p:txBody>
           <a:bodyPr wrap="square">
-            <a:spAutoFit/>
+            <a:normAutofit/>
           </a:bodyPr>
           <a:lstStyle/>
           <a:p>
@@ -13284,7 +13284,7 @@
         </p:spPr>
         <p:txBody>
           <a:bodyPr wrap="square">
-            <a:spAutoFit/>
+            <a:normAutofit/>
           </a:bodyPr>
           <a:lstStyle/>
           <a:p>
@@ -13663,7 +13663,7 @@
         </p:spPr>
         <p:txBody>
           <a:bodyPr wrap="square">
-            <a:spAutoFit/>
+            <a:normAutofit/>
           </a:bodyPr>
           <a:lstStyle/>
           <a:p>
@@ -13698,7 +13698,7 @@
         </p:spPr>
         <p:txBody>
           <a:bodyPr wrap="square">
-            <a:spAutoFit/>
+            <a:normAutofit/>
           </a:bodyPr>
           <a:lstStyle/>
           <a:p>
@@ -13733,7 +13733,7 @@
         </p:spPr>
         <p:txBody>
           <a:bodyPr wrap="square">
-            <a:spAutoFit/>
+            <a:normAutofit/>
           </a:bodyPr>
           <a:lstStyle/>
           <a:p>
@@ -13768,7 +13768,7 @@
         </p:spPr>
         <p:txBody>
           <a:bodyPr wrap="square">
-            <a:spAutoFit/>
+            <a:normAutofit/>
           </a:bodyPr>
           <a:lstStyle/>
           <a:p>
@@ -13846,7 +13846,7 @@
         </p:spPr>
         <p:txBody>
           <a:bodyPr wrap="square">
-            <a:spAutoFit/>
+            <a:normAutofit/>
           </a:bodyPr>
           <a:lstStyle/>
           <a:p>
@@ -13881,7 +13881,7 @@
         </p:spPr>
         <p:txBody>
           <a:bodyPr wrap="square">
-            <a:spAutoFit/>
+            <a:normAutofit/>
           </a:bodyPr>
           <a:lstStyle/>
           <a:p>
@@ -13916,7 +13916,7 @@
         </p:spPr>
         <p:txBody>
           <a:bodyPr wrap="square">
-            <a:spAutoFit/>
+            <a:normAutofit/>
           </a:bodyPr>
           <a:lstStyle/>
           <a:p>
@@ -14295,7 +14295,7 @@
         </p:spPr>
         <p:txBody>
           <a:bodyPr wrap="square">
-            <a:spAutoFit/>
+            <a:normAutofit/>
           </a:bodyPr>
           <a:lstStyle/>
           <a:p>
@@ -14330,7 +14330,7 @@
         </p:spPr>
         <p:txBody>
           <a:bodyPr wrap="square">
-            <a:spAutoFit/>
+            <a:normAutofit/>
           </a:bodyPr>
           <a:lstStyle/>
           <a:p>
@@ -14365,7 +14365,7 @@
         </p:spPr>
         <p:txBody>
           <a:bodyPr wrap="square">
-            <a:spAutoFit/>
+            <a:normAutofit/>
           </a:bodyPr>
           <a:lstStyle/>
           <a:p>
@@ -14400,7 +14400,7 @@
         </p:spPr>
         <p:txBody>
           <a:bodyPr wrap="square">
-            <a:spAutoFit/>
+            <a:normAutofit/>
           </a:bodyPr>
           <a:lstStyle/>
           <a:p>
@@ -14478,7 +14478,7 @@
         </p:spPr>
         <p:txBody>
           <a:bodyPr wrap="square">
-            <a:spAutoFit/>
+            <a:normAutofit/>
           </a:bodyPr>
           <a:lstStyle/>
           <a:p>
@@ -14513,7 +14513,7 @@
         </p:spPr>
         <p:txBody>
           <a:bodyPr wrap="square">
-            <a:spAutoFit/>
+            <a:normAutofit/>
           </a:bodyPr>
           <a:lstStyle/>
           <a:p>
@@ -14548,7 +14548,7 @@
         </p:spPr>
         <p:txBody>
           <a:bodyPr wrap="square">
-            <a:spAutoFit/>
+            <a:normAutofit/>
           </a:bodyPr>
           <a:lstStyle/>
           <a:p>
@@ -14927,7 +14927,7 @@
         </p:spPr>
         <p:txBody>
           <a:bodyPr wrap="square">
-            <a:spAutoFit/>
+            <a:normAutofit/>
           </a:bodyPr>
           <a:lstStyle/>
           <a:p>
@@ -14962,7 +14962,7 @@
         </p:spPr>
         <p:txBody>
           <a:bodyPr wrap="square">
-            <a:spAutoFit/>
+            <a:normAutofit/>
           </a:bodyPr>
           <a:lstStyle/>
           <a:p>
@@ -14997,7 +14997,7 @@
         </p:spPr>
         <p:txBody>
           <a:bodyPr wrap="square">
-            <a:spAutoFit/>
+            <a:normAutofit/>
           </a:bodyPr>
           <a:lstStyle/>
           <a:p>
@@ -15032,7 +15032,7 @@
         </p:spPr>
         <p:txBody>
           <a:bodyPr wrap="square">
-            <a:spAutoFit/>
+            <a:normAutofit/>
           </a:bodyPr>
           <a:lstStyle/>
           <a:p>
@@ -15110,7 +15110,7 @@
         </p:spPr>
         <p:txBody>
           <a:bodyPr wrap="square">
-            <a:spAutoFit/>
+            <a:normAutofit/>
           </a:bodyPr>
           <a:lstStyle/>
           <a:p>
@@ -15145,7 +15145,7 @@
         </p:spPr>
         <p:txBody>
           <a:bodyPr wrap="square">
-            <a:spAutoFit/>
+            <a:normAutofit/>
           </a:bodyPr>
           <a:lstStyle/>
           <a:p>
@@ -15180,7 +15180,7 @@
         </p:spPr>
         <p:txBody>
           <a:bodyPr wrap="square">
-            <a:spAutoFit/>
+            <a:normAutofit/>
           </a:bodyPr>
           <a:lstStyle/>
           <a:p>
@@ -15516,7 +15516,7 @@
         </p:spPr>
         <p:txBody>
           <a:bodyPr wrap="square">
-            <a:spAutoFit/>
+            <a:normAutofit/>
           </a:bodyPr>
           <a:lstStyle/>
           <a:p>
@@ -15551,7 +15551,7 @@
         </p:spPr>
         <p:txBody>
           <a:bodyPr wrap="square">
-            <a:spAutoFit/>
+            <a:normAutofit/>
           </a:bodyPr>
           <a:lstStyle/>
           <a:p>
@@ -15586,7 +15586,7 @@
         </p:spPr>
         <p:txBody>
           <a:bodyPr wrap="square">
-            <a:spAutoFit/>
+            <a:normAutofit/>
           </a:bodyPr>
           <a:lstStyle/>
           <a:p>
@@ -15621,7 +15621,7 @@
         </p:spPr>
         <p:txBody>
           <a:bodyPr wrap="square">
-            <a:spAutoFit/>
+            <a:normAutofit/>
           </a:bodyPr>
           <a:lstStyle/>
           <a:p>
@@ -15699,7 +15699,7 @@
         </p:spPr>
         <p:txBody>
           <a:bodyPr wrap="square">
-            <a:spAutoFit/>
+            <a:normAutofit/>
           </a:bodyPr>
           <a:lstStyle/>
           <a:p>
@@ -15734,7 +15734,7 @@
         </p:spPr>
         <p:txBody>
           <a:bodyPr wrap="square">
-            <a:spAutoFit/>
+            <a:normAutofit/>
           </a:bodyPr>
           <a:lstStyle/>
           <a:p>
@@ -15881,7 +15881,7 @@
         </p:spPr>
         <p:txBody>
           <a:bodyPr wrap="square">
-            <a:spAutoFit/>
+            <a:normAutofit/>
           </a:bodyPr>
           <a:lstStyle/>
           <a:p>
@@ -15916,7 +15916,7 @@
         </p:spPr>
         <p:txBody>
           <a:bodyPr wrap="square">
-            <a:spAutoFit/>
+            <a:normAutofit/>
           </a:bodyPr>
           <a:lstStyle/>
           <a:p>
@@ -16037,7 +16037,7 @@
         </p:spPr>
         <p:txBody>
           <a:bodyPr wrap="square">
-            <a:spAutoFit/>
+            <a:normAutofit/>
           </a:bodyPr>
           <a:lstStyle/>
           <a:p>
@@ -16158,7 +16158,7 @@
         </p:spPr>
         <p:txBody>
           <a:bodyPr wrap="square">
-            <a:spAutoFit/>
+            <a:normAutofit/>
           </a:bodyPr>
           <a:lstStyle/>
           <a:p>
@@ -16193,7 +16193,7 @@
         </p:spPr>
         <p:txBody>
           <a:bodyPr wrap="square">
-            <a:spAutoFit/>
+            <a:normAutofit/>
           </a:bodyPr>
           <a:lstStyle/>
           <a:p>
@@ -16228,7 +16228,7 @@
         </p:spPr>
         <p:txBody>
           <a:bodyPr wrap="square">
-            <a:spAutoFit/>
+            <a:normAutofit/>
           </a:bodyPr>
           <a:lstStyle/>
           <a:p>
@@ -16263,7 +16263,7 @@
         </p:spPr>
         <p:txBody>
           <a:bodyPr wrap="square">
-            <a:spAutoFit/>
+            <a:normAutofit/>
           </a:bodyPr>
           <a:lstStyle/>
           <a:p>
@@ -16341,7 +16341,7 @@
         </p:spPr>
         <p:txBody>
           <a:bodyPr wrap="square">
-            <a:spAutoFit/>
+            <a:normAutofit/>
           </a:bodyPr>
           <a:lstStyle/>
           <a:p>
@@ -16462,7 +16462,7 @@
         </p:spPr>
         <p:txBody>
           <a:bodyPr wrap="square">
-            <a:spAutoFit/>
+            <a:normAutofit/>
           </a:bodyPr>
           <a:lstStyle/>
           <a:p>
@@ -16497,7 +16497,7 @@
         </p:spPr>
         <p:txBody>
           <a:bodyPr wrap="square">
-            <a:spAutoFit/>
+            <a:normAutofit/>
           </a:bodyPr>
           <a:lstStyle/>
           <a:p>
@@ -16532,7 +16532,7 @@
         </p:spPr>
         <p:txBody>
           <a:bodyPr wrap="square">
-            <a:spAutoFit/>
+            <a:normAutofit/>
           </a:bodyPr>
           <a:lstStyle/>
           <a:p>
@@ -16567,7 +16567,7 @@
         </p:spPr>
         <p:txBody>
           <a:bodyPr wrap="square">
-            <a:spAutoFit/>
+            <a:normAutofit/>
           </a:bodyPr>
           <a:lstStyle/>
           <a:p>
@@ -16645,7 +16645,7 @@
         </p:spPr>
         <p:txBody>
           <a:bodyPr wrap="square">
-            <a:spAutoFit/>
+            <a:normAutofit/>
           </a:bodyPr>
           <a:lstStyle/>
           <a:p>
@@ -16766,7 +16766,7 @@
         </p:spPr>
         <p:txBody>
           <a:bodyPr wrap="square">
-            <a:spAutoFit/>
+            <a:normAutofit/>
           </a:bodyPr>
           <a:lstStyle/>
           <a:p>
@@ -16801,7 +16801,7 @@
         </p:spPr>
         <p:txBody>
           <a:bodyPr wrap="square">
-            <a:spAutoFit/>
+            <a:normAutofit/>
           </a:bodyPr>
           <a:lstStyle/>
           <a:p>
@@ -16836,7 +16836,7 @@
         </p:spPr>
         <p:txBody>
           <a:bodyPr wrap="square">
-            <a:spAutoFit/>
+            <a:normAutofit/>
           </a:bodyPr>
           <a:lstStyle/>
           <a:p>
@@ -16871,7 +16871,7 @@
         </p:spPr>
         <p:txBody>
           <a:bodyPr wrap="square">
-            <a:spAutoFit/>
+            <a:normAutofit/>
           </a:bodyPr>
           <a:lstStyle/>
           <a:p>
@@ -16949,7 +16949,7 @@
         </p:spPr>
         <p:txBody>
           <a:bodyPr wrap="square">
-            <a:spAutoFit/>
+            <a:normAutofit/>
           </a:bodyPr>
           <a:lstStyle/>
           <a:p>
@@ -17027,7 +17027,7 @@
         </p:spPr>
         <p:txBody>
           <a:bodyPr wrap="square">
-            <a:spAutoFit/>
+            <a:normAutofit/>
           </a:bodyPr>
           <a:lstStyle/>
           <a:p>
@@ -17105,7 +17105,7 @@
         </p:spPr>
         <p:txBody>
           <a:bodyPr wrap="square">
-            <a:spAutoFit/>
+            <a:normAutofit/>
           </a:bodyPr>
           <a:lstStyle/>
           <a:p>
@@ -17226,7 +17226,7 @@
         </p:spPr>
         <p:txBody>
           <a:bodyPr wrap="square">
-            <a:spAutoFit/>
+            <a:normAutofit/>
           </a:bodyPr>
           <a:lstStyle/>
           <a:p>
@@ -17261,7 +17261,7 @@
         </p:spPr>
         <p:txBody>
           <a:bodyPr wrap="square">
-            <a:spAutoFit/>
+            <a:normAutofit/>
           </a:bodyPr>
           <a:lstStyle/>
           <a:p>
@@ -17382,7 +17382,7 @@
         </p:spPr>
         <p:txBody>
           <a:bodyPr wrap="square">
-            <a:spAutoFit/>
+            <a:normAutofit/>
           </a:bodyPr>
           <a:lstStyle/>
           <a:p>
@@ -17417,7 +17417,7 @@
         </p:spPr>
         <p:txBody>
           <a:bodyPr wrap="square">
-            <a:spAutoFit/>
+            <a:normAutofit/>
           </a:bodyPr>
           <a:lstStyle/>
           <a:p>
@@ -17538,7 +17538,7 @@
         </p:spPr>
         <p:txBody>
           <a:bodyPr wrap="square">
-            <a:spAutoFit/>
+            <a:normAutofit/>
           </a:bodyPr>
           <a:lstStyle/>
           <a:p>
@@ -17573,7 +17573,7 @@
         </p:spPr>
         <p:txBody>
           <a:bodyPr wrap="square">
-            <a:spAutoFit/>
+            <a:normAutofit/>
           </a:bodyPr>
           <a:lstStyle/>
           <a:p>
@@ -17694,7 +17694,7 @@
         </p:spPr>
         <p:txBody>
           <a:bodyPr wrap="square">
-            <a:spAutoFit/>
+            <a:normAutofit/>
           </a:bodyPr>
           <a:lstStyle/>
           <a:p>
@@ -17729,7 +17729,7 @@
         </p:spPr>
         <p:txBody>
           <a:bodyPr wrap="square">
-            <a:spAutoFit/>
+            <a:normAutofit/>
           </a:bodyPr>
           <a:lstStyle/>
           <a:p>
@@ -17850,7 +17850,7 @@
         </p:spPr>
         <p:txBody>
           <a:bodyPr wrap="square">
-            <a:spAutoFit/>
+            <a:normAutofit/>
           </a:bodyPr>
           <a:lstStyle/>
           <a:p>
@@ -17885,7 +17885,7 @@
         </p:spPr>
         <p:txBody>
           <a:bodyPr wrap="square">
-            <a:spAutoFit/>
+            <a:normAutofit/>
           </a:bodyPr>
           <a:lstStyle/>
           <a:p>
@@ -18006,7 +18006,7 @@
         </p:spPr>
         <p:txBody>
           <a:bodyPr wrap="square">
-            <a:spAutoFit/>
+            <a:normAutofit/>
           </a:bodyPr>
           <a:lstStyle/>
           <a:p>
@@ -18041,7 +18041,7 @@
         </p:spPr>
         <p:txBody>
           <a:bodyPr wrap="square">
-            <a:spAutoFit/>
+            <a:normAutofit/>
           </a:bodyPr>
           <a:lstStyle/>
           <a:p>
@@ -18162,7 +18162,7 @@
         </p:spPr>
         <p:txBody>
           <a:bodyPr wrap="square">
-            <a:spAutoFit/>
+            <a:normAutofit/>
           </a:bodyPr>
           <a:lstStyle/>
           <a:p>
@@ -18240,7 +18240,7 @@
         </p:spPr>
         <p:txBody>
           <a:bodyPr wrap="square">
-            <a:spAutoFit/>
+            <a:normAutofit/>
           </a:bodyPr>
           <a:lstStyle/>
           <a:p>
@@ -18318,7 +18318,7 @@
         </p:spPr>
         <p:txBody>
           <a:bodyPr wrap="square">
-            <a:spAutoFit/>
+            <a:normAutofit/>
           </a:bodyPr>
           <a:lstStyle/>
           <a:p>
@@ -18353,7 +18353,7 @@
         </p:spPr>
         <p:txBody>
           <a:bodyPr wrap="square">
-            <a:spAutoFit/>
+            <a:normAutofit/>
           </a:bodyPr>
           <a:lstStyle/>
           <a:p>
@@ -18500,7 +18500,7 @@
         </p:spPr>
         <p:txBody>
           <a:bodyPr wrap="square">
-            <a:spAutoFit/>
+            <a:normAutofit/>
           </a:bodyPr>
           <a:lstStyle/>
           <a:p>
@@ -18535,7 +18535,7 @@
         </p:spPr>
         <p:txBody>
           <a:bodyPr wrap="square">
-            <a:spAutoFit/>
+            <a:normAutofit/>
           </a:bodyPr>
           <a:lstStyle/>
           <a:p>
@@ -18656,7 +18656,7 @@
         </p:spPr>
         <p:txBody>
           <a:bodyPr wrap="square">
-            <a:spAutoFit/>
+            <a:normAutofit/>
           </a:bodyPr>
           <a:lstStyle/>
           <a:p>
@@ -18777,7 +18777,7 @@
         </p:spPr>
         <p:txBody>
           <a:bodyPr wrap="square">
-            <a:spAutoFit/>
+            <a:normAutofit/>
           </a:bodyPr>
           <a:lstStyle/>
           <a:p>
@@ -18812,7 +18812,7 @@
         </p:spPr>
         <p:txBody>
           <a:bodyPr wrap="square">
-            <a:spAutoFit/>
+            <a:normAutofit/>
           </a:bodyPr>
           <a:lstStyle/>
           <a:p>
@@ -18890,7 +18890,7 @@
         </p:spPr>
         <p:txBody>
           <a:bodyPr wrap="square">
-            <a:spAutoFit/>
+            <a:normAutofit/>
           </a:bodyPr>
           <a:lstStyle/>
           <a:p>
@@ -18925,7 +18925,7 @@
         </p:spPr>
         <p:txBody>
           <a:bodyPr wrap="square">
-            <a:spAutoFit/>
+            <a:normAutofit/>
           </a:bodyPr>
           <a:lstStyle/>
           <a:p>
@@ -18960,7 +18960,7 @@
         </p:spPr>
         <p:txBody>
           <a:bodyPr wrap="square">
-            <a:spAutoFit/>
+            <a:normAutofit/>
           </a:bodyPr>
           <a:lstStyle/>
           <a:p>
@@ -19038,7 +19038,7 @@
         </p:spPr>
         <p:txBody>
           <a:bodyPr wrap="square">
-            <a:spAutoFit/>
+            <a:normAutofit/>
           </a:bodyPr>
           <a:lstStyle/>
           <a:p>
@@ -19159,7 +19159,7 @@
         </p:spPr>
         <p:txBody>
           <a:bodyPr wrap="square">
-            <a:spAutoFit/>
+            <a:normAutofit/>
           </a:bodyPr>
           <a:lstStyle/>
           <a:p>
@@ -19194,7 +19194,7 @@
         </p:spPr>
         <p:txBody>
           <a:bodyPr wrap="square">
-            <a:spAutoFit/>
+            <a:normAutofit/>
           </a:bodyPr>
           <a:lstStyle/>
           <a:p>
@@ -19272,7 +19272,7 @@
         </p:spPr>
         <p:txBody>
           <a:bodyPr wrap="square">
-            <a:spAutoFit/>
+            <a:normAutofit/>
           </a:bodyPr>
           <a:lstStyle/>
           <a:p>
@@ -19307,7 +19307,7 @@
         </p:spPr>
         <p:txBody>
           <a:bodyPr wrap="square">
-            <a:spAutoFit/>
+            <a:normAutofit/>
           </a:bodyPr>
           <a:lstStyle/>
           <a:p>
@@ -19342,7 +19342,7 @@
         </p:spPr>
         <p:txBody>
           <a:bodyPr wrap="square">
-            <a:spAutoFit/>
+            <a:normAutofit/>
           </a:bodyPr>
           <a:lstStyle/>
           <a:p>
@@ -19420,7 +19420,7 @@
         </p:spPr>
         <p:txBody>
           <a:bodyPr wrap="square">
-            <a:spAutoFit/>
+            <a:normAutofit/>
           </a:bodyPr>
           <a:lstStyle/>
           <a:p>
@@ -19541,7 +19541,7 @@
         </p:spPr>
         <p:txBody>
           <a:bodyPr wrap="square">
-            <a:spAutoFit/>
+            <a:normAutofit/>
           </a:bodyPr>
           <a:lstStyle/>
           <a:p>
@@ -19576,7 +19576,7 @@
         </p:spPr>
         <p:txBody>
           <a:bodyPr wrap="square">
-            <a:spAutoFit/>
+            <a:normAutofit/>
           </a:bodyPr>
           <a:lstStyle/>
           <a:p>
@@ -19654,7 +19654,7 @@
         </p:spPr>
         <p:txBody>
           <a:bodyPr wrap="square">
-            <a:spAutoFit/>
+            <a:normAutofit/>
           </a:bodyPr>
           <a:lstStyle/>
           <a:p>
@@ -19689,7 +19689,7 @@
         </p:spPr>
         <p:txBody>
           <a:bodyPr wrap="square">
-            <a:spAutoFit/>
+            <a:normAutofit/>
           </a:bodyPr>
           <a:lstStyle/>
           <a:p>
@@ -19724,7 +19724,7 @@
         </p:spPr>
         <p:txBody>
           <a:bodyPr wrap="square">
-            <a:spAutoFit/>
+            <a:normAutofit/>
           </a:bodyPr>
           <a:lstStyle/>
           <a:p>
@@ -19802,7 +19802,7 @@
         </p:spPr>
         <p:txBody>
           <a:bodyPr wrap="square">
-            <a:spAutoFit/>
+            <a:normAutofit/>
           </a:bodyPr>
           <a:lstStyle/>
           <a:p>
@@ -19880,7 +19880,7 @@
         </p:spPr>
         <p:txBody>
           <a:bodyPr wrap="square">
-            <a:spAutoFit/>
+            <a:normAutofit/>
           </a:bodyPr>
           <a:lstStyle/>
           <a:p>
@@ -19958,7 +19958,7 @@
         </p:spPr>
         <p:txBody>
           <a:bodyPr wrap="square">
-            <a:spAutoFit/>
+            <a:normAutofit/>
           </a:bodyPr>
           <a:lstStyle/>
           <a:p>
@@ -20036,7 +20036,7 @@
         </p:spPr>
         <p:txBody>
           <a:bodyPr wrap="square">
-            <a:spAutoFit/>
+            <a:normAutofit/>
           </a:bodyPr>
           <a:lstStyle/>
           <a:p>
@@ -20071,7 +20071,7 @@
         </p:spPr>
         <p:txBody>
           <a:bodyPr wrap="square">
-            <a:spAutoFit/>
+            <a:normAutofit/>
           </a:bodyPr>
           <a:lstStyle/>
           <a:p>
@@ -20149,7 +20149,7 @@
         </p:spPr>
         <p:txBody>
           <a:bodyPr wrap="square">
-            <a:spAutoFit/>
+            <a:normAutofit/>
           </a:bodyPr>
           <a:lstStyle/>
           <a:p>
@@ -20184,7 +20184,7 @@
         </p:spPr>
         <p:txBody>
           <a:bodyPr wrap="square">
-            <a:spAutoFit/>
+            <a:normAutofit/>
           </a:bodyPr>
           <a:lstStyle/>
           <a:p>
@@ -20262,7 +20262,7 @@
         </p:spPr>
         <p:txBody>
           <a:bodyPr wrap="square">
-            <a:spAutoFit/>
+            <a:normAutofit/>
           </a:bodyPr>
           <a:lstStyle/>
           <a:p>
@@ -20297,7 +20297,7 @@
         </p:spPr>
         <p:txBody>
           <a:bodyPr wrap="square">
-            <a:spAutoFit/>
+            <a:normAutofit/>
           </a:bodyPr>
           <a:lstStyle/>
           <a:p>
@@ -20375,7 +20375,7 @@
         </p:spPr>
         <p:txBody>
           <a:bodyPr wrap="square">
-            <a:spAutoFit/>
+            <a:normAutofit/>
           </a:bodyPr>
           <a:lstStyle/>
           <a:p>
@@ -20496,7 +20496,7 @@
         </p:spPr>
         <p:txBody>
           <a:bodyPr wrap="square">
-            <a:spAutoFit/>
+            <a:normAutofit/>
           </a:bodyPr>
           <a:lstStyle/>
           <a:p>
@@ -20531,7 +20531,7 @@
         </p:spPr>
         <p:txBody>
           <a:bodyPr wrap="square">
-            <a:spAutoFit/>
+            <a:normAutofit/>
           </a:bodyPr>
           <a:lstStyle/>
           <a:p>
@@ -20652,7 +20652,7 @@
         </p:spPr>
         <p:txBody>
           <a:bodyPr wrap="square">
-            <a:spAutoFit/>
+            <a:normAutofit/>
           </a:bodyPr>
           <a:lstStyle/>
           <a:p>
@@ -20687,7 +20687,7 @@
         </p:spPr>
         <p:txBody>
           <a:bodyPr wrap="square">
-            <a:spAutoFit/>
+            <a:normAutofit/>
           </a:bodyPr>
           <a:lstStyle/>
           <a:p>
@@ -20808,7 +20808,7 @@
         </p:spPr>
         <p:txBody>
           <a:bodyPr wrap="square">
-            <a:spAutoFit/>
+            <a:normAutofit/>
           </a:bodyPr>
           <a:lstStyle/>
           <a:p>
@@ -20843,7 +20843,7 @@
         </p:spPr>
         <p:txBody>
           <a:bodyPr wrap="square">
-            <a:spAutoFit/>
+            <a:normAutofit/>
           </a:bodyPr>
           <a:lstStyle/>
           <a:p>
@@ -20964,7 +20964,7 @@
         </p:spPr>
         <p:txBody>
           <a:bodyPr wrap="square">
-            <a:spAutoFit/>
+            <a:normAutofit/>
           </a:bodyPr>
           <a:lstStyle/>
           <a:p>
@@ -20999,7 +20999,7 @@
         </p:spPr>
         <p:txBody>
           <a:bodyPr wrap="square">
-            <a:spAutoFit/>
+            <a:normAutofit/>
           </a:bodyPr>
           <a:lstStyle/>
           <a:p>
@@ -21120,7 +21120,7 @@
         </p:spPr>
         <p:txBody>
           <a:bodyPr wrap="square">
-            <a:spAutoFit/>
+            <a:normAutofit/>
           </a:bodyPr>
           <a:lstStyle/>
           <a:p>
@@ -21155,7 +21155,7 @@
         </p:spPr>
         <p:txBody>
           <a:bodyPr wrap="square">
-            <a:spAutoFit/>
+            <a:normAutofit/>
           </a:bodyPr>
           <a:lstStyle/>
           <a:p>
@@ -21276,7 +21276,7 @@
         </p:spPr>
         <p:txBody>
           <a:bodyPr wrap="square">
-            <a:spAutoFit/>
+            <a:normAutofit/>
           </a:bodyPr>
           <a:lstStyle/>
           <a:p>
@@ -21354,7 +21354,7 @@
         </p:spPr>
         <p:txBody>
           <a:bodyPr wrap="square">
-            <a:spAutoFit/>
+            <a:normAutofit/>
           </a:bodyPr>
           <a:lstStyle/>
           <a:p>
@@ -21389,7 +21389,7 @@
         </p:spPr>
         <p:txBody>
           <a:bodyPr wrap="square">
-            <a:spAutoFit/>
+            <a:normAutofit/>
           </a:bodyPr>
           <a:lstStyle/>
           <a:p>
@@ -21536,7 +21536,7 @@
         </p:spPr>
         <p:txBody>
           <a:bodyPr wrap="square">
-            <a:spAutoFit/>
+            <a:normAutofit/>
           </a:bodyPr>
           <a:lstStyle/>
           <a:p>
@@ -21571,7 +21571,7 @@
         </p:spPr>
         <p:txBody>
           <a:bodyPr wrap="square">
-            <a:spAutoFit/>
+            <a:normAutofit/>
           </a:bodyPr>
           <a:lstStyle/>
           <a:p>
@@ -21735,7 +21735,7 @@
         </p:spPr>
         <p:txBody>
           <a:bodyPr wrap="square">
-            <a:spAutoFit/>
+            <a:normAutofit/>
           </a:bodyPr>
           <a:lstStyle/>
           <a:p>
@@ -21813,7 +21813,7 @@
         </p:spPr>
         <p:txBody>
           <a:bodyPr wrap="square">
-            <a:spAutoFit/>
+            <a:normAutofit/>
           </a:bodyPr>
           <a:lstStyle/>
           <a:p>
@@ -21848,7 +21848,7 @@
         </p:spPr>
         <p:txBody>
           <a:bodyPr wrap="square">
-            <a:spAutoFit/>
+            <a:normAutofit/>
           </a:bodyPr>
           <a:lstStyle/>
           <a:p>
@@ -21883,7 +21883,7 @@
         </p:spPr>
         <p:txBody>
           <a:bodyPr wrap="square">
-            <a:spAutoFit/>
+            <a:normAutofit/>
           </a:bodyPr>
           <a:lstStyle/>
           <a:p>
@@ -21918,7 +21918,7 @@
         </p:spPr>
         <p:txBody>
           <a:bodyPr wrap="square">
-            <a:spAutoFit/>
+            <a:normAutofit/>
           </a:bodyPr>
           <a:lstStyle/>
           <a:p>
@@ -21953,7 +21953,7 @@
         </p:spPr>
         <p:txBody>
           <a:bodyPr wrap="square">
-            <a:spAutoFit/>
+            <a:normAutofit/>
           </a:bodyPr>
           <a:lstStyle/>
           <a:p>
@@ -22031,7 +22031,7 @@
         </p:spPr>
         <p:txBody>
           <a:bodyPr wrap="square">
-            <a:spAutoFit/>
+            <a:normAutofit/>
           </a:bodyPr>
           <a:lstStyle/>
           <a:p>
@@ -22153,7 +22153,7 @@
         </p:spPr>
         <p:txBody>
           <a:bodyPr wrap="square">
-            <a:spAutoFit/>
+            <a:normAutofit/>
           </a:bodyPr>
           <a:lstStyle/>
           <a:p>
@@ -22231,7 +22231,7 @@
         </p:spPr>
         <p:txBody>
           <a:bodyPr wrap="square">
-            <a:spAutoFit/>
+            <a:normAutofit/>
           </a:bodyPr>
           <a:lstStyle/>
           <a:p>
@@ -22266,7 +22266,7 @@
         </p:spPr>
         <p:txBody>
           <a:bodyPr wrap="square">
-            <a:spAutoFit/>
+            <a:normAutofit/>
           </a:bodyPr>
           <a:lstStyle/>
           <a:p>
@@ -22301,7 +22301,7 @@
         </p:spPr>
         <p:txBody>
           <a:bodyPr wrap="square">
-            <a:spAutoFit/>
+            <a:normAutofit/>
           </a:bodyPr>
           <a:lstStyle/>
           <a:p>
@@ -22336,7 +22336,7 @@
         </p:spPr>
         <p:txBody>
           <a:bodyPr wrap="square">
-            <a:spAutoFit/>
+            <a:normAutofit/>
           </a:bodyPr>
           <a:lstStyle/>
           <a:p>
@@ -22371,7 +22371,7 @@
         </p:spPr>
         <p:txBody>
           <a:bodyPr wrap="square">
-            <a:spAutoFit/>
+            <a:normAutofit/>
           </a:bodyPr>
           <a:lstStyle/>
           <a:p>
@@ -22449,7 +22449,7 @@
         </p:spPr>
         <p:txBody>
           <a:bodyPr wrap="square">
-            <a:spAutoFit/>
+            <a:normAutofit/>
           </a:bodyPr>
           <a:lstStyle/>
           <a:p>
@@ -22571,7 +22571,7 @@
         </p:spPr>
         <p:txBody>
           <a:bodyPr wrap="square">
-            <a:spAutoFit/>
+            <a:normAutofit/>
           </a:bodyPr>
           <a:lstStyle/>
           <a:p>
@@ -22649,7 +22649,7 @@
         </p:spPr>
         <p:txBody>
           <a:bodyPr wrap="square">
-            <a:spAutoFit/>
+            <a:normAutofit/>
           </a:bodyPr>
           <a:lstStyle/>
           <a:p>
@@ -22684,7 +22684,7 @@
         </p:spPr>
         <p:txBody>
           <a:bodyPr wrap="square">
-            <a:spAutoFit/>
+            <a:normAutofit/>
           </a:bodyPr>
           <a:lstStyle/>
           <a:p>
@@ -22719,7 +22719,7 @@
         </p:spPr>
         <p:txBody>
           <a:bodyPr wrap="square">
-            <a:spAutoFit/>
+            <a:normAutofit/>
           </a:bodyPr>
           <a:lstStyle/>
           <a:p>
@@ -22754,7 +22754,7 @@
         </p:spPr>
         <p:txBody>
           <a:bodyPr wrap="square">
-            <a:spAutoFit/>
+            <a:normAutofit/>
           </a:bodyPr>
           <a:lstStyle/>
           <a:p>
@@ -22789,7 +22789,7 @@
         </p:spPr>
         <p:txBody>
           <a:bodyPr wrap="square">
-            <a:spAutoFit/>
+            <a:normAutofit/>
           </a:bodyPr>
           <a:lstStyle/>
           <a:p>
@@ -22867,7 +22867,7 @@
         </p:spPr>
         <p:txBody>
           <a:bodyPr wrap="square">
-            <a:spAutoFit/>
+            <a:normAutofit/>
           </a:bodyPr>
           <a:lstStyle/>
           <a:p>
@@ -22989,7 +22989,7 @@
         </p:spPr>
         <p:txBody>
           <a:bodyPr wrap="square">
-            <a:spAutoFit/>
+            <a:normAutofit/>
           </a:bodyPr>
           <a:lstStyle/>
           <a:p>
@@ -23067,7 +23067,7 @@
         </p:spPr>
         <p:txBody>
           <a:bodyPr wrap="square">
-            <a:spAutoFit/>
+            <a:normAutofit/>
           </a:bodyPr>
           <a:lstStyle/>
           <a:p>
@@ -23188,7 +23188,7 @@
         </p:spPr>
         <p:txBody>
           <a:bodyPr wrap="square">
-            <a:spAutoFit/>
+            <a:normAutofit/>
           </a:bodyPr>
           <a:lstStyle/>
           <a:p>
@@ -23266,7 +23266,7 @@
         </p:spPr>
         <p:txBody>
           <a:bodyPr wrap="square">
-            <a:spAutoFit/>
+            <a:normAutofit/>
           </a:bodyPr>
           <a:lstStyle/>
           <a:p>
@@ -23301,7 +23301,7 @@
         </p:spPr>
         <p:txBody>
           <a:bodyPr wrap="square">
-            <a:spAutoFit/>
+            <a:normAutofit/>
           </a:bodyPr>
           <a:lstStyle/>
           <a:p>
@@ -23448,7 +23448,7 @@
         </p:spPr>
         <p:txBody>
           <a:bodyPr wrap="square">
-            <a:spAutoFit/>
+            <a:normAutofit/>
           </a:bodyPr>
           <a:lstStyle/>
           <a:p>
@@ -23483,7 +23483,7 @@
         </p:spPr>
         <p:txBody>
           <a:bodyPr wrap="square">
-            <a:spAutoFit/>
+            <a:normAutofit/>
           </a:bodyPr>
           <a:lstStyle/>
           <a:p>
@@ -23604,7 +23604,7 @@
         </p:spPr>
         <p:txBody>
           <a:bodyPr wrap="square">
-            <a:spAutoFit/>
+            <a:normAutofit/>
           </a:bodyPr>
           <a:lstStyle/>
           <a:p>
@@ -23682,7 +23682,7 @@
         </p:spPr>
         <p:txBody>
           <a:bodyPr wrap="square">
-            <a:spAutoFit/>
+            <a:normAutofit/>
           </a:bodyPr>
           <a:lstStyle/>
           <a:p>
@@ -23760,7 +23760,7 @@
         </p:spPr>
         <p:txBody>
           <a:bodyPr wrap="square">
-            <a:spAutoFit/>
+            <a:normAutofit/>
           </a:bodyPr>
           <a:lstStyle/>
           <a:p>
@@ -23838,7 +23838,7 @@
         </p:spPr>
         <p:txBody>
           <a:bodyPr wrap="square">
-            <a:spAutoFit/>
+            <a:normAutofit/>
           </a:bodyPr>
           <a:lstStyle/>
           <a:p>
@@ -23916,7 +23916,7 @@
         </p:spPr>
         <p:txBody>
           <a:bodyPr wrap="square">
-            <a:spAutoFit/>
+            <a:normAutofit/>
           </a:bodyPr>
           <a:lstStyle/>
           <a:p>
@@ -23994,7 +23994,7 @@
         </p:spPr>
         <p:txBody>
           <a:bodyPr wrap="square">
-            <a:spAutoFit/>
+            <a:normAutofit/>
           </a:bodyPr>
           <a:lstStyle/>
           <a:p>
@@ -24072,7 +24072,7 @@
         </p:spPr>
         <p:txBody>
           <a:bodyPr wrap="square">
-            <a:spAutoFit/>
+            <a:normAutofit/>
           </a:bodyPr>
           <a:lstStyle/>
           <a:p>
@@ -24150,7 +24150,7 @@
         </p:spPr>
         <p:txBody>
           <a:bodyPr wrap="square">
-            <a:spAutoFit/>
+            <a:normAutofit/>
           </a:bodyPr>
           <a:lstStyle/>
           <a:p>
@@ -24229,7 +24229,7 @@
         </p:spPr>
         <p:txBody>
           <a:bodyPr wrap="square">
-            <a:spAutoFit/>
+            <a:normAutofit/>
           </a:bodyPr>
           <a:lstStyle/>
           <a:p>
@@ -24308,7 +24308,7 @@
         </p:spPr>
         <p:txBody>
           <a:bodyPr wrap="square">
-            <a:spAutoFit/>
+            <a:normAutofit/>
           </a:bodyPr>
           <a:lstStyle/>
           <a:p>
@@ -24386,7 +24386,7 @@
         </p:spPr>
         <p:txBody>
           <a:bodyPr wrap="square">
-            <a:spAutoFit/>
+            <a:normAutofit/>
           </a:bodyPr>
           <a:lstStyle/>
           <a:p>
@@ -24464,7 +24464,7 @@
         </p:spPr>
         <p:txBody>
           <a:bodyPr wrap="square">
-            <a:spAutoFit/>
+            <a:normAutofit/>
           </a:bodyPr>
           <a:lstStyle/>
           <a:p>
@@ -24542,7 +24542,7 @@
         </p:spPr>
         <p:txBody>
           <a:bodyPr wrap="square">
-            <a:spAutoFit/>
+            <a:normAutofit/>
           </a:bodyPr>
           <a:lstStyle/>
           <a:p>
@@ -24620,7 +24620,7 @@
         </p:spPr>
         <p:txBody>
           <a:bodyPr wrap="square">
-            <a:spAutoFit/>
+            <a:normAutofit/>
           </a:bodyPr>
           <a:lstStyle/>
           <a:p>
@@ -24698,7 +24698,7 @@
         </p:spPr>
         <p:txBody>
           <a:bodyPr wrap="square">
-            <a:spAutoFit/>
+            <a:normAutofit/>
           </a:bodyPr>
           <a:lstStyle/>
           <a:p>
@@ -24777,7 +24777,7 @@
         </p:spPr>
         <p:txBody>
           <a:bodyPr wrap="square">
-            <a:spAutoFit/>
+            <a:normAutofit/>
           </a:bodyPr>
           <a:lstStyle/>
           <a:p>
@@ -24856,7 +24856,7 @@
         </p:spPr>
         <p:txBody>
           <a:bodyPr wrap="square">
-            <a:spAutoFit/>
+            <a:normAutofit/>
           </a:bodyPr>
           <a:lstStyle/>
           <a:p>
@@ -24935,7 +24935,7 @@
         </p:spPr>
         <p:txBody>
           <a:bodyPr wrap="square">
-            <a:spAutoFit/>
+            <a:normAutofit/>
           </a:bodyPr>
           <a:lstStyle/>
           <a:p>
@@ -25013,7 +25013,7 @@
         </p:spPr>
         <p:txBody>
           <a:bodyPr wrap="square">
-            <a:spAutoFit/>
+            <a:normAutofit/>
           </a:bodyPr>
           <a:lstStyle/>
           <a:p>
@@ -25091,7 +25091,7 @@
         </p:spPr>
         <p:txBody>
           <a:bodyPr wrap="square">
-            <a:spAutoFit/>
+            <a:normAutofit/>
           </a:bodyPr>
           <a:lstStyle/>
           <a:p>
@@ -25169,7 +25169,7 @@
         </p:spPr>
         <p:txBody>
           <a:bodyPr wrap="square">
-            <a:spAutoFit/>
+            <a:normAutofit/>
           </a:bodyPr>
           <a:lstStyle/>
           <a:p>
@@ -25247,7 +25247,7 @@
         </p:spPr>
         <p:txBody>
           <a:bodyPr wrap="square">
-            <a:spAutoFit/>
+            <a:normAutofit/>
           </a:bodyPr>
           <a:lstStyle/>
           <a:p>
@@ -25326,7 +25326,7 @@
         </p:spPr>
         <p:txBody>
           <a:bodyPr wrap="square">
-            <a:spAutoFit/>
+            <a:normAutofit/>
           </a:bodyPr>
           <a:lstStyle/>
           <a:p>
@@ -25405,7 +25405,7 @@
         </p:spPr>
         <p:txBody>
           <a:bodyPr wrap="square">
-            <a:spAutoFit/>
+            <a:normAutofit/>
           </a:bodyPr>
           <a:lstStyle/>
           <a:p>
@@ -25484,7 +25484,7 @@
         </p:spPr>
         <p:txBody>
           <a:bodyPr wrap="square">
-            <a:spAutoFit/>
+            <a:normAutofit/>
           </a:bodyPr>
           <a:lstStyle/>
           <a:p>
@@ -25563,7 +25563,7 @@
         </p:spPr>
         <p:txBody>
           <a:bodyPr wrap="square">
-            <a:spAutoFit/>
+            <a:normAutofit/>
           </a:bodyPr>
           <a:lstStyle/>
           <a:p>
@@ -25641,7 +25641,7 @@
         </p:spPr>
         <p:txBody>
           <a:bodyPr wrap="square">
-            <a:spAutoFit/>
+            <a:normAutofit/>
           </a:bodyPr>
           <a:lstStyle/>
           <a:p>
@@ -25719,7 +25719,7 @@
         </p:spPr>
         <p:txBody>
           <a:bodyPr wrap="square">
-            <a:spAutoFit/>
+            <a:normAutofit/>
           </a:bodyPr>
           <a:lstStyle/>
           <a:p>
@@ -25797,7 +25797,7 @@
         </p:spPr>
         <p:txBody>
           <a:bodyPr wrap="square">
-            <a:spAutoFit/>
+            <a:normAutofit/>
           </a:bodyPr>
           <a:lstStyle/>
           <a:p>
@@ -25832,7 +25832,7 @@
         </p:spPr>
         <p:txBody>
           <a:bodyPr wrap="square">
-            <a:spAutoFit/>
+            <a:normAutofit/>
           </a:bodyPr>
           <a:lstStyle/>
           <a:p>
@@ -25867,7 +25867,7 @@
         </p:spPr>
         <p:txBody>
           <a:bodyPr wrap="square">
-            <a:spAutoFit/>
+            <a:normAutofit/>
           </a:bodyPr>
           <a:lstStyle/>
           <a:p>
@@ -25902,7 +25902,7 @@
         </p:spPr>
         <p:txBody>
           <a:bodyPr wrap="square">
-            <a:spAutoFit/>
+            <a:normAutofit/>
           </a:bodyPr>
           <a:lstStyle/>
           <a:p>
@@ -25937,7 +25937,7 @@
         </p:spPr>
         <p:txBody>
           <a:bodyPr wrap="square">
-            <a:spAutoFit/>
+            <a:normAutofit/>
           </a:bodyPr>
           <a:lstStyle/>
           <a:p>
@@ -25972,7 +25972,7 @@
         </p:spPr>
         <p:txBody>
           <a:bodyPr wrap="square">
-            <a:spAutoFit/>
+            <a:normAutofit/>
           </a:bodyPr>
           <a:lstStyle/>
           <a:p>
@@ -26007,7 +26007,7 @@
         </p:spPr>
         <p:txBody>
           <a:bodyPr wrap="square">
-            <a:spAutoFit/>
+            <a:normAutofit/>
           </a:bodyPr>
           <a:lstStyle/>
           <a:p>
@@ -26128,7 +26128,7 @@
         </p:spPr>
         <p:txBody>
           <a:bodyPr wrap="square">
-            <a:spAutoFit/>
+            <a:normAutofit/>
           </a:bodyPr>
           <a:lstStyle/>
           <a:p>
@@ -26206,7 +26206,7 @@
         </p:spPr>
         <p:txBody>
           <a:bodyPr wrap="square">
-            <a:spAutoFit/>
+            <a:normAutofit/>
           </a:bodyPr>
           <a:lstStyle/>
           <a:p>
@@ -26241,7 +26241,7 @@
         </p:spPr>
         <p:txBody>
           <a:bodyPr wrap="square">
-            <a:spAutoFit/>
+            <a:normAutofit/>
           </a:bodyPr>
           <a:lstStyle/>
           <a:p>
@@ -26319,7 +26319,7 @@
         </p:spPr>
         <p:txBody>
           <a:bodyPr wrap="square">
-            <a:spAutoFit/>
+            <a:normAutofit/>
           </a:bodyPr>
           <a:lstStyle/>
           <a:p>
@@ -26354,7 +26354,7 @@
         </p:spPr>
         <p:txBody>
           <a:bodyPr wrap="square">
-            <a:spAutoFit/>
+            <a:normAutofit/>
           </a:bodyPr>
           <a:lstStyle/>
           <a:p>
@@ -26432,7 +26432,7 @@
         </p:spPr>
         <p:txBody>
           <a:bodyPr wrap="square">
-            <a:spAutoFit/>
+            <a:normAutofit/>
           </a:bodyPr>
           <a:lstStyle/>
           <a:p>
@@ -26467,7 +26467,7 @@
         </p:spPr>
         <p:txBody>
           <a:bodyPr wrap="square">
-            <a:spAutoFit/>
+            <a:normAutofit/>
           </a:bodyPr>
           <a:lstStyle/>
           <a:p>
@@ -26545,7 +26545,7 @@
         </p:spPr>
         <p:txBody>
           <a:bodyPr wrap="square">
-            <a:spAutoFit/>
+            <a:normAutofit/>
           </a:bodyPr>
           <a:lstStyle/>
           <a:p>
@@ -26580,7 +26580,7 @@
         </p:spPr>
         <p:txBody>
           <a:bodyPr wrap="square">
-            <a:spAutoFit/>
+            <a:normAutofit/>
           </a:bodyPr>
           <a:lstStyle/>
           <a:p>
@@ -26658,7 +26658,7 @@
         </p:spPr>
         <p:txBody>
           <a:bodyPr wrap="square">
-            <a:spAutoFit/>
+            <a:normAutofit/>
           </a:bodyPr>
           <a:lstStyle/>
           <a:p>
@@ -26693,7 +26693,7 @@
         </p:spPr>
         <p:txBody>
           <a:bodyPr wrap="square">
-            <a:spAutoFit/>
+            <a:normAutofit/>
           </a:bodyPr>
           <a:lstStyle/>
           <a:p>
@@ -26840,7 +26840,7 @@
         </p:spPr>
         <p:txBody>
           <a:bodyPr wrap="square">
-            <a:spAutoFit/>
+            <a:normAutofit/>
           </a:bodyPr>
           <a:lstStyle/>
           <a:p>
@@ -26875,7 +26875,7 @@
         </p:spPr>
         <p:txBody>
           <a:bodyPr wrap="square">
-            <a:spAutoFit/>
+            <a:normAutofit/>
           </a:bodyPr>
           <a:lstStyle/>
           <a:p>
@@ -26996,7 +26996,7 @@
         </p:spPr>
         <p:txBody>
           <a:bodyPr wrap="square">
-            <a:spAutoFit/>
+            <a:normAutofit/>
           </a:bodyPr>
           <a:lstStyle/>
           <a:p>
@@ -27074,7 +27074,7 @@
         </p:spPr>
         <p:txBody>
           <a:bodyPr wrap="square">
-            <a:spAutoFit/>
+            <a:normAutofit/>
           </a:bodyPr>
           <a:lstStyle/>
           <a:p>
@@ -27109,7 +27109,7 @@
         </p:spPr>
         <p:txBody>
           <a:bodyPr wrap="square">
-            <a:spAutoFit/>
+            <a:normAutofit/>
           </a:bodyPr>
           <a:lstStyle/>
           <a:p>
@@ -27144,7 +27144,7 @@
         </p:spPr>
         <p:txBody>
           <a:bodyPr wrap="square">
-            <a:spAutoFit/>
+            <a:normAutofit/>
           </a:bodyPr>
           <a:lstStyle/>
           <a:p>
@@ -27222,7 +27222,7 @@
         </p:spPr>
         <p:txBody>
           <a:bodyPr wrap="square">
-            <a:spAutoFit/>
+            <a:normAutofit/>
           </a:bodyPr>
           <a:lstStyle/>
           <a:p>
@@ -27257,7 +27257,7 @@
         </p:spPr>
         <p:txBody>
           <a:bodyPr wrap="square">
-            <a:spAutoFit/>
+            <a:normAutofit/>
           </a:bodyPr>
           <a:lstStyle/>
           <a:p>
@@ -27292,7 +27292,7 @@
         </p:spPr>
         <p:txBody>
           <a:bodyPr wrap="square">
-            <a:spAutoFit/>
+            <a:normAutofit/>
           </a:bodyPr>
           <a:lstStyle/>
           <a:p>
@@ -27370,7 +27370,7 @@
         </p:spPr>
         <p:txBody>
           <a:bodyPr wrap="square">
-            <a:spAutoFit/>
+            <a:normAutofit/>
           </a:bodyPr>
           <a:lstStyle/>
           <a:p>
@@ -27405,7 +27405,7 @@
         </p:spPr>
         <p:txBody>
           <a:bodyPr wrap="square">
-            <a:spAutoFit/>
+            <a:normAutofit/>
           </a:bodyPr>
           <a:lstStyle/>
           <a:p>
@@ -27440,7 +27440,7 @@
         </p:spPr>
         <p:txBody>
           <a:bodyPr wrap="square">
-            <a:spAutoFit/>
+            <a:normAutofit/>
           </a:bodyPr>
           <a:lstStyle/>
           <a:p>
@@ -27518,7 +27518,7 @@
         </p:spPr>
         <p:txBody>
           <a:bodyPr wrap="square">
-            <a:spAutoFit/>
+            <a:normAutofit/>
           </a:bodyPr>
           <a:lstStyle/>
           <a:p>
@@ -27553,7 +27553,7 @@
         </p:spPr>
         <p:txBody>
           <a:bodyPr wrap="square">
-            <a:spAutoFit/>
+            <a:normAutofit/>
           </a:bodyPr>
           <a:lstStyle/>
           <a:p>
@@ -27588,7 +27588,7 @@
         </p:spPr>
         <p:txBody>
           <a:bodyPr wrap="square">
-            <a:spAutoFit/>
+            <a:normAutofit/>
           </a:bodyPr>
           <a:lstStyle/>
           <a:p>
@@ -27666,7 +27666,7 @@
         </p:spPr>
         <p:txBody>
           <a:bodyPr wrap="square">
-            <a:spAutoFit/>
+            <a:normAutofit/>
           </a:bodyPr>
           <a:lstStyle/>
           <a:p>
@@ -27701,7 +27701,7 @@
         </p:spPr>
         <p:txBody>
           <a:bodyPr wrap="square">
-            <a:spAutoFit/>
+            <a:normAutofit/>
           </a:bodyPr>
           <a:lstStyle/>
           <a:p>
@@ -27736,7 +27736,7 @@
         </p:spPr>
         <p:txBody>
           <a:bodyPr wrap="square">
-            <a:spAutoFit/>
+            <a:normAutofit/>
           </a:bodyPr>
           <a:lstStyle/>
           <a:p>
@@ -27814,7 +27814,7 @@
         </p:spPr>
         <p:txBody>
           <a:bodyPr wrap="square">
-            <a:spAutoFit/>
+            <a:normAutofit/>
           </a:bodyPr>
           <a:lstStyle/>
           <a:p>
@@ -27849,7 +27849,7 @@
         </p:spPr>
         <p:txBody>
           <a:bodyPr wrap="square">
-            <a:spAutoFit/>
+            <a:normAutofit/>
           </a:bodyPr>
           <a:lstStyle/>
           <a:p>
@@ -27884,7 +27884,7 @@
         </p:spPr>
         <p:txBody>
           <a:bodyPr wrap="square">
-            <a:spAutoFit/>
+            <a:normAutofit/>
           </a:bodyPr>
           <a:lstStyle/>
           <a:p>
@@ -27962,7 +27962,7 @@
         </p:spPr>
         <p:txBody>
           <a:bodyPr wrap="square">
-            <a:spAutoFit/>
+            <a:normAutofit/>
           </a:bodyPr>
           <a:lstStyle/>
           <a:p>
@@ -28040,7 +28040,7 @@
         </p:spPr>
         <p:txBody>
           <a:bodyPr wrap="square">
-            <a:spAutoFit/>
+            <a:normAutofit/>
           </a:bodyPr>
           <a:lstStyle/>
           <a:p>
@@ -28075,7 +28075,7 @@
         </p:spPr>
         <p:txBody>
           <a:bodyPr wrap="square">
-            <a:spAutoFit/>
+            <a:normAutofit/>
           </a:bodyPr>
           <a:lstStyle/>
           <a:p>
@@ -28110,7 +28110,7 @@
         </p:spPr>
         <p:txBody>
           <a:bodyPr wrap="square">
-            <a:spAutoFit/>
+            <a:normAutofit/>
           </a:bodyPr>
           <a:lstStyle/>
           <a:p>
@@ -28188,7 +28188,7 @@
         </p:spPr>
         <p:txBody>
           <a:bodyPr wrap="square">
-            <a:spAutoFit/>
+            <a:normAutofit/>
           </a:bodyPr>
           <a:lstStyle/>
           <a:p>
@@ -28223,7 +28223,7 @@
         </p:spPr>
         <p:txBody>
           <a:bodyPr wrap="square">
-            <a:spAutoFit/>
+            <a:normAutofit/>
           </a:bodyPr>
           <a:lstStyle/>
           <a:p>
@@ -28258,7 +28258,7 @@
         </p:spPr>
         <p:txBody>
           <a:bodyPr wrap="square">
-            <a:spAutoFit/>
+            <a:normAutofit/>
           </a:bodyPr>
           <a:lstStyle/>
           <a:p>
@@ -28336,7 +28336,7 @@
         </p:spPr>
         <p:txBody>
           <a:bodyPr wrap="square">
-            <a:spAutoFit/>
+            <a:normAutofit/>
           </a:bodyPr>
           <a:lstStyle/>
           <a:p>
@@ -28371,7 +28371,7 @@
         </p:spPr>
         <p:txBody>
           <a:bodyPr wrap="square">
-            <a:spAutoFit/>
+            <a:normAutofit/>
           </a:bodyPr>
           <a:lstStyle/>
           <a:p>
@@ -28406,7 +28406,7 @@
         </p:spPr>
         <p:txBody>
           <a:bodyPr wrap="square">
-            <a:spAutoFit/>
+            <a:normAutofit/>
           </a:bodyPr>
           <a:lstStyle/>
           <a:p>
@@ -28484,7 +28484,7 @@
         </p:spPr>
         <p:txBody>
           <a:bodyPr wrap="square">
-            <a:spAutoFit/>
+            <a:normAutofit/>
           </a:bodyPr>
           <a:lstStyle/>
           <a:p>
@@ -28519,7 +28519,7 @@
         </p:spPr>
         <p:txBody>
           <a:bodyPr wrap="square">
-            <a:spAutoFit/>
+            <a:normAutofit/>
           </a:bodyPr>
           <a:lstStyle/>
           <a:p>
@@ -28554,7 +28554,7 @@
         </p:spPr>
         <p:txBody>
           <a:bodyPr wrap="square">
-            <a:spAutoFit/>
+            <a:normAutofit/>
           </a:bodyPr>
           <a:lstStyle/>
           <a:p>
@@ -28632,7 +28632,7 @@
         </p:spPr>
         <p:txBody>
           <a:bodyPr wrap="square">
-            <a:spAutoFit/>
+            <a:normAutofit/>
           </a:bodyPr>
           <a:lstStyle/>
           <a:p>
@@ -28667,7 +28667,7 @@
         </p:spPr>
         <p:txBody>
           <a:bodyPr wrap="square">
-            <a:spAutoFit/>
+            <a:normAutofit/>
           </a:bodyPr>
           <a:lstStyle/>
           <a:p>
@@ -28702,7 +28702,7 @@
         </p:spPr>
         <p:txBody>
           <a:bodyPr wrap="square">
-            <a:spAutoFit/>
+            <a:normAutofit/>
           </a:bodyPr>
           <a:lstStyle/>
           <a:p>
@@ -28780,7 +28780,7 @@
         </p:spPr>
         <p:txBody>
           <a:bodyPr wrap="square">
-            <a:spAutoFit/>
+            <a:normAutofit/>
           </a:bodyPr>
           <a:lstStyle/>
           <a:p>
@@ -28815,7 +28815,7 @@
         </p:spPr>
         <p:txBody>
           <a:bodyPr wrap="square">
-            <a:spAutoFit/>
+            <a:normAutofit/>
           </a:bodyPr>
           <a:lstStyle/>
           <a:p>
@@ -28850,7 +28850,7 @@
         </p:spPr>
         <p:txBody>
           <a:bodyPr wrap="square">
-            <a:spAutoFit/>
+            <a:normAutofit/>
           </a:bodyPr>
           <a:lstStyle/>
           <a:p>
@@ -28928,7 +28928,7 @@
         </p:spPr>
         <p:txBody>
           <a:bodyPr wrap="square">
-            <a:spAutoFit/>
+            <a:normAutofit/>
           </a:bodyPr>
           <a:lstStyle/>
           <a:p>
@@ -29006,7 +29006,7 @@
         </p:spPr>
         <p:txBody>
           <a:bodyPr wrap="square">
-            <a:spAutoFit/>
+            <a:normAutofit/>
           </a:bodyPr>
           <a:lstStyle/>
           <a:p>
@@ -29041,7 +29041,7 @@
         </p:spPr>
         <p:txBody>
           <a:bodyPr wrap="square">
-            <a:spAutoFit/>
+            <a:normAutofit/>
           </a:bodyPr>
           <a:lstStyle/>
           <a:p>
@@ -29076,7 +29076,7 @@
         </p:spPr>
         <p:txBody>
           <a:bodyPr wrap="square">
-            <a:spAutoFit/>
+            <a:normAutofit/>
           </a:bodyPr>
           <a:lstStyle/>
           <a:p>
@@ -29154,7 +29154,7 @@
         </p:spPr>
         <p:txBody>
           <a:bodyPr wrap="square">
-            <a:spAutoFit/>
+            <a:normAutofit/>
           </a:bodyPr>
           <a:lstStyle/>
           <a:p>
@@ -29189,7 +29189,7 @@
         </p:spPr>
         <p:txBody>
           <a:bodyPr wrap="square">
-            <a:spAutoFit/>
+            <a:normAutofit/>
           </a:bodyPr>
           <a:lstStyle/>
           <a:p>
@@ -29224,7 +29224,7 @@
         </p:spPr>
         <p:txBody>
           <a:bodyPr wrap="square">
-            <a:spAutoFit/>
+            <a:normAutofit/>
           </a:bodyPr>
           <a:lstStyle/>
           <a:p>
@@ -29302,7 +29302,7 @@
         </p:spPr>
         <p:txBody>
           <a:bodyPr wrap="square">
-            <a:spAutoFit/>
+            <a:normAutofit/>
           </a:bodyPr>
           <a:lstStyle/>
           <a:p>
@@ -29337,7 +29337,7 @@
         </p:spPr>
         <p:txBody>
           <a:bodyPr wrap="square">
-            <a:spAutoFit/>
+            <a:normAutofit/>
           </a:bodyPr>
           <a:lstStyle/>
           <a:p>
@@ -29372,7 +29372,7 @@
         </p:spPr>
         <p:txBody>
           <a:bodyPr wrap="square">
-            <a:spAutoFit/>
+            <a:normAutofit/>
           </a:bodyPr>
           <a:lstStyle/>
           <a:p>
@@ -29450,7 +29450,7 @@
         </p:spPr>
         <p:txBody>
           <a:bodyPr wrap="square">
-            <a:spAutoFit/>
+            <a:normAutofit/>
           </a:bodyPr>
           <a:lstStyle/>
           <a:p>
@@ -29485,7 +29485,7 @@
         </p:spPr>
         <p:txBody>
           <a:bodyPr wrap="square">
-            <a:spAutoFit/>
+            <a:normAutofit/>
           </a:bodyPr>
           <a:lstStyle/>
           <a:p>
@@ -29520,7 +29520,7 @@
         </p:spPr>
         <p:txBody>
           <a:bodyPr wrap="square">
-            <a:spAutoFit/>
+            <a:normAutofit/>
           </a:bodyPr>
           <a:lstStyle/>
           <a:p>
@@ -29598,7 +29598,7 @@
         </p:spPr>
         <p:txBody>
           <a:bodyPr wrap="square">
-            <a:spAutoFit/>
+            <a:normAutofit/>
           </a:bodyPr>
           <a:lstStyle/>
           <a:p>
@@ -29633,7 +29633,7 @@
         </p:spPr>
         <p:txBody>
           <a:bodyPr wrap="square">
-            <a:spAutoFit/>
+            <a:normAutofit/>
           </a:bodyPr>
           <a:lstStyle/>
           <a:p>
@@ -29668,7 +29668,7 @@
         </p:spPr>
         <p:txBody>
           <a:bodyPr wrap="square">
-            <a:spAutoFit/>
+            <a:normAutofit/>
           </a:bodyPr>
           <a:lstStyle/>
           <a:p>
@@ -29746,7 +29746,7 @@
         </p:spPr>
         <p:txBody>
           <a:bodyPr wrap="square">
-            <a:spAutoFit/>
+            <a:normAutofit/>
           </a:bodyPr>
           <a:lstStyle/>
           <a:p>
@@ -29781,7 +29781,7 @@
         </p:spPr>
         <p:txBody>
           <a:bodyPr wrap="square">
-            <a:spAutoFit/>
+            <a:normAutofit/>
           </a:bodyPr>
           <a:lstStyle/>
           <a:p>
@@ -29816,7 +29816,7 @@
         </p:spPr>
         <p:txBody>
           <a:bodyPr wrap="square">
-            <a:spAutoFit/>
+            <a:normAutofit/>
           </a:bodyPr>
           <a:lstStyle/>
           <a:p>
@@ -29937,7 +29937,7 @@
         </p:spPr>
         <p:txBody>
           <a:bodyPr wrap="square">
-            <a:spAutoFit/>
+            <a:normAutofit/>
           </a:bodyPr>
           <a:lstStyle/>
           <a:p>
@@ -29972,7 +29972,7 @@
         </p:spPr>
         <p:txBody>
           <a:bodyPr wrap="square">
-            <a:spAutoFit/>
+            <a:normAutofit/>
           </a:bodyPr>
           <a:lstStyle/>
           <a:p>
@@ -30093,7 +30093,7 @@
         </p:spPr>
         <p:txBody>
           <a:bodyPr wrap="square">
-            <a:spAutoFit/>
+            <a:normAutofit/>
           </a:bodyPr>
           <a:lstStyle/>
           <a:p>
@@ -30171,7 +30171,7 @@
         </p:spPr>
         <p:txBody>
           <a:bodyPr wrap="square">
-            <a:spAutoFit/>
+            <a:normAutofit/>
           </a:bodyPr>
           <a:lstStyle/>
           <a:p>
@@ -30249,7 +30249,7 @@
         </p:spPr>
         <p:txBody>
           <a:bodyPr wrap="square">
-            <a:spAutoFit/>
+            <a:normAutofit/>
           </a:bodyPr>
           <a:lstStyle/>
           <a:p>
@@ -30327,7 +30327,7 @@
         </p:spPr>
         <p:txBody>
           <a:bodyPr wrap="square">
-            <a:spAutoFit/>
+            <a:normAutofit/>
           </a:bodyPr>
           <a:lstStyle/>
           <a:p>
@@ -30405,7 +30405,7 @@
         </p:spPr>
         <p:txBody>
           <a:bodyPr wrap="square">
-            <a:spAutoFit/>
+            <a:normAutofit/>
           </a:bodyPr>
           <a:lstStyle/>
           <a:p>
@@ -30483,7 +30483,7 @@
         </p:spPr>
         <p:txBody>
           <a:bodyPr wrap="square">
-            <a:spAutoFit/>
+            <a:normAutofit/>
           </a:bodyPr>
           <a:lstStyle/>
           <a:p>
@@ -30561,7 +30561,7 @@
         </p:spPr>
         <p:txBody>
           <a:bodyPr wrap="square">
-            <a:spAutoFit/>
+            <a:normAutofit/>
           </a:bodyPr>
           <a:lstStyle/>
           <a:p>
@@ -30596,7 +30596,7 @@
         </p:spPr>
         <p:txBody>
           <a:bodyPr wrap="square">
-            <a:spAutoFit/>
+            <a:normAutofit/>
           </a:bodyPr>
           <a:lstStyle/>
           <a:p>

</xml_diff>

<commit_message>
fix: update KPIs to realistic targets based on actual IG baseline
Actual account data: 1,031 total IG views, 389 accounts reached (organic).
New account with ~200-350 views/Reel before boost.

KPI changes (per boosted post, PH market rates for new accounts):
- Reach: 3,000-7,000 → 600-1,500 (TikTok), 400-900 (IG)
- Views: 5,000-15,000 → 800-2,000 (TikTok)
- New followers: 20-80 → 5-20 (TikTok), 3-12 (IG)
- CPF: <Php 25 → Php 35-90 (TikTok), Php 60-110 (IG)
- W3 CPF goal: <Php 15 → <Php 45 (TikTok), <Php 65 (IG)
- Scale rule trigger: CPF <Php 12 → <Php 30

Add organic baseline bar to KPI slide with IG data.
Update scale rules: 50+ followers → 25+, CPF<12 → CPF<30.

Co-Authored-By: Claude Sonnet 4.6 <noreply@anthropic.com>
</commit_message>
<xml_diff>
--- a/content/strategy/TitoAI-ContentBoostPlan-W26-W28.pptx
+++ b/content/strategy/TitoAI-ContentBoostPlan-W26-W28.pptx
@@ -22531,7 +22531,7 @@
                 </a:solidFill>
                 <a:latin typeface="Arial"/>
               </a:rPr>
-              <a:t>Single post earns 50+ followers  →  extend that post 2 more days at the same daily rate</a:t>
+              <a:t>Single post earns 25+ followers  →  extend that post 2 more days at the same daily rate</a:t>
             </a:r>
           </a:p>
         </p:txBody>
@@ -22609,7 +22609,7 @@
                 </a:solidFill>
                 <a:latin typeface="Arial"/>
               </a:rPr>
-              <a:t>Cost-per-follow drops below Php 12  →  increase that platform's weekly budget by Php 400</a:t>
+              <a:t>Cost-per-follow drops below Php 30  →  increase that platform's weekly budget by Php 400</a:t>
             </a:r>
           </a:p>
         </p:txBody>
@@ -22982,7 +22982,7 @@
                 </a:solidFill>
                 <a:latin typeface="Arial"/>
               </a:rPr>
-              <a:t>Pull every Sunday · share screenshots · review before next week's boost</a:t>
+              <a:t>Baseline: IG 1,031 views · 389 reached (organic) · targets based on PH market rates for new accounts</a:t>
             </a:r>
           </a:p>
         </p:txBody>
@@ -23039,6 +23039,127 @@
         <p:spPr>
           <a:xfrm>
             <a:off x="320040" y="1783080"/>
+            <a:ext cx="11548872" cy="292608"/>
+          </a:xfrm>
+          <a:prstGeom prst="rect">
+            <a:avLst/>
+          </a:prstGeom>
+          <a:solidFill>
+            <a:srgbClr val="1C1F2E"/>
+          </a:solidFill>
+          <a:ln>
+            <a:noFill/>
+          </a:ln>
+        </p:spPr>
+        <p:style>
+          <a:lnRef idx="1">
+            <a:schemeClr val="accent1"/>
+          </a:lnRef>
+          <a:fillRef idx="3">
+            <a:schemeClr val="accent1"/>
+          </a:fillRef>
+          <a:effectRef idx="2">
+            <a:schemeClr val="accent1"/>
+          </a:effectRef>
+          <a:fontRef idx="minor">
+            <a:schemeClr val="lt1"/>
+          </a:fontRef>
+        </p:style>
+        <p:txBody>
+          <a:bodyPr rtlCol="0" anchor="ctr"/>
+          <a:lstStyle/>
+          <a:p>
+            <a:pPr algn="ctr"/>
+          </a:p>
+        </p:txBody>
+      </p:sp>
+      <p:sp>
+        <p:nvSpPr>
+          <p:cNvPr id="8" name="Rectangle 7"/>
+          <p:cNvSpPr/>
+          <p:nvPr/>
+        </p:nvSpPr>
+        <p:spPr>
+          <a:xfrm>
+            <a:off x="320040" y="1783080"/>
+            <a:ext cx="63500" cy="292608"/>
+          </a:xfrm>
+          <a:prstGeom prst="rect">
+            <a:avLst/>
+          </a:prstGeom>
+          <a:solidFill>
+            <a:srgbClr val="FCD34D"/>
+          </a:solidFill>
+          <a:ln>
+            <a:noFill/>
+          </a:ln>
+        </p:spPr>
+        <p:style>
+          <a:lnRef idx="1">
+            <a:schemeClr val="accent1"/>
+          </a:lnRef>
+          <a:fillRef idx="3">
+            <a:schemeClr val="accent1"/>
+          </a:fillRef>
+          <a:effectRef idx="2">
+            <a:schemeClr val="accent1"/>
+          </a:effectRef>
+          <a:fontRef idx="minor">
+            <a:schemeClr val="lt1"/>
+          </a:fontRef>
+        </p:style>
+        <p:txBody>
+          <a:bodyPr rtlCol="0" anchor="ctr"/>
+          <a:lstStyle/>
+          <a:p>
+            <a:pPr algn="ctr"/>
+          </a:p>
+        </p:txBody>
+      </p:sp>
+      <p:sp>
+        <p:nvSpPr>
+          <p:cNvPr id="9" name="TextBox 8"/>
+          <p:cNvSpPr txBox="1"/>
+          <p:nvPr/>
+        </p:nvSpPr>
+        <p:spPr>
+          <a:xfrm>
+            <a:off x="448056" y="1847088"/>
+            <a:ext cx="11292840" cy="201168"/>
+          </a:xfrm>
+          <a:prstGeom prst="rect">
+            <a:avLst/>
+          </a:prstGeom>
+          <a:noFill/>
+        </p:spPr>
+        <p:txBody>
+          <a:bodyPr wrap="square">
+            <a:normAutofit/>
+          </a:bodyPr>
+          <a:lstStyle/>
+          <a:p>
+            <a:pPr algn="l"/>
+            <a:r>
+              <a:rPr sz="850" b="0" i="0">
+                <a:solidFill>
+                  <a:srgbClr val="FCD34D"/>
+                </a:solidFill>
+                <a:latin typeface="Arial"/>
+              </a:rPr>
+              <a:t>ORGANIC BASELINE (before boost)  ·  Instagram: 1,031 total views · 389 accounts reached · ~200–350 views/Reel  ·  TikTok: pending  ·  New account — boost targets set conservatively</a:t>
+            </a:r>
+          </a:p>
+        </p:txBody>
+      </p:sp>
+      <p:sp>
+        <p:nvSpPr>
+          <p:cNvPr id="10" name="Rectangle 9"/>
+          <p:cNvSpPr/>
+          <p:nvPr/>
+        </p:nvSpPr>
+        <p:spPr>
+          <a:xfrm>
+            <a:off x="320040" y="2148840"/>
             <a:ext cx="3529584" cy="310896"/>
           </a:xfrm>
           <a:prstGeom prst="rect">
@@ -23075,13 +23196,13 @@
       </p:sp>
       <p:sp>
         <p:nvSpPr>
-          <p:cNvPr id="8" name="TextBox 7"/>
-          <p:cNvSpPr txBox="1"/>
-          <p:nvPr/>
-        </p:nvSpPr>
-        <p:spPr>
-          <a:xfrm>
-            <a:off x="448056" y="1856232"/>
+          <p:cNvPr id="11" name="TextBox 10"/>
+          <p:cNvSpPr txBox="1"/>
+          <p:nvPr/>
+        </p:nvSpPr>
+        <p:spPr>
+          <a:xfrm>
+            <a:off x="448056" y="2221992"/>
             <a:ext cx="3273552" cy="219456"/>
           </a:xfrm>
           <a:prstGeom prst="rect">
@@ -23110,13 +23231,13 @@
       </p:sp>
       <p:sp>
         <p:nvSpPr>
-          <p:cNvPr id="9" name="Rectangle 8"/>
-          <p:cNvSpPr/>
-          <p:nvPr/>
-        </p:nvSpPr>
-        <p:spPr>
-          <a:xfrm>
-            <a:off x="3849624" y="1783080"/>
+          <p:cNvPr id="12" name="Rectangle 11"/>
+          <p:cNvSpPr/>
+          <p:nvPr/>
+        </p:nvSpPr>
+        <p:spPr>
+          <a:xfrm>
+            <a:off x="3849624" y="2148840"/>
             <a:ext cx="2651760" cy="310896"/>
           </a:xfrm>
           <a:prstGeom prst="rect">
@@ -23153,13 +23274,13 @@
       </p:sp>
       <p:sp>
         <p:nvSpPr>
-          <p:cNvPr id="10" name="TextBox 9"/>
-          <p:cNvSpPr txBox="1"/>
-          <p:nvPr/>
-        </p:nvSpPr>
-        <p:spPr>
-          <a:xfrm>
-            <a:off x="3977640" y="1856232"/>
+          <p:cNvPr id="13" name="TextBox 12"/>
+          <p:cNvSpPr txBox="1"/>
+          <p:nvPr/>
+        </p:nvSpPr>
+        <p:spPr>
+          <a:xfrm>
+            <a:off x="3977640" y="2221992"/>
             <a:ext cx="2395728" cy="219456"/>
           </a:xfrm>
           <a:prstGeom prst="rect">
@@ -23188,13 +23309,13 @@
       </p:sp>
       <p:sp>
         <p:nvSpPr>
-          <p:cNvPr id="11" name="Rectangle 10"/>
-          <p:cNvSpPr/>
-          <p:nvPr/>
-        </p:nvSpPr>
-        <p:spPr>
-          <a:xfrm>
-            <a:off x="6501384" y="1783080"/>
+          <p:cNvPr id="14" name="Rectangle 13"/>
+          <p:cNvSpPr/>
+          <p:nvPr/>
+        </p:nvSpPr>
+        <p:spPr>
+          <a:xfrm>
+            <a:off x="6501384" y="2148840"/>
             <a:ext cx="2651760" cy="310896"/>
           </a:xfrm>
           <a:prstGeom prst="rect">
@@ -23231,13 +23352,13 @@
       </p:sp>
       <p:sp>
         <p:nvSpPr>
-          <p:cNvPr id="12" name="TextBox 11"/>
-          <p:cNvSpPr txBox="1"/>
-          <p:nvPr/>
-        </p:nvSpPr>
-        <p:spPr>
-          <a:xfrm>
-            <a:off x="6629400" y="1856232"/>
+          <p:cNvPr id="15" name="TextBox 14"/>
+          <p:cNvSpPr txBox="1"/>
+          <p:nvPr/>
+        </p:nvSpPr>
+        <p:spPr>
+          <a:xfrm>
+            <a:off x="6629400" y="2221992"/>
             <a:ext cx="2395728" cy="219456"/>
           </a:xfrm>
           <a:prstGeom prst="rect">
@@ -23266,13 +23387,13 @@
       </p:sp>
       <p:sp>
         <p:nvSpPr>
-          <p:cNvPr id="13" name="Rectangle 12"/>
-          <p:cNvSpPr/>
-          <p:nvPr/>
-        </p:nvSpPr>
-        <p:spPr>
-          <a:xfrm>
-            <a:off x="9153144" y="1783080"/>
+          <p:cNvPr id="16" name="Rectangle 15"/>
+          <p:cNvSpPr/>
+          <p:nvPr/>
+        </p:nvSpPr>
+        <p:spPr>
+          <a:xfrm>
+            <a:off x="9153144" y="2148840"/>
             <a:ext cx="2715768" cy="310896"/>
           </a:xfrm>
           <a:prstGeom prst="rect">
@@ -23309,13 +23430,13 @@
       </p:sp>
       <p:sp>
         <p:nvSpPr>
-          <p:cNvPr id="14" name="TextBox 13"/>
-          <p:cNvSpPr txBox="1"/>
-          <p:nvPr/>
-        </p:nvSpPr>
-        <p:spPr>
-          <a:xfrm>
-            <a:off x="9281160" y="1856232"/>
+          <p:cNvPr id="17" name="TextBox 16"/>
+          <p:cNvSpPr txBox="1"/>
+          <p:nvPr/>
+        </p:nvSpPr>
+        <p:spPr>
+          <a:xfrm>
+            <a:off x="9281160" y="2221992"/>
             <a:ext cx="2459736" cy="219456"/>
           </a:xfrm>
           <a:prstGeom prst="rect">
@@ -23344,14 +23465,14 @@
       </p:sp>
       <p:sp>
         <p:nvSpPr>
-          <p:cNvPr id="15" name="Rectangle 14"/>
-          <p:cNvSpPr/>
-          <p:nvPr/>
-        </p:nvSpPr>
-        <p:spPr>
-          <a:xfrm>
-            <a:off x="320040" y="2093976"/>
-            <a:ext cx="3529584" cy="384048"/>
+          <p:cNvPr id="18" name="Rectangle 17"/>
+          <p:cNvSpPr/>
+          <p:nvPr/>
+        </p:nvSpPr>
+        <p:spPr>
+          <a:xfrm>
+            <a:off x="320040" y="2459736"/>
+            <a:ext cx="3529584" cy="347472"/>
           </a:xfrm>
           <a:prstGeom prst="rect">
             <a:avLst/>
@@ -23387,14 +23508,14 @@
       </p:sp>
       <p:sp>
         <p:nvSpPr>
-          <p:cNvPr id="16" name="Rectangle 15"/>
-          <p:cNvSpPr/>
-          <p:nvPr/>
-        </p:nvSpPr>
-        <p:spPr>
-          <a:xfrm>
-            <a:off x="3849624" y="2093976"/>
-            <a:ext cx="2651760" cy="384048"/>
+          <p:cNvPr id="19" name="Rectangle 18"/>
+          <p:cNvSpPr/>
+          <p:nvPr/>
+        </p:nvSpPr>
+        <p:spPr>
+          <a:xfrm>
+            <a:off x="3849624" y="2459736"/>
+            <a:ext cx="2651760" cy="347472"/>
           </a:xfrm>
           <a:prstGeom prst="rect">
             <a:avLst/>
@@ -23430,14 +23551,14 @@
       </p:sp>
       <p:sp>
         <p:nvSpPr>
-          <p:cNvPr id="17" name="Rectangle 16"/>
-          <p:cNvSpPr/>
-          <p:nvPr/>
-        </p:nvSpPr>
-        <p:spPr>
-          <a:xfrm>
-            <a:off x="6501384" y="2093976"/>
-            <a:ext cx="2651760" cy="384048"/>
+          <p:cNvPr id="20" name="Rectangle 19"/>
+          <p:cNvSpPr/>
+          <p:nvPr/>
+        </p:nvSpPr>
+        <p:spPr>
+          <a:xfrm>
+            <a:off x="6501384" y="2459736"/>
+            <a:ext cx="2651760" cy="347472"/>
           </a:xfrm>
           <a:prstGeom prst="rect">
             <a:avLst/>
@@ -23473,14 +23594,14 @@
       </p:sp>
       <p:sp>
         <p:nvSpPr>
-          <p:cNvPr id="18" name="Rectangle 17"/>
-          <p:cNvSpPr/>
-          <p:nvPr/>
-        </p:nvSpPr>
-        <p:spPr>
-          <a:xfrm>
-            <a:off x="9153144" y="2093976"/>
-            <a:ext cx="2715768" cy="384048"/>
+          <p:cNvPr id="21" name="Rectangle 20"/>
+          <p:cNvSpPr/>
+          <p:nvPr/>
+        </p:nvSpPr>
+        <p:spPr>
+          <a:xfrm>
+            <a:off x="9153144" y="2459736"/>
+            <a:ext cx="2715768" cy="347472"/>
           </a:xfrm>
           <a:prstGeom prst="rect">
             <a:avLst/>
@@ -23516,14 +23637,14 @@
       </p:sp>
       <p:sp>
         <p:nvSpPr>
-          <p:cNvPr id="19" name="Rectangle 18"/>
-          <p:cNvSpPr/>
-          <p:nvPr/>
-        </p:nvSpPr>
-        <p:spPr>
-          <a:xfrm>
-            <a:off x="320040" y="2093976"/>
-            <a:ext cx="50800" cy="384048"/>
+          <p:cNvPr id="22" name="Rectangle 21"/>
+          <p:cNvSpPr/>
+          <p:nvPr/>
+        </p:nvSpPr>
+        <p:spPr>
+          <a:xfrm>
+            <a:off x="320040" y="2459736"/>
+            <a:ext cx="50800" cy="347472"/>
           </a:xfrm>
           <a:prstGeom prst="rect">
             <a:avLst/>
@@ -23559,14 +23680,14 @@
       </p:sp>
       <p:sp>
         <p:nvSpPr>
-          <p:cNvPr id="20" name="TextBox 19"/>
-          <p:cNvSpPr txBox="1"/>
-          <p:nvPr/>
-        </p:nvSpPr>
-        <p:spPr>
-          <a:xfrm>
-            <a:off x="448056" y="2203704"/>
-            <a:ext cx="3273552" cy="219456"/>
+          <p:cNvPr id="23" name="TextBox 22"/>
+          <p:cNvSpPr txBox="1"/>
+          <p:nvPr/>
+        </p:nvSpPr>
+        <p:spPr>
+          <a:xfrm>
+            <a:off x="448056" y="2569464"/>
+            <a:ext cx="3273552" cy="182880"/>
           </a:xfrm>
           <a:prstGeom prst="rect">
             <a:avLst/>
@@ -23594,14 +23715,14 @@
       </p:sp>
       <p:sp>
         <p:nvSpPr>
-          <p:cNvPr id="21" name="TextBox 20"/>
-          <p:cNvSpPr txBox="1"/>
-          <p:nvPr/>
-        </p:nvSpPr>
-        <p:spPr>
-          <a:xfrm>
-            <a:off x="3977640" y="2203704"/>
-            <a:ext cx="2395728" cy="219456"/>
+          <p:cNvPr id="24" name="TextBox 23"/>
+          <p:cNvSpPr txBox="1"/>
+          <p:nvPr/>
+        </p:nvSpPr>
+        <p:spPr>
+          <a:xfrm>
+            <a:off x="3977640" y="2569464"/>
+            <a:ext cx="2395728" cy="182880"/>
           </a:xfrm>
           <a:prstGeom prst="rect">
             <a:avLst/>
@@ -23622,21 +23743,21 @@
                 </a:solidFill>
                 <a:latin typeface="Arial"/>
               </a:rPr>
-              <a:t>3,000–7,000+</a:t>
-            </a:r>
-          </a:p>
-        </p:txBody>
-      </p:sp>
-      <p:sp>
-        <p:nvSpPr>
-          <p:cNvPr id="22" name="TextBox 21"/>
-          <p:cNvSpPr txBox="1"/>
-          <p:nvPr/>
-        </p:nvSpPr>
-        <p:spPr>
-          <a:xfrm>
-            <a:off x="6629400" y="2203704"/>
-            <a:ext cx="2395728" cy="219456"/>
+              <a:t>600–1,500</a:t>
+            </a:r>
+          </a:p>
+        </p:txBody>
+      </p:sp>
+      <p:sp>
+        <p:nvSpPr>
+          <p:cNvPr id="25" name="TextBox 24"/>
+          <p:cNvSpPr txBox="1"/>
+          <p:nvPr/>
+        </p:nvSpPr>
+        <p:spPr>
+          <a:xfrm>
+            <a:off x="6629400" y="2569464"/>
+            <a:ext cx="2395728" cy="182880"/>
           </a:xfrm>
           <a:prstGeom prst="rect">
             <a:avLst/>
@@ -23657,21 +23778,21 @@
                 </a:solidFill>
                 <a:latin typeface="Arial"/>
               </a:rPr>
-              <a:t>2,000–5,000+</a:t>
-            </a:r>
-          </a:p>
-        </p:txBody>
-      </p:sp>
-      <p:sp>
-        <p:nvSpPr>
-          <p:cNvPr id="23" name="TextBox 22"/>
-          <p:cNvSpPr txBox="1"/>
-          <p:nvPr/>
-        </p:nvSpPr>
-        <p:spPr>
-          <a:xfrm>
-            <a:off x="9281160" y="2203704"/>
-            <a:ext cx="2459736" cy="219456"/>
+              <a:t>400–900</a:t>
+            </a:r>
+          </a:p>
+        </p:txBody>
+      </p:sp>
+      <p:sp>
+        <p:nvSpPr>
+          <p:cNvPr id="26" name="TextBox 25"/>
+          <p:cNvSpPr txBox="1"/>
+          <p:nvPr/>
+        </p:nvSpPr>
+        <p:spPr>
+          <a:xfrm>
+            <a:off x="9281160" y="2569464"/>
+            <a:ext cx="2459736" cy="182880"/>
           </a:xfrm>
           <a:prstGeom prst="rect">
             <a:avLst/>
@@ -23692,21 +23813,21 @@
                 </a:solidFill>
                 <a:latin typeface="Arial"/>
               </a:rPr>
-              <a:t>2,500–6,000+</a:t>
-            </a:r>
-          </a:p>
-        </p:txBody>
-      </p:sp>
-      <p:sp>
-        <p:nvSpPr>
-          <p:cNvPr id="24" name="Rectangle 23"/>
-          <p:cNvSpPr/>
-          <p:nvPr/>
-        </p:nvSpPr>
-        <p:spPr>
-          <a:xfrm>
-            <a:off x="320040" y="2478024"/>
-            <a:ext cx="3529584" cy="384048"/>
+              <a:t>500–1,200</a:t>
+            </a:r>
+          </a:p>
+        </p:txBody>
+      </p:sp>
+      <p:sp>
+        <p:nvSpPr>
+          <p:cNvPr id="27" name="Rectangle 26"/>
+          <p:cNvSpPr/>
+          <p:nvPr/>
+        </p:nvSpPr>
+        <p:spPr>
+          <a:xfrm>
+            <a:off x="320040" y="2807208"/>
+            <a:ext cx="3529584" cy="347472"/>
           </a:xfrm>
           <a:prstGeom prst="rect">
             <a:avLst/>
@@ -23742,14 +23863,14 @@
       </p:sp>
       <p:sp>
         <p:nvSpPr>
-          <p:cNvPr id="25" name="Rectangle 24"/>
-          <p:cNvSpPr/>
-          <p:nvPr/>
-        </p:nvSpPr>
-        <p:spPr>
-          <a:xfrm>
-            <a:off x="3849624" y="2478024"/>
-            <a:ext cx="2651760" cy="384048"/>
+          <p:cNvPr id="28" name="Rectangle 27"/>
+          <p:cNvSpPr/>
+          <p:nvPr/>
+        </p:nvSpPr>
+        <p:spPr>
+          <a:xfrm>
+            <a:off x="3849624" y="2807208"/>
+            <a:ext cx="2651760" cy="347472"/>
           </a:xfrm>
           <a:prstGeom prst="rect">
             <a:avLst/>
@@ -23785,14 +23906,14 @@
       </p:sp>
       <p:sp>
         <p:nvSpPr>
-          <p:cNvPr id="26" name="Rectangle 25"/>
-          <p:cNvSpPr/>
-          <p:nvPr/>
-        </p:nvSpPr>
-        <p:spPr>
-          <a:xfrm>
-            <a:off x="6501384" y="2478024"/>
-            <a:ext cx="2651760" cy="384048"/>
+          <p:cNvPr id="29" name="Rectangle 28"/>
+          <p:cNvSpPr/>
+          <p:nvPr/>
+        </p:nvSpPr>
+        <p:spPr>
+          <a:xfrm>
+            <a:off x="6501384" y="2807208"/>
+            <a:ext cx="2651760" cy="347472"/>
           </a:xfrm>
           <a:prstGeom prst="rect">
             <a:avLst/>
@@ -23828,14 +23949,14 @@
       </p:sp>
       <p:sp>
         <p:nvSpPr>
-          <p:cNvPr id="27" name="Rectangle 26"/>
-          <p:cNvSpPr/>
-          <p:nvPr/>
-        </p:nvSpPr>
-        <p:spPr>
-          <a:xfrm>
-            <a:off x="9153144" y="2478024"/>
-            <a:ext cx="2715768" cy="384048"/>
+          <p:cNvPr id="30" name="Rectangle 29"/>
+          <p:cNvSpPr/>
+          <p:nvPr/>
+        </p:nvSpPr>
+        <p:spPr>
+          <a:xfrm>
+            <a:off x="9153144" y="2807208"/>
+            <a:ext cx="2715768" cy="347472"/>
           </a:xfrm>
           <a:prstGeom prst="rect">
             <a:avLst/>
@@ -23871,14 +23992,14 @@
       </p:sp>
       <p:sp>
         <p:nvSpPr>
-          <p:cNvPr id="28" name="Rectangle 27"/>
-          <p:cNvSpPr/>
-          <p:nvPr/>
-        </p:nvSpPr>
-        <p:spPr>
-          <a:xfrm>
-            <a:off x="320040" y="2478024"/>
-            <a:ext cx="50800" cy="384048"/>
+          <p:cNvPr id="31" name="Rectangle 30"/>
+          <p:cNvSpPr/>
+          <p:nvPr/>
+        </p:nvSpPr>
+        <p:spPr>
+          <a:xfrm>
+            <a:off x="320040" y="2807208"/>
+            <a:ext cx="50800" cy="347472"/>
           </a:xfrm>
           <a:prstGeom prst="rect">
             <a:avLst/>
@@ -23914,14 +24035,14 @@
       </p:sp>
       <p:sp>
         <p:nvSpPr>
-          <p:cNvPr id="29" name="TextBox 28"/>
-          <p:cNvSpPr txBox="1"/>
-          <p:nvPr/>
-        </p:nvSpPr>
-        <p:spPr>
-          <a:xfrm>
-            <a:off x="448056" y="2587752"/>
-            <a:ext cx="3273552" cy="219456"/>
+          <p:cNvPr id="32" name="TextBox 31"/>
+          <p:cNvSpPr txBox="1"/>
+          <p:nvPr/>
+        </p:nvSpPr>
+        <p:spPr>
+          <a:xfrm>
+            <a:off x="448056" y="2916936"/>
+            <a:ext cx="3273552" cy="182880"/>
           </a:xfrm>
           <a:prstGeom prst="rect">
             <a:avLst/>
@@ -23942,21 +24063,21 @@
                 </a:solidFill>
                 <a:latin typeface="Arial"/>
               </a:rPr>
-              <a:t>Views / clicks per post</a:t>
-            </a:r>
-          </a:p>
-        </p:txBody>
-      </p:sp>
-      <p:sp>
-        <p:nvSpPr>
-          <p:cNvPr id="30" name="TextBox 29"/>
-          <p:cNvSpPr txBox="1"/>
-          <p:nvPr/>
-        </p:nvSpPr>
-        <p:spPr>
-          <a:xfrm>
-            <a:off x="3977640" y="2587752"/>
-            <a:ext cx="2395728" cy="219456"/>
+              <a:t>Views per boosted post</a:t>
+            </a:r>
+          </a:p>
+        </p:txBody>
+      </p:sp>
+      <p:sp>
+        <p:nvSpPr>
+          <p:cNvPr id="33" name="TextBox 32"/>
+          <p:cNvSpPr txBox="1"/>
+          <p:nvPr/>
+        </p:nvSpPr>
+        <p:spPr>
+          <a:xfrm>
+            <a:off x="3977640" y="2916936"/>
+            <a:ext cx="2395728" cy="182880"/>
           </a:xfrm>
           <a:prstGeom prst="rect">
             <a:avLst/>
@@ -23977,21 +24098,21 @@
                 </a:solidFill>
                 <a:latin typeface="Arial"/>
               </a:rPr>
-              <a:t>5,000–15,000+</a:t>
-            </a:r>
-          </a:p>
-        </p:txBody>
-      </p:sp>
-      <p:sp>
-        <p:nvSpPr>
-          <p:cNvPr id="31" name="TextBox 30"/>
-          <p:cNvSpPr txBox="1"/>
-          <p:nvPr/>
-        </p:nvSpPr>
-        <p:spPr>
-          <a:xfrm>
-            <a:off x="6629400" y="2587752"/>
-            <a:ext cx="2395728" cy="219456"/>
+              <a:t>800–2,000</a:t>
+            </a:r>
+          </a:p>
+        </p:txBody>
+      </p:sp>
+      <p:sp>
+        <p:nvSpPr>
+          <p:cNvPr id="34" name="TextBox 33"/>
+          <p:cNvSpPr txBox="1"/>
+          <p:nvPr/>
+        </p:nvSpPr>
+        <p:spPr>
+          <a:xfrm>
+            <a:off x="6629400" y="2916936"/>
+            <a:ext cx="2395728" cy="182880"/>
           </a:xfrm>
           <a:prstGeom prst="rect">
             <a:avLst/>
@@ -24012,21 +24133,21 @@
                 </a:solidFill>
                 <a:latin typeface="Arial"/>
               </a:rPr>
-              <a:t>1,500–4,000+</a:t>
-            </a:r>
-          </a:p>
-        </p:txBody>
-      </p:sp>
-      <p:sp>
-        <p:nvSpPr>
-          <p:cNvPr id="32" name="TextBox 31"/>
-          <p:cNvSpPr txBox="1"/>
-          <p:nvPr/>
-        </p:nvSpPr>
-        <p:spPr>
-          <a:xfrm>
-            <a:off x="9281160" y="2587752"/>
-            <a:ext cx="2459736" cy="219456"/>
+              <a:t>300–700</a:t>
+            </a:r>
+          </a:p>
+        </p:txBody>
+      </p:sp>
+      <p:sp>
+        <p:nvSpPr>
+          <p:cNvPr id="35" name="TextBox 34"/>
+          <p:cNvSpPr txBox="1"/>
+          <p:nvPr/>
+        </p:nvSpPr>
+        <p:spPr>
+          <a:xfrm>
+            <a:off x="9281160" y="2916936"/>
+            <a:ext cx="2459736" cy="182880"/>
           </a:xfrm>
           <a:prstGeom prst="rect">
             <a:avLst/>
@@ -24047,21 +24168,21 @@
                 </a:solidFill>
                 <a:latin typeface="Arial"/>
               </a:rPr>
-              <a:t>1,000–3,000+</a:t>
-            </a:r>
-          </a:p>
-        </p:txBody>
-      </p:sp>
-      <p:sp>
-        <p:nvSpPr>
-          <p:cNvPr id="33" name="Rectangle 32"/>
-          <p:cNvSpPr/>
-          <p:nvPr/>
-        </p:nvSpPr>
-        <p:spPr>
-          <a:xfrm>
-            <a:off x="320040" y="2862072"/>
-            <a:ext cx="3529584" cy="384048"/>
+              <a:t>N/A</a:t>
+            </a:r>
+          </a:p>
+        </p:txBody>
+      </p:sp>
+      <p:sp>
+        <p:nvSpPr>
+          <p:cNvPr id="36" name="Rectangle 35"/>
+          <p:cNvSpPr/>
+          <p:nvPr/>
+        </p:nvSpPr>
+        <p:spPr>
+          <a:xfrm>
+            <a:off x="320040" y="3154680"/>
+            <a:ext cx="3529584" cy="347472"/>
           </a:xfrm>
           <a:prstGeom prst="rect">
             <a:avLst/>
@@ -24097,14 +24218,14 @@
       </p:sp>
       <p:sp>
         <p:nvSpPr>
-          <p:cNvPr id="34" name="Rectangle 33"/>
-          <p:cNvSpPr/>
-          <p:nvPr/>
-        </p:nvSpPr>
-        <p:spPr>
-          <a:xfrm>
-            <a:off x="3849624" y="2862072"/>
-            <a:ext cx="2651760" cy="384048"/>
+          <p:cNvPr id="37" name="Rectangle 36"/>
+          <p:cNvSpPr/>
+          <p:nvPr/>
+        </p:nvSpPr>
+        <p:spPr>
+          <a:xfrm>
+            <a:off x="3849624" y="3154680"/>
+            <a:ext cx="2651760" cy="347472"/>
           </a:xfrm>
           <a:prstGeom prst="rect">
             <a:avLst/>
@@ -24140,14 +24261,14 @@
       </p:sp>
       <p:sp>
         <p:nvSpPr>
-          <p:cNvPr id="35" name="Rectangle 34"/>
-          <p:cNvSpPr/>
-          <p:nvPr/>
-        </p:nvSpPr>
-        <p:spPr>
-          <a:xfrm>
-            <a:off x="6501384" y="2862072"/>
-            <a:ext cx="2651760" cy="384048"/>
+          <p:cNvPr id="38" name="Rectangle 37"/>
+          <p:cNvSpPr/>
+          <p:nvPr/>
+        </p:nvSpPr>
+        <p:spPr>
+          <a:xfrm>
+            <a:off x="6501384" y="3154680"/>
+            <a:ext cx="2651760" cy="347472"/>
           </a:xfrm>
           <a:prstGeom prst="rect">
             <a:avLst/>
@@ -24183,14 +24304,14 @@
       </p:sp>
       <p:sp>
         <p:nvSpPr>
-          <p:cNvPr id="36" name="Rectangle 35"/>
-          <p:cNvSpPr/>
-          <p:nvPr/>
-        </p:nvSpPr>
-        <p:spPr>
-          <a:xfrm>
-            <a:off x="9153144" y="2862072"/>
-            <a:ext cx="2715768" cy="384048"/>
+          <p:cNvPr id="39" name="Rectangle 38"/>
+          <p:cNvSpPr/>
+          <p:nvPr/>
+        </p:nvSpPr>
+        <p:spPr>
+          <a:xfrm>
+            <a:off x="9153144" y="3154680"/>
+            <a:ext cx="2715768" cy="347472"/>
           </a:xfrm>
           <a:prstGeom prst="rect">
             <a:avLst/>
@@ -24226,14 +24347,14 @@
       </p:sp>
       <p:sp>
         <p:nvSpPr>
-          <p:cNvPr id="37" name="Rectangle 36"/>
-          <p:cNvSpPr/>
-          <p:nvPr/>
-        </p:nvSpPr>
-        <p:spPr>
-          <a:xfrm>
-            <a:off x="320040" y="2862072"/>
-            <a:ext cx="50800" cy="384048"/>
+          <p:cNvPr id="40" name="Rectangle 39"/>
+          <p:cNvSpPr/>
+          <p:nvPr/>
+        </p:nvSpPr>
+        <p:spPr>
+          <a:xfrm>
+            <a:off x="320040" y="3154680"/>
+            <a:ext cx="50800" cy="347472"/>
           </a:xfrm>
           <a:prstGeom prst="rect">
             <a:avLst/>
@@ -24269,14 +24390,14 @@
       </p:sp>
       <p:sp>
         <p:nvSpPr>
-          <p:cNvPr id="38" name="TextBox 37"/>
-          <p:cNvSpPr txBox="1"/>
-          <p:nvPr/>
-        </p:nvSpPr>
-        <p:spPr>
-          <a:xfrm>
-            <a:off x="448056" y="2971800"/>
-            <a:ext cx="3273552" cy="219456"/>
+          <p:cNvPr id="41" name="TextBox 40"/>
+          <p:cNvSpPr txBox="1"/>
+          <p:nvPr/>
+        </p:nvSpPr>
+        <p:spPr>
+          <a:xfrm>
+            <a:off x="448056" y="3264408"/>
+            <a:ext cx="3273552" cy="182880"/>
           </a:xfrm>
           <a:prstGeom prst="rect">
             <a:avLst/>
@@ -24297,21 +24418,21 @@
                 </a:solidFill>
                 <a:latin typeface="Arial"/>
               </a:rPr>
-              <a:t>New followers per post</a:t>
-            </a:r>
-          </a:p>
-        </p:txBody>
-      </p:sp>
-      <p:sp>
-        <p:nvSpPr>
-          <p:cNvPr id="39" name="TextBox 38"/>
-          <p:cNvSpPr txBox="1"/>
-          <p:nvPr/>
-        </p:nvSpPr>
-        <p:spPr>
-          <a:xfrm>
-            <a:off x="3977640" y="2971800"/>
-            <a:ext cx="2395728" cy="219456"/>
+              <a:t>New followers per boost</a:t>
+            </a:r>
+          </a:p>
+        </p:txBody>
+      </p:sp>
+      <p:sp>
+        <p:nvSpPr>
+          <p:cNvPr id="42" name="TextBox 41"/>
+          <p:cNvSpPr txBox="1"/>
+          <p:nvPr/>
+        </p:nvSpPr>
+        <p:spPr>
+          <a:xfrm>
+            <a:off x="3977640" y="3264408"/>
+            <a:ext cx="2395728" cy="182880"/>
           </a:xfrm>
           <a:prstGeom prst="rect">
             <a:avLst/>
@@ -24332,21 +24453,21 @@
                 </a:solidFill>
                 <a:latin typeface="Arial"/>
               </a:rPr>
-              <a:t>20–80+</a:t>
-            </a:r>
-          </a:p>
-        </p:txBody>
-      </p:sp>
-      <p:sp>
-        <p:nvSpPr>
-          <p:cNvPr id="40" name="TextBox 39"/>
-          <p:cNvSpPr txBox="1"/>
-          <p:nvPr/>
-        </p:nvSpPr>
-        <p:spPr>
-          <a:xfrm>
-            <a:off x="6629400" y="2971800"/>
-            <a:ext cx="2395728" cy="219456"/>
+              <a:t>5–20</a:t>
+            </a:r>
+          </a:p>
+        </p:txBody>
+      </p:sp>
+      <p:sp>
+        <p:nvSpPr>
+          <p:cNvPr id="43" name="TextBox 42"/>
+          <p:cNvSpPr txBox="1"/>
+          <p:nvPr/>
+        </p:nvSpPr>
+        <p:spPr>
+          <a:xfrm>
+            <a:off x="6629400" y="3264408"/>
+            <a:ext cx="2395728" cy="182880"/>
           </a:xfrm>
           <a:prstGeom prst="rect">
             <a:avLst/>
@@ -24367,21 +24488,21 @@
                 </a:solidFill>
                 <a:latin typeface="Arial"/>
               </a:rPr>
-              <a:t>15–50+</a:t>
-            </a:r>
-          </a:p>
-        </p:txBody>
-      </p:sp>
-      <p:sp>
-        <p:nvSpPr>
-          <p:cNvPr id="41" name="TextBox 40"/>
-          <p:cNvSpPr txBox="1"/>
-          <p:nvPr/>
-        </p:nvSpPr>
-        <p:spPr>
-          <a:xfrm>
-            <a:off x="9281160" y="2971800"/>
-            <a:ext cx="2459736" cy="219456"/>
+              <a:t>3–12</a:t>
+            </a:r>
+          </a:p>
+        </p:txBody>
+      </p:sp>
+      <p:sp>
+        <p:nvSpPr>
+          <p:cNvPr id="44" name="TextBox 43"/>
+          <p:cNvSpPr txBox="1"/>
+          <p:nvPr/>
+        </p:nvSpPr>
+        <p:spPr>
+          <a:xfrm>
+            <a:off x="9281160" y="3264408"/>
+            <a:ext cx="2459736" cy="182880"/>
           </a:xfrm>
           <a:prstGeom prst="rect">
             <a:avLst/>
@@ -24402,21 +24523,21 @@
                 </a:solidFill>
                 <a:latin typeface="Arial"/>
               </a:rPr>
-              <a:t>20–50+ page likes</a:t>
-            </a:r>
-          </a:p>
-        </p:txBody>
-      </p:sp>
-      <p:sp>
-        <p:nvSpPr>
-          <p:cNvPr id="42" name="Rectangle 41"/>
-          <p:cNvSpPr/>
-          <p:nvPr/>
-        </p:nvSpPr>
-        <p:spPr>
-          <a:xfrm>
-            <a:off x="320040" y="3246120"/>
-            <a:ext cx="3529584" cy="384048"/>
+              <a:t>10–25 page likes</a:t>
+            </a:r>
+          </a:p>
+        </p:txBody>
+      </p:sp>
+      <p:sp>
+        <p:nvSpPr>
+          <p:cNvPr id="45" name="Rectangle 44"/>
+          <p:cNvSpPr/>
+          <p:nvPr/>
+        </p:nvSpPr>
+        <p:spPr>
+          <a:xfrm>
+            <a:off x="320040" y="3502152"/>
+            <a:ext cx="3529584" cy="347472"/>
           </a:xfrm>
           <a:prstGeom prst="rect">
             <a:avLst/>
@@ -24452,14 +24573,14 @@
       </p:sp>
       <p:sp>
         <p:nvSpPr>
-          <p:cNvPr id="43" name="Rectangle 42"/>
-          <p:cNvSpPr/>
-          <p:nvPr/>
-        </p:nvSpPr>
-        <p:spPr>
-          <a:xfrm>
-            <a:off x="3849624" y="3246120"/>
-            <a:ext cx="2651760" cy="384048"/>
+          <p:cNvPr id="46" name="Rectangle 45"/>
+          <p:cNvSpPr/>
+          <p:nvPr/>
+        </p:nvSpPr>
+        <p:spPr>
+          <a:xfrm>
+            <a:off x="3849624" y="3502152"/>
+            <a:ext cx="2651760" cy="347472"/>
           </a:xfrm>
           <a:prstGeom prst="rect">
             <a:avLst/>
@@ -24495,14 +24616,14 @@
       </p:sp>
       <p:sp>
         <p:nvSpPr>
-          <p:cNvPr id="44" name="Rectangle 43"/>
-          <p:cNvSpPr/>
-          <p:nvPr/>
-        </p:nvSpPr>
-        <p:spPr>
-          <a:xfrm>
-            <a:off x="6501384" y="3246120"/>
-            <a:ext cx="2651760" cy="384048"/>
+          <p:cNvPr id="47" name="Rectangle 46"/>
+          <p:cNvSpPr/>
+          <p:nvPr/>
+        </p:nvSpPr>
+        <p:spPr>
+          <a:xfrm>
+            <a:off x="6501384" y="3502152"/>
+            <a:ext cx="2651760" cy="347472"/>
           </a:xfrm>
           <a:prstGeom prst="rect">
             <a:avLst/>
@@ -24538,14 +24659,14 @@
       </p:sp>
       <p:sp>
         <p:nvSpPr>
-          <p:cNvPr id="45" name="Rectangle 44"/>
-          <p:cNvSpPr/>
-          <p:nvPr/>
-        </p:nvSpPr>
-        <p:spPr>
-          <a:xfrm>
-            <a:off x="9153144" y="3246120"/>
-            <a:ext cx="2715768" cy="384048"/>
+          <p:cNvPr id="48" name="Rectangle 47"/>
+          <p:cNvSpPr/>
+          <p:nvPr/>
+        </p:nvSpPr>
+        <p:spPr>
+          <a:xfrm>
+            <a:off x="9153144" y="3502152"/>
+            <a:ext cx="2715768" cy="347472"/>
           </a:xfrm>
           <a:prstGeom prst="rect">
             <a:avLst/>
@@ -24581,14 +24702,14 @@
       </p:sp>
       <p:sp>
         <p:nvSpPr>
-          <p:cNvPr id="46" name="Rectangle 45"/>
-          <p:cNvSpPr/>
-          <p:nvPr/>
-        </p:nvSpPr>
-        <p:spPr>
-          <a:xfrm>
-            <a:off x="320040" y="3246120"/>
-            <a:ext cx="50800" cy="384048"/>
+          <p:cNvPr id="49" name="Rectangle 48"/>
+          <p:cNvSpPr/>
+          <p:nvPr/>
+        </p:nvSpPr>
+        <p:spPr>
+          <a:xfrm>
+            <a:off x="320040" y="3502152"/>
+            <a:ext cx="50800" cy="347472"/>
           </a:xfrm>
           <a:prstGeom prst="rect">
             <a:avLst/>
@@ -24624,14 +24745,14 @@
       </p:sp>
       <p:sp>
         <p:nvSpPr>
-          <p:cNvPr id="47" name="TextBox 46"/>
-          <p:cNvSpPr txBox="1"/>
-          <p:nvPr/>
-        </p:nvSpPr>
-        <p:spPr>
-          <a:xfrm>
-            <a:off x="448056" y="3355848"/>
-            <a:ext cx="3273552" cy="219456"/>
+          <p:cNvPr id="50" name="TextBox 49"/>
+          <p:cNvSpPr txBox="1"/>
+          <p:nvPr/>
+        </p:nvSpPr>
+        <p:spPr>
+          <a:xfrm>
+            <a:off x="448056" y="3611880"/>
+            <a:ext cx="3273552" cy="182880"/>
           </a:xfrm>
           <a:prstGeom prst="rect">
             <a:avLst/>
@@ -24659,14 +24780,14 @@
       </p:sp>
       <p:sp>
         <p:nvSpPr>
-          <p:cNvPr id="48" name="TextBox 47"/>
-          <p:cNvSpPr txBox="1"/>
-          <p:nvPr/>
-        </p:nvSpPr>
-        <p:spPr>
-          <a:xfrm>
-            <a:off x="3977640" y="3355848"/>
-            <a:ext cx="2395728" cy="219456"/>
+          <p:cNvPr id="51" name="TextBox 50"/>
+          <p:cNvSpPr txBox="1"/>
+          <p:nvPr/>
+        </p:nvSpPr>
+        <p:spPr>
+          <a:xfrm>
+            <a:off x="3977640" y="3611880"/>
+            <a:ext cx="2395728" cy="182880"/>
           </a:xfrm>
           <a:prstGeom prst="rect">
             <a:avLst/>
@@ -24687,21 +24808,21 @@
                 </a:solidFill>
                 <a:latin typeface="Arial"/>
               </a:rPr>
-              <a:t>&lt; Php 25</a:t>
-            </a:r>
-          </a:p>
-        </p:txBody>
-      </p:sp>
-      <p:sp>
-        <p:nvSpPr>
-          <p:cNvPr id="49" name="TextBox 48"/>
-          <p:cNvSpPr txBox="1"/>
-          <p:nvPr/>
-        </p:nvSpPr>
-        <p:spPr>
-          <a:xfrm>
-            <a:off x="6629400" y="3355848"/>
-            <a:ext cx="2395728" cy="219456"/>
+              <a:t>Php 35–90</a:t>
+            </a:r>
+          </a:p>
+        </p:txBody>
+      </p:sp>
+      <p:sp>
+        <p:nvSpPr>
+          <p:cNvPr id="52" name="TextBox 51"/>
+          <p:cNvSpPr txBox="1"/>
+          <p:nvPr/>
+        </p:nvSpPr>
+        <p:spPr>
+          <a:xfrm>
+            <a:off x="6629400" y="3611880"/>
+            <a:ext cx="2395728" cy="182880"/>
           </a:xfrm>
           <a:prstGeom prst="rect">
             <a:avLst/>
@@ -24722,21 +24843,21 @@
                 </a:solidFill>
                 <a:latin typeface="Arial"/>
               </a:rPr>
-              <a:t>&lt; Php 25</a:t>
-            </a:r>
-          </a:p>
-        </p:txBody>
-      </p:sp>
-      <p:sp>
-        <p:nvSpPr>
-          <p:cNvPr id="50" name="TextBox 49"/>
-          <p:cNvSpPr txBox="1"/>
-          <p:nvPr/>
-        </p:nvSpPr>
-        <p:spPr>
-          <a:xfrm>
-            <a:off x="9281160" y="3355848"/>
-            <a:ext cx="2459736" cy="219456"/>
+              <a:t>Php 60–110</a:t>
+            </a:r>
+          </a:p>
+        </p:txBody>
+      </p:sp>
+      <p:sp>
+        <p:nvSpPr>
+          <p:cNvPr id="53" name="TextBox 52"/>
+          <p:cNvSpPr txBox="1"/>
+          <p:nvPr/>
+        </p:nvSpPr>
+        <p:spPr>
+          <a:xfrm>
+            <a:off x="9281160" y="3611880"/>
+            <a:ext cx="2459736" cy="182880"/>
           </a:xfrm>
           <a:prstGeom prst="rect">
             <a:avLst/>
@@ -24757,21 +24878,21 @@
                 </a:solidFill>
                 <a:latin typeface="Arial"/>
               </a:rPr>
-              <a:t>&lt; Php 25</a:t>
-            </a:r>
-          </a:p>
-        </p:txBody>
-      </p:sp>
-      <p:sp>
-        <p:nvSpPr>
-          <p:cNvPr id="51" name="Rectangle 50"/>
-          <p:cNvSpPr/>
-          <p:nvPr/>
-        </p:nvSpPr>
-        <p:spPr>
-          <a:xfrm>
-            <a:off x="320040" y="3630168"/>
-            <a:ext cx="3529584" cy="384048"/>
+              <a:t>Php 35–80</a:t>
+            </a:r>
+          </a:p>
+        </p:txBody>
+      </p:sp>
+      <p:sp>
+        <p:nvSpPr>
+          <p:cNvPr id="54" name="Rectangle 53"/>
+          <p:cNvSpPr/>
+          <p:nvPr/>
+        </p:nvSpPr>
+        <p:spPr>
+          <a:xfrm>
+            <a:off x="320040" y="3849624"/>
+            <a:ext cx="3529584" cy="347472"/>
           </a:xfrm>
           <a:prstGeom prst="rect">
             <a:avLst/>
@@ -24807,14 +24928,14 @@
       </p:sp>
       <p:sp>
         <p:nvSpPr>
-          <p:cNvPr id="52" name="Rectangle 51"/>
-          <p:cNvSpPr/>
-          <p:nvPr/>
-        </p:nvSpPr>
-        <p:spPr>
-          <a:xfrm>
-            <a:off x="3849624" y="3630168"/>
-            <a:ext cx="2651760" cy="384048"/>
+          <p:cNvPr id="55" name="Rectangle 54"/>
+          <p:cNvSpPr/>
+          <p:nvPr/>
+        </p:nvSpPr>
+        <p:spPr>
+          <a:xfrm>
+            <a:off x="3849624" y="3849624"/>
+            <a:ext cx="2651760" cy="347472"/>
           </a:xfrm>
           <a:prstGeom prst="rect">
             <a:avLst/>
@@ -24850,14 +24971,14 @@
       </p:sp>
       <p:sp>
         <p:nvSpPr>
-          <p:cNvPr id="53" name="Rectangle 52"/>
-          <p:cNvSpPr/>
-          <p:nvPr/>
-        </p:nvSpPr>
-        <p:spPr>
-          <a:xfrm>
-            <a:off x="6501384" y="3630168"/>
-            <a:ext cx="2651760" cy="384048"/>
+          <p:cNvPr id="56" name="Rectangle 55"/>
+          <p:cNvSpPr/>
+          <p:nvPr/>
+        </p:nvSpPr>
+        <p:spPr>
+          <a:xfrm>
+            <a:off x="6501384" y="3849624"/>
+            <a:ext cx="2651760" cy="347472"/>
           </a:xfrm>
           <a:prstGeom prst="rect">
             <a:avLst/>
@@ -24893,14 +25014,14 @@
       </p:sp>
       <p:sp>
         <p:nvSpPr>
-          <p:cNvPr id="54" name="Rectangle 53"/>
-          <p:cNvSpPr/>
-          <p:nvPr/>
-        </p:nvSpPr>
-        <p:spPr>
-          <a:xfrm>
-            <a:off x="9153144" y="3630168"/>
-            <a:ext cx="2715768" cy="384048"/>
+          <p:cNvPr id="57" name="Rectangle 56"/>
+          <p:cNvSpPr/>
+          <p:nvPr/>
+        </p:nvSpPr>
+        <p:spPr>
+          <a:xfrm>
+            <a:off x="9153144" y="3849624"/>
+            <a:ext cx="2715768" cy="347472"/>
           </a:xfrm>
           <a:prstGeom prst="rect">
             <a:avLst/>
@@ -24936,14 +25057,14 @@
       </p:sp>
       <p:sp>
         <p:nvSpPr>
-          <p:cNvPr id="55" name="Rectangle 54"/>
-          <p:cNvSpPr/>
-          <p:nvPr/>
-        </p:nvSpPr>
-        <p:spPr>
-          <a:xfrm>
-            <a:off x="320040" y="3630168"/>
-            <a:ext cx="50800" cy="384048"/>
+          <p:cNvPr id="58" name="Rectangle 57"/>
+          <p:cNvSpPr/>
+          <p:nvPr/>
+        </p:nvSpPr>
+        <p:spPr>
+          <a:xfrm>
+            <a:off x="320040" y="3849624"/>
+            <a:ext cx="50800" cy="347472"/>
           </a:xfrm>
           <a:prstGeom prst="rect">
             <a:avLst/>
@@ -24979,14 +25100,14 @@
       </p:sp>
       <p:sp>
         <p:nvSpPr>
-          <p:cNvPr id="56" name="TextBox 55"/>
-          <p:cNvSpPr txBox="1"/>
-          <p:nvPr/>
-        </p:nvSpPr>
-        <p:spPr>
-          <a:xfrm>
-            <a:off x="448056" y="3739896"/>
-            <a:ext cx="3273552" cy="219456"/>
+          <p:cNvPr id="59" name="TextBox 58"/>
+          <p:cNvSpPr txBox="1"/>
+          <p:nvPr/>
+        </p:nvSpPr>
+        <p:spPr>
+          <a:xfrm>
+            <a:off x="448056" y="3959352"/>
+            <a:ext cx="3273552" cy="182880"/>
           </a:xfrm>
           <a:prstGeom prst="rect">
             <a:avLst/>
@@ -25007,21 +25128,21 @@
                 </a:solidFill>
                 <a:latin typeface="Arial"/>
               </a:rPr>
-              <a:t>Watch completion rate</a:t>
-            </a:r>
-          </a:p>
-        </p:txBody>
-      </p:sp>
-      <p:sp>
-        <p:nvSpPr>
-          <p:cNvPr id="57" name="TextBox 56"/>
-          <p:cNvSpPr txBox="1"/>
-          <p:nvPr/>
-        </p:nvSpPr>
-        <p:spPr>
-          <a:xfrm>
-            <a:off x="3977640" y="3739896"/>
-            <a:ext cx="2395728" cy="219456"/>
+              <a:t>Watch completion (W1)</a:t>
+            </a:r>
+          </a:p>
+        </p:txBody>
+      </p:sp>
+      <p:sp>
+        <p:nvSpPr>
+          <p:cNvPr id="60" name="TextBox 59"/>
+          <p:cNvSpPr txBox="1"/>
+          <p:nvPr/>
+        </p:nvSpPr>
+        <p:spPr>
+          <a:xfrm>
+            <a:off x="3977640" y="3959352"/>
+            <a:ext cx="2395728" cy="182880"/>
           </a:xfrm>
           <a:prstGeom prst="rect">
             <a:avLst/>
@@ -25042,21 +25163,21 @@
                 </a:solidFill>
                 <a:latin typeface="Arial"/>
               </a:rPr>
-              <a:t>&gt; 35%</a:t>
-            </a:r>
-          </a:p>
-        </p:txBody>
-      </p:sp>
-      <p:sp>
-        <p:nvSpPr>
-          <p:cNvPr id="58" name="TextBox 57"/>
-          <p:cNvSpPr txBox="1"/>
-          <p:nvPr/>
-        </p:nvSpPr>
-        <p:spPr>
-          <a:xfrm>
-            <a:off x="6629400" y="3739896"/>
-            <a:ext cx="2395728" cy="219456"/>
+              <a:t>15–30%</a:t>
+            </a:r>
+          </a:p>
+        </p:txBody>
+      </p:sp>
+      <p:sp>
+        <p:nvSpPr>
+          <p:cNvPr id="61" name="TextBox 60"/>
+          <p:cNvSpPr txBox="1"/>
+          <p:nvPr/>
+        </p:nvSpPr>
+        <p:spPr>
+          <a:xfrm>
+            <a:off x="6629400" y="3959352"/>
+            <a:ext cx="2395728" cy="182880"/>
           </a:xfrm>
           <a:prstGeom prst="rect">
             <a:avLst/>
@@ -25077,21 +25198,21 @@
                 </a:solidFill>
                 <a:latin typeface="Arial"/>
               </a:rPr>
-              <a:t>&gt; 30%</a:t>
-            </a:r>
-          </a:p>
-        </p:txBody>
-      </p:sp>
-      <p:sp>
-        <p:nvSpPr>
-          <p:cNvPr id="59" name="TextBox 58"/>
-          <p:cNvSpPr txBox="1"/>
-          <p:nvPr/>
-        </p:nvSpPr>
-        <p:spPr>
-          <a:xfrm>
-            <a:off x="9281160" y="3739896"/>
-            <a:ext cx="2459736" cy="219456"/>
+              <a:t>20–35%</a:t>
+            </a:r>
+          </a:p>
+        </p:txBody>
+      </p:sp>
+      <p:sp>
+        <p:nvSpPr>
+          <p:cNvPr id="62" name="TextBox 61"/>
+          <p:cNvSpPr txBox="1"/>
+          <p:nvPr/>
+        </p:nvSpPr>
+        <p:spPr>
+          <a:xfrm>
+            <a:off x="9281160" y="3959352"/>
+            <a:ext cx="2459736" cy="182880"/>
           </a:xfrm>
           <a:prstGeom prst="rect">
             <a:avLst/>
@@ -25119,14 +25240,14 @@
       </p:sp>
       <p:sp>
         <p:nvSpPr>
-          <p:cNvPr id="60" name="Rectangle 59"/>
-          <p:cNvSpPr/>
-          <p:nvPr/>
-        </p:nvSpPr>
-        <p:spPr>
-          <a:xfrm>
-            <a:off x="320040" y="4014216"/>
-            <a:ext cx="3529584" cy="384048"/>
+          <p:cNvPr id="63" name="Rectangle 62"/>
+          <p:cNvSpPr/>
+          <p:nvPr/>
+        </p:nvSpPr>
+        <p:spPr>
+          <a:xfrm>
+            <a:off x="320040" y="4197096"/>
+            <a:ext cx="3529584" cy="347472"/>
           </a:xfrm>
           <a:prstGeom prst="rect">
             <a:avLst/>
@@ -25162,14 +25283,14 @@
       </p:sp>
       <p:sp>
         <p:nvSpPr>
-          <p:cNvPr id="61" name="Rectangle 60"/>
-          <p:cNvSpPr/>
-          <p:nvPr/>
-        </p:nvSpPr>
-        <p:spPr>
-          <a:xfrm>
-            <a:off x="3849624" y="4014216"/>
-            <a:ext cx="2651760" cy="384048"/>
+          <p:cNvPr id="64" name="Rectangle 63"/>
+          <p:cNvSpPr/>
+          <p:nvPr/>
+        </p:nvSpPr>
+        <p:spPr>
+          <a:xfrm>
+            <a:off x="3849624" y="4197096"/>
+            <a:ext cx="2651760" cy="347472"/>
           </a:xfrm>
           <a:prstGeom prst="rect">
             <a:avLst/>
@@ -25205,14 +25326,14 @@
       </p:sp>
       <p:sp>
         <p:nvSpPr>
-          <p:cNvPr id="62" name="Rectangle 61"/>
-          <p:cNvSpPr/>
-          <p:nvPr/>
-        </p:nvSpPr>
-        <p:spPr>
-          <a:xfrm>
-            <a:off x="6501384" y="4014216"/>
-            <a:ext cx="2651760" cy="384048"/>
+          <p:cNvPr id="65" name="Rectangle 64"/>
+          <p:cNvSpPr/>
+          <p:nvPr/>
+        </p:nvSpPr>
+        <p:spPr>
+          <a:xfrm>
+            <a:off x="6501384" y="4197096"/>
+            <a:ext cx="2651760" cy="347472"/>
           </a:xfrm>
           <a:prstGeom prst="rect">
             <a:avLst/>
@@ -25248,14 +25369,14 @@
       </p:sp>
       <p:sp>
         <p:nvSpPr>
-          <p:cNvPr id="63" name="Rectangle 62"/>
-          <p:cNvSpPr/>
-          <p:nvPr/>
-        </p:nvSpPr>
-        <p:spPr>
-          <a:xfrm>
-            <a:off x="9153144" y="4014216"/>
-            <a:ext cx="2715768" cy="384048"/>
+          <p:cNvPr id="66" name="Rectangle 65"/>
+          <p:cNvSpPr/>
+          <p:nvPr/>
+        </p:nvSpPr>
+        <p:spPr>
+          <a:xfrm>
+            <a:off x="9153144" y="4197096"/>
+            <a:ext cx="2715768" cy="347472"/>
           </a:xfrm>
           <a:prstGeom prst="rect">
             <a:avLst/>
@@ -25291,14 +25412,14 @@
       </p:sp>
       <p:sp>
         <p:nvSpPr>
-          <p:cNvPr id="64" name="Rectangle 63"/>
-          <p:cNvSpPr/>
-          <p:nvPr/>
-        </p:nvSpPr>
-        <p:spPr>
-          <a:xfrm>
-            <a:off x="320040" y="4014216"/>
-            <a:ext cx="50800" cy="384048"/>
+          <p:cNvPr id="67" name="Rectangle 66"/>
+          <p:cNvSpPr/>
+          <p:nvPr/>
+        </p:nvSpPr>
+        <p:spPr>
+          <a:xfrm>
+            <a:off x="320040" y="4197096"/>
+            <a:ext cx="50800" cy="347472"/>
           </a:xfrm>
           <a:prstGeom prst="rect">
             <a:avLst/>
@@ -25334,14 +25455,14 @@
       </p:sp>
       <p:sp>
         <p:nvSpPr>
-          <p:cNvPr id="65" name="TextBox 64"/>
-          <p:cNvSpPr txBox="1"/>
-          <p:nvPr/>
-        </p:nvSpPr>
-        <p:spPr>
-          <a:xfrm>
-            <a:off x="448056" y="4123944"/>
-            <a:ext cx="3273552" cy="219456"/>
+          <p:cNvPr id="68" name="TextBox 67"/>
+          <p:cNvSpPr txBox="1"/>
+          <p:nvPr/>
+        </p:nvSpPr>
+        <p:spPr>
+          <a:xfrm>
+            <a:off x="448056" y="4306824"/>
+            <a:ext cx="3273552" cy="182880"/>
           </a:xfrm>
           <a:prstGeom prst="rect">
             <a:avLst/>
@@ -25362,21 +25483,21 @@
                 </a:solidFill>
                 <a:latin typeface="Arial"/>
               </a:rPr>
-              <a:t>W3 scale target (CPF)</a:t>
-            </a:r>
-          </a:p>
-        </p:txBody>
-      </p:sp>
-      <p:sp>
-        <p:nvSpPr>
-          <p:cNvPr id="66" name="TextBox 65"/>
-          <p:cNvSpPr txBox="1"/>
-          <p:nvPr/>
-        </p:nvSpPr>
-        <p:spPr>
-          <a:xfrm>
-            <a:off x="3977640" y="4123944"/>
-            <a:ext cx="2395728" cy="219456"/>
+              <a:t>W3 CPF target (goal)</a:t>
+            </a:r>
+          </a:p>
+        </p:txBody>
+      </p:sp>
+      <p:sp>
+        <p:nvSpPr>
+          <p:cNvPr id="69" name="TextBox 68"/>
+          <p:cNvSpPr txBox="1"/>
+          <p:nvPr/>
+        </p:nvSpPr>
+        <p:spPr>
+          <a:xfrm>
+            <a:off x="3977640" y="4306824"/>
+            <a:ext cx="2395728" cy="182880"/>
           </a:xfrm>
           <a:prstGeom prst="rect">
             <a:avLst/>
@@ -25397,21 +25518,21 @@
                 </a:solidFill>
                 <a:latin typeface="Arial"/>
               </a:rPr>
-              <a:t>&lt; Php 15</a:t>
-            </a:r>
-          </a:p>
-        </p:txBody>
-      </p:sp>
-      <p:sp>
-        <p:nvSpPr>
-          <p:cNvPr id="67" name="TextBox 66"/>
-          <p:cNvSpPr txBox="1"/>
-          <p:nvPr/>
-        </p:nvSpPr>
-        <p:spPr>
-          <a:xfrm>
-            <a:off x="6629400" y="4123944"/>
-            <a:ext cx="2395728" cy="219456"/>
+              <a:t>&lt; Php 45</a:t>
+            </a:r>
+          </a:p>
+        </p:txBody>
+      </p:sp>
+      <p:sp>
+        <p:nvSpPr>
+          <p:cNvPr id="70" name="TextBox 69"/>
+          <p:cNvSpPr txBox="1"/>
+          <p:nvPr/>
+        </p:nvSpPr>
+        <p:spPr>
+          <a:xfrm>
+            <a:off x="6629400" y="4306824"/>
+            <a:ext cx="2395728" cy="182880"/>
           </a:xfrm>
           <a:prstGeom prst="rect">
             <a:avLst/>
@@ -25432,21 +25553,21 @@
                 </a:solidFill>
                 <a:latin typeface="Arial"/>
               </a:rPr>
-              <a:t>&lt; Php 15</a:t>
-            </a:r>
-          </a:p>
-        </p:txBody>
-      </p:sp>
-      <p:sp>
-        <p:nvSpPr>
-          <p:cNvPr id="68" name="TextBox 67"/>
-          <p:cNvSpPr txBox="1"/>
-          <p:nvPr/>
-        </p:nvSpPr>
-        <p:spPr>
-          <a:xfrm>
-            <a:off x="9281160" y="4123944"/>
-            <a:ext cx="2459736" cy="219456"/>
+              <a:t>&lt; Php 65</a:t>
+            </a:r>
+          </a:p>
+        </p:txBody>
+      </p:sp>
+      <p:sp>
+        <p:nvSpPr>
+          <p:cNvPr id="71" name="TextBox 70"/>
+          <p:cNvSpPr txBox="1"/>
+          <p:nvPr/>
+        </p:nvSpPr>
+        <p:spPr>
+          <a:xfrm>
+            <a:off x="9281160" y="4306824"/>
+            <a:ext cx="2459736" cy="182880"/>
           </a:xfrm>
           <a:prstGeom prst="rect">
             <a:avLst/>
@@ -25467,21 +25588,21 @@
                 </a:solidFill>
                 <a:latin typeface="Arial"/>
               </a:rPr>
-              <a:t>&lt; Php 15</a:t>
-            </a:r>
-          </a:p>
-        </p:txBody>
-      </p:sp>
-      <p:sp>
-        <p:nvSpPr>
-          <p:cNvPr id="69" name="Rectangle 68"/>
-          <p:cNvSpPr/>
-          <p:nvPr/>
-        </p:nvSpPr>
-        <p:spPr>
-          <a:xfrm>
-            <a:off x="320040" y="4526280"/>
-            <a:ext cx="11548872" cy="329184"/>
+              <a:t>&lt; Php 55</a:t>
+            </a:r>
+          </a:p>
+        </p:txBody>
+      </p:sp>
+      <p:sp>
+        <p:nvSpPr>
+          <p:cNvPr id="72" name="Rectangle 71"/>
+          <p:cNvSpPr/>
+          <p:nvPr/>
+        </p:nvSpPr>
+        <p:spPr>
+          <a:xfrm>
+            <a:off x="320040" y="4654296"/>
+            <a:ext cx="11548872" cy="310896"/>
           </a:xfrm>
           <a:prstGeom prst="rect">
             <a:avLst/>
@@ -25517,14 +25638,14 @@
       </p:sp>
       <p:sp>
         <p:nvSpPr>
-          <p:cNvPr id="70" name="Rectangle 69"/>
-          <p:cNvSpPr/>
-          <p:nvPr/>
-        </p:nvSpPr>
-        <p:spPr>
-          <a:xfrm>
-            <a:off x="320040" y="4526280"/>
-            <a:ext cx="63500" cy="329184"/>
+          <p:cNvPr id="73" name="Rectangle 72"/>
+          <p:cNvSpPr/>
+          <p:nvPr/>
+        </p:nvSpPr>
+        <p:spPr>
+          <a:xfrm>
+            <a:off x="320040" y="4654296"/>
+            <a:ext cx="63500" cy="310896"/>
           </a:xfrm>
           <a:prstGeom prst="rect">
             <a:avLst/>
@@ -25560,13 +25681,13 @@
       </p:sp>
       <p:sp>
         <p:nvSpPr>
-          <p:cNvPr id="71" name="TextBox 70"/>
-          <p:cNvSpPr txBox="1"/>
-          <p:nvPr/>
-        </p:nvSpPr>
-        <p:spPr>
-          <a:xfrm>
-            <a:off x="448056" y="4599432"/>
+          <p:cNvPr id="74" name="TextBox 73"/>
+          <p:cNvSpPr txBox="1"/>
+          <p:nvPr/>
+        </p:nvSpPr>
+        <p:spPr>
+          <a:xfrm>
+            <a:off x="448056" y="4718304"/>
             <a:ext cx="11292840" cy="219456"/>
           </a:xfrm>
           <a:prstGeom prst="rect">
@@ -25595,13 +25716,13 @@
       </p:sp>
       <p:sp>
         <p:nvSpPr>
-          <p:cNvPr id="72" name="Rectangle 71"/>
-          <p:cNvSpPr/>
-          <p:nvPr/>
-        </p:nvSpPr>
-        <p:spPr>
-          <a:xfrm>
-            <a:off x="320040" y="4946904"/>
+          <p:cNvPr id="75" name="Rectangle 74"/>
+          <p:cNvSpPr/>
+          <p:nvPr/>
+        </p:nvSpPr>
+        <p:spPr>
+          <a:xfrm>
+            <a:off x="320040" y="5056632"/>
             <a:ext cx="11548872" cy="256032"/>
           </a:xfrm>
           <a:prstGeom prst="rect">
@@ -25638,13 +25759,13 @@
       </p:sp>
       <p:sp>
         <p:nvSpPr>
-          <p:cNvPr id="73" name="Rectangle 72"/>
-          <p:cNvSpPr/>
-          <p:nvPr/>
-        </p:nvSpPr>
-        <p:spPr>
-          <a:xfrm>
-            <a:off x="320040" y="4946904"/>
+          <p:cNvPr id="76" name="Rectangle 75"/>
+          <p:cNvSpPr/>
+          <p:nvPr/>
+        </p:nvSpPr>
+        <p:spPr>
+          <a:xfrm>
+            <a:off x="320040" y="5056632"/>
             <a:ext cx="63500" cy="256032"/>
           </a:xfrm>
           <a:prstGeom prst="rect">
@@ -25681,13 +25802,13 @@
       </p:sp>
       <p:sp>
         <p:nvSpPr>
-          <p:cNvPr id="74" name="TextBox 73"/>
-          <p:cNvSpPr txBox="1"/>
-          <p:nvPr/>
-        </p:nvSpPr>
-        <p:spPr>
-          <a:xfrm>
-            <a:off x="448056" y="5001768"/>
+          <p:cNvPr id="77" name="TextBox 76"/>
+          <p:cNvSpPr txBox="1"/>
+          <p:nvPr/>
+        </p:nvSpPr>
+        <p:spPr>
+          <a:xfrm>
+            <a:off x="448056" y="5111496"/>
             <a:ext cx="3657600" cy="182880"/>
           </a:xfrm>
           <a:prstGeom prst="rect">
@@ -25716,13 +25837,13 @@
       </p:sp>
       <p:sp>
         <p:nvSpPr>
-          <p:cNvPr id="75" name="Rectangle 74"/>
-          <p:cNvSpPr/>
-          <p:nvPr/>
-        </p:nvSpPr>
-        <p:spPr>
-          <a:xfrm>
-            <a:off x="320040" y="5202936"/>
+          <p:cNvPr id="78" name="Rectangle 77"/>
+          <p:cNvSpPr/>
+          <p:nvPr/>
+        </p:nvSpPr>
+        <p:spPr>
+          <a:xfrm>
+            <a:off x="320040" y="5312664"/>
             <a:ext cx="11548872" cy="237744"/>
           </a:xfrm>
           <a:prstGeom prst="rect">
@@ -25759,13 +25880,13 @@
       </p:sp>
       <p:sp>
         <p:nvSpPr>
-          <p:cNvPr id="76" name="TextBox 75"/>
-          <p:cNvSpPr txBox="1"/>
-          <p:nvPr/>
-        </p:nvSpPr>
-        <p:spPr>
-          <a:xfrm>
-            <a:off x="448056" y="5266944"/>
+          <p:cNvPr id="79" name="TextBox 78"/>
+          <p:cNvSpPr txBox="1"/>
+          <p:nvPr/>
+        </p:nvSpPr>
+        <p:spPr>
+          <a:xfrm>
+            <a:off x="448056" y="5376672"/>
             <a:ext cx="11292840" cy="201168"/>
           </a:xfrm>
           <a:prstGeom prst="rect">
@@ -25794,13 +25915,13 @@
       </p:sp>
       <p:sp>
         <p:nvSpPr>
-          <p:cNvPr id="77" name="Rectangle 76"/>
-          <p:cNvSpPr/>
-          <p:nvPr/>
-        </p:nvSpPr>
-        <p:spPr>
-          <a:xfrm>
-            <a:off x="320040" y="5458968"/>
+          <p:cNvPr id="80" name="Rectangle 79"/>
+          <p:cNvSpPr/>
+          <p:nvPr/>
+        </p:nvSpPr>
+        <p:spPr>
+          <a:xfrm>
+            <a:off x="320040" y="5568696"/>
             <a:ext cx="11548872" cy="237744"/>
           </a:xfrm>
           <a:prstGeom prst="rect">
@@ -25837,13 +25958,13 @@
       </p:sp>
       <p:sp>
         <p:nvSpPr>
-          <p:cNvPr id="78" name="TextBox 77"/>
-          <p:cNvSpPr txBox="1"/>
-          <p:nvPr/>
-        </p:nvSpPr>
-        <p:spPr>
-          <a:xfrm>
-            <a:off x="448056" y="5522976"/>
+          <p:cNvPr id="81" name="TextBox 80"/>
+          <p:cNvSpPr txBox="1"/>
+          <p:nvPr/>
+        </p:nvSpPr>
+        <p:spPr>
+          <a:xfrm>
+            <a:off x="448056" y="5632704"/>
             <a:ext cx="11292840" cy="201168"/>
           </a:xfrm>
           <a:prstGeom prst="rect">
@@ -25872,13 +25993,13 @@
       </p:sp>
       <p:sp>
         <p:nvSpPr>
-          <p:cNvPr id="79" name="Rectangle 78"/>
-          <p:cNvSpPr/>
-          <p:nvPr/>
-        </p:nvSpPr>
-        <p:spPr>
-          <a:xfrm>
-            <a:off x="320040" y="5715000"/>
+          <p:cNvPr id="82" name="Rectangle 81"/>
+          <p:cNvSpPr/>
+          <p:nvPr/>
+        </p:nvSpPr>
+        <p:spPr>
+          <a:xfrm>
+            <a:off x="320040" y="5824728"/>
             <a:ext cx="11548872" cy="237744"/>
           </a:xfrm>
           <a:prstGeom prst="rect">
@@ -25915,13 +26036,13 @@
       </p:sp>
       <p:sp>
         <p:nvSpPr>
-          <p:cNvPr id="80" name="TextBox 79"/>
-          <p:cNvSpPr txBox="1"/>
-          <p:nvPr/>
-        </p:nvSpPr>
-        <p:spPr>
-          <a:xfrm>
-            <a:off x="448056" y="5779008"/>
+          <p:cNvPr id="83" name="TextBox 82"/>
+          <p:cNvSpPr txBox="1"/>
+          <p:nvPr/>
+        </p:nvSpPr>
+        <p:spPr>
+          <a:xfrm>
+            <a:off x="448056" y="5888736"/>
             <a:ext cx="11292840" cy="201168"/>
           </a:xfrm>
           <a:prstGeom prst="rect">
@@ -25950,13 +26071,13 @@
       </p:sp>
       <p:sp>
         <p:nvSpPr>
-          <p:cNvPr id="81" name="Rectangle 80"/>
-          <p:cNvSpPr/>
-          <p:nvPr/>
-        </p:nvSpPr>
-        <p:spPr>
-          <a:xfrm>
-            <a:off x="320040" y="5971032"/>
+          <p:cNvPr id="84" name="Rectangle 83"/>
+          <p:cNvSpPr/>
+          <p:nvPr/>
+        </p:nvSpPr>
+        <p:spPr>
+          <a:xfrm>
+            <a:off x="320040" y="6080760"/>
             <a:ext cx="11548872" cy="237744"/>
           </a:xfrm>
           <a:prstGeom prst="rect">
@@ -25993,13 +26114,13 @@
       </p:sp>
       <p:sp>
         <p:nvSpPr>
-          <p:cNvPr id="82" name="TextBox 81"/>
-          <p:cNvSpPr txBox="1"/>
-          <p:nvPr/>
-        </p:nvSpPr>
-        <p:spPr>
-          <a:xfrm>
-            <a:off x="448056" y="6035040"/>
+          <p:cNvPr id="85" name="TextBox 84"/>
+          <p:cNvSpPr txBox="1"/>
+          <p:nvPr/>
+        </p:nvSpPr>
+        <p:spPr>
+          <a:xfrm>
+            <a:off x="448056" y="6144768"/>
             <a:ext cx="11292840" cy="201168"/>
           </a:xfrm>
           <a:prstGeom prst="rect">
@@ -26028,7 +26149,7 @@
       </p:sp>
       <p:sp>
         <p:nvSpPr>
-          <p:cNvPr id="83" name="Rectangle 82"/>
+          <p:cNvPr id="86" name="Rectangle 85"/>
           <p:cNvSpPr/>
           <p:nvPr/>
         </p:nvSpPr>
@@ -26071,7 +26192,7 @@
       </p:sp>
       <p:sp>
         <p:nvSpPr>
-          <p:cNvPr id="84" name="TextBox 83"/>
+          <p:cNvPr id="87" name="TextBox 86"/>
           <p:cNvSpPr txBox="1"/>
           <p:nvPr/>
         </p:nvSpPr>
@@ -26106,7 +26227,7 @@
       </p:sp>
       <p:sp>
         <p:nvSpPr>
-          <p:cNvPr id="85" name="TextBox 84"/>
+          <p:cNvPr id="88" name="TextBox 87"/>
           <p:cNvSpPr txBox="1"/>
           <p:nvPr/>
         </p:nvSpPr>

</xml_diff>

<commit_message>
fix: clarify boost ramp is budget-only — posting continues all platforms weekly
PPTX/PDF: 'TikTok only' → 'Boost: TikTok', 'TikTok + Instagram' → 'Boost: TikTok + IG', etc.
Slide 3 descriptions now state 'Post organically to all platforms. Boost X only.'
niche-and-growth-plan.md: added explicit note before ramp table.

Co-Authored-By: Claude Sonnet 4.6 <noreply@anthropic.com>
</commit_message>
<xml_diff>
--- a/content/strategy/TitoAI-ContentBoostPlan-W26-W28.pptx
+++ b/content/strategy/TitoAI-ContentBoostPlan-W26-W28.pptx
@@ -3559,7 +3559,7 @@
                 </a:solidFill>
                 <a:latin typeface="Arial"/>
               </a:rPr>
-              <a:t>TikTok only</a:t>
+              <a:t>Boost: TikTok only</a:t>
             </a:r>
           </a:p>
         </p:txBody>
@@ -3750,7 +3750,7 @@
                 </a:solidFill>
                 <a:latin typeface="Arial"/>
               </a:rPr>
-              <a:t>TikTok + Instagram</a:t>
+              <a:t>Boost: TikTok + IG</a:t>
             </a:r>
           </a:p>
         </p:txBody>
@@ -3941,7 +3941,7 @@
                 </a:solidFill>
                 <a:latin typeface="Arial"/>
               </a:rPr>
-              <a:t>All 3 platforms</a:t>
+              <a:t>Boost: All 3 platforms</a:t>
             </a:r>
           </a:p>
         </p:txBody>
@@ -5860,7 +5860,7 @@
                 </a:solidFill>
                 <a:latin typeface="Arial"/>
               </a:rPr>
-              <a:t>Php 2,000/week  ·  3 posts/week  ·  progressive platform ramp  ·  launch Jun 22</a:t>
+              <a:t>Post all platforms every week  ·  boost budget ramps progressively  ·  Php 2,000/week  ·  launch Jun 22</a:t>
             </a:r>
           </a:p>
         </p:txBody>
@@ -6137,7 +6137,7 @@
                 </a:solidFill>
                 <a:latin typeface="Arial"/>
               </a:rPr>
-              <a:t>TikTok Only</a:t>
+              <a:t>Boost: TikTok</a:t>
             </a:r>
           </a:p>
         </p:txBody>
@@ -6449,7 +6449,7 @@
                 </a:solidFill>
                 <a:latin typeface="Arial"/>
               </a:rPr>
-              <a:t>Learn TikTok Promote mechanics. Establish baseline cost-per-view and cost-per-follow before adding more platforms.</a:t>
+              <a:t>Post organically to all platforms. Boost TikTok only — learn Promote mechanics and establish baseline CPV + CPF.</a:t>
             </a:r>
           </a:p>
         </p:txBody>
@@ -6761,7 +6761,7 @@
                 </a:solidFill>
                 <a:latin typeface="Arial"/>
               </a:rPr>
-              <a:t>TikTok + Instagram</a:t>
+              <a:t>Boost: TikTok + IG</a:t>
             </a:r>
           </a:p>
         </p:txBody>
@@ -7073,7 +7073,7 @@
                 </a:solidFill>
                 <a:latin typeface="Arial"/>
               </a:rPr>
-              <a:t>Add Instagram Boost. Compare cost-per-follow across two platforms using real W26 data to decide budget split.</a:t>
+              <a:t>Post organically to all platforms. Add Instagram Boost using W26 data to decide budget split.</a:t>
             </a:r>
           </a:p>
         </p:txBody>
@@ -7385,7 +7385,7 @@
                 </a:solidFill>
                 <a:latin typeface="Arial"/>
               </a:rPr>
-              <a:t>All 3 Platforms</a:t>
+              <a:t>Boost: All 3</a:t>
             </a:r>
           </a:p>
         </p:txBody>
@@ -7697,7 +7697,7 @@
                 </a:solidFill>
                 <a:latin typeface="Arial"/>
               </a:rPr>
-              <a:t>Full push across TikTok, Instagram, and Facebook. ⚠️ Facebook Page required before this week.</a:t>
+              <a:t>Post organically to all platforms. Full boost across TikTok, IG, and Facebook. ⚠️ FB Page required.</a:t>
             </a:r>
           </a:p>
         </p:txBody>
@@ -12509,7 +12509,7 @@
                 </a:solidFill>
                 <a:latin typeface="Arial"/>
               </a:rPr>
-              <a:t>Week 1 — W26  ·  Jun 22–28  ·  TikTok Only</a:t>
+              <a:t>Week 1 — W26  ·  Jun 22–28  ·  Boost: TikTok</a:t>
             </a:r>
           </a:p>
         </p:txBody>
@@ -12544,7 +12544,7 @@
                 </a:solidFill>
                 <a:latin typeface="Arial"/>
               </a:rPr>
-              <a:t>Learn TikTok Promote mechanics · establish baseline CPV + CPF · Php 2,000</a:t>
+              <a:t>Post all platforms · boost TikTok only · learn Promote mechanics · establish baseline CPV + CPF · Php 2,000</a:t>
             </a:r>
           </a:p>
         </p:txBody>
@@ -15421,7 +15421,7 @@
                 </a:solidFill>
                 <a:latin typeface="Arial"/>
               </a:rPr>
-              <a:t>Week 2 — W27  ·  Jun 29–Jul 5  ·  TikTok + Instagram</a:t>
+              <a:t>Week 2 — W27  ·  Jun 29–Jul 5  ·  Boost: TikTok + IG</a:t>
             </a:r>
           </a:p>
         </p:txBody>
@@ -15456,7 +15456,7 @@
                 </a:solidFill>
                 <a:latin typeface="Arial"/>
               </a:rPr>
-              <a:t>Apply W26 learnings · add Instagram Boost · compare cost-per-follow · Php 2,000</a:t>
+              <a:t>Post all platforms · add Instagram Boost · compare cost-per-follow using W26 data · Php 2,000</a:t>
             </a:r>
           </a:p>
         </p:txBody>
@@ -18575,7 +18575,7 @@
                 </a:solidFill>
                 <a:latin typeface="Arial"/>
               </a:rPr>
-              <a:t>Week 3 — W28  ·  Jul 6–12  ·  All 3 Platforms</a:t>
+              <a:t>Week 3 — W28  ·  Jul 6–12  ·  Boost: All 3 Platforms</a:t>
             </a:r>
           </a:p>
         </p:txBody>
@@ -18610,7 +18610,7 @@
                 </a:solidFill>
                 <a:latin typeface="Arial"/>
               </a:rPr>
-              <a:t>Full push · compare CPF across platforms · decide July budget · FB Page required</a:t>
+              <a:t>Post all platforms · full boost push · compare CPF · decide July budget · FB Page required</a:t>
             </a:r>
           </a:p>
         </p:txBody>

</xml_diff>

<commit_message>
chore: add finished carousels W24/W25, brand fonts, updated boost plan PPTX
Co-Authored-By: Claude Sonnet 4.6 <noreply@anthropic.com>
</commit_message>
<xml_diff>
--- a/content/strategy/TitoAI-ContentBoostPlan-W26-W28.pptx
+++ b/content/strategy/TitoAI-ContentBoostPlan-W26-W28.pptx
@@ -5,17 +5,17 @@
     <p:sldMasterId id="2147483648" r:id="rId1"/>
   </p:sldMasterIdLst>
   <p:sldIdLst>
-    <p:sldId id="256" r:id="rId7"/>
-    <p:sldId id="257" r:id="rId8"/>
-    <p:sldId id="258" r:id="rId9"/>
-    <p:sldId id="259" r:id="rId10"/>
-    <p:sldId id="260" r:id="rId11"/>
-    <p:sldId id="261" r:id="rId12"/>
-    <p:sldId id="262" r:id="rId13"/>
-    <p:sldId id="263" r:id="rId14"/>
-    <p:sldId id="264" r:id="rId15"/>
+    <p:sldId id="256" r:id="rId2"/>
+    <p:sldId id="257" r:id="rId3"/>
+    <p:sldId id="258" r:id="rId4"/>
+    <p:sldId id="259" r:id="rId5"/>
+    <p:sldId id="260" r:id="rId6"/>
+    <p:sldId id="261" r:id="rId7"/>
+    <p:sldId id="262" r:id="rId8"/>
+    <p:sldId id="263" r:id="rId9"/>
+    <p:sldId id="264" r:id="rId10"/>
   </p:sldIdLst>
-  <p:sldSz cx="12188952" cy="6858000" type="screen4x3"/>
+  <p:sldSz cx="12188825" cy="6858000"/>
   <p:notesSz cx="6858000" cy="9144000"/>
   <p:defaultTextStyle>
     <a:defPPr>
@@ -112,6 +112,22 @@
       </a:defRPr>
     </a:lvl9pPr>
   </p:defaultTextStyle>
+  <p:extLst>
+    <p:ext uri="{EFAFB233-063F-42B5-8137-9DF3F51BA10A}">
+      <p15:sldGuideLst xmlns:p15="http://schemas.microsoft.com/office/powerpoint/2012/main">
+        <p15:guide id="1" orient="horz" pos="2160">
+          <p15:clr>
+            <a:srgbClr val="A4A3A4"/>
+          </p15:clr>
+        </p15:guide>
+        <p15:guide id="2" pos="2880">
+          <p15:clr>
+            <a:srgbClr val="A4A3A4"/>
+          </p15:clr>
+        </p15:guide>
+      </p15:sldGuideLst>
+    </p:ext>
+  </p:extLst>
 </p:presentation>
 </file>
 
@@ -153,10 +169,9 @@
           <a:lstStyle/>
           <a:p>
             <a:r>
-              <a:rPr lang="en-US" smtClean="0"/>
+              <a:rPr lang="en-US"/>
               <a:t>Click to edit Master title style</a:t>
             </a:r>
-            <a:endParaRPr lang="en-US"/>
           </a:p>
         </p:txBody>
       </p:sp>
@@ -272,10 +287,9 @@
           </a:lstStyle>
           <a:p>
             <a:r>
-              <a:rPr lang="en-US" smtClean="0"/>
+              <a:rPr lang="en-US"/>
               <a:t>Click to edit Master subtitle style</a:t>
             </a:r>
-            <a:endParaRPr lang="en-US"/>
           </a:p>
         </p:txBody>
       </p:sp>
@@ -296,7 +310,7 @@
           <a:p>
             <a:fld id="{5BCAD085-E8A6-8845-BD4E-CB4CCA059FC4}" type="datetimeFigureOut">
               <a:rPr lang="en-US" smtClean="0"/>
-              <a:t>1/27/13</a:t>
+              <a:t>6/18/26</a:t>
             </a:fld>
             <a:endParaRPr lang="en-US"/>
           </a:p>
@@ -390,10 +404,9 @@
           <a:lstStyle/>
           <a:p>
             <a:r>
-              <a:rPr lang="en-US" smtClean="0"/>
+              <a:rPr lang="en-US"/>
               <a:t>Click to edit Master title style</a:t>
             </a:r>
-            <a:endParaRPr lang="en-US"/>
           </a:p>
         </p:txBody>
       </p:sp>
@@ -414,38 +427,37 @@
           <a:p>
             <a:pPr lvl="0"/>
             <a:r>
-              <a:rPr lang="en-US" smtClean="0"/>
+              <a:rPr lang="en-US"/>
               <a:t>Click to edit Master text styles</a:t>
             </a:r>
           </a:p>
           <a:p>
             <a:pPr lvl="1"/>
             <a:r>
-              <a:rPr lang="en-US" smtClean="0"/>
+              <a:rPr lang="en-US"/>
               <a:t>Second level</a:t>
             </a:r>
           </a:p>
           <a:p>
             <a:pPr lvl="2"/>
             <a:r>
-              <a:rPr lang="en-US" smtClean="0"/>
+              <a:rPr lang="en-US"/>
               <a:t>Third level</a:t>
             </a:r>
           </a:p>
           <a:p>
             <a:pPr lvl="3"/>
             <a:r>
-              <a:rPr lang="en-US" smtClean="0"/>
+              <a:rPr lang="en-US"/>
               <a:t>Fourth level</a:t>
             </a:r>
           </a:p>
           <a:p>
             <a:pPr lvl="4"/>
             <a:r>
-              <a:rPr lang="en-US" smtClean="0"/>
+              <a:rPr lang="en-US"/>
               <a:t>Fifth level</a:t>
             </a:r>
-            <a:endParaRPr lang="en-US"/>
           </a:p>
         </p:txBody>
       </p:sp>
@@ -466,7 +478,7 @@
           <a:p>
             <a:fld id="{5BCAD085-E8A6-8845-BD4E-CB4CCA059FC4}" type="datetimeFigureOut">
               <a:rPr lang="en-US" smtClean="0"/>
-              <a:t>1/27/13</a:t>
+              <a:t>6/18/26</a:t>
             </a:fld>
             <a:endParaRPr lang="en-US"/>
           </a:p>
@@ -565,10 +577,9 @@
           <a:lstStyle/>
           <a:p>
             <a:r>
-              <a:rPr lang="en-US" smtClean="0"/>
+              <a:rPr lang="en-US"/>
               <a:t>Click to edit Master title style</a:t>
             </a:r>
-            <a:endParaRPr lang="en-US"/>
           </a:p>
         </p:txBody>
       </p:sp>
@@ -594,38 +605,37 @@
           <a:p>
             <a:pPr lvl="0"/>
             <a:r>
-              <a:rPr lang="en-US" smtClean="0"/>
+              <a:rPr lang="en-US"/>
               <a:t>Click to edit Master text styles</a:t>
             </a:r>
           </a:p>
           <a:p>
             <a:pPr lvl="1"/>
             <a:r>
-              <a:rPr lang="en-US" smtClean="0"/>
+              <a:rPr lang="en-US"/>
               <a:t>Second level</a:t>
             </a:r>
           </a:p>
           <a:p>
             <a:pPr lvl="2"/>
             <a:r>
-              <a:rPr lang="en-US" smtClean="0"/>
+              <a:rPr lang="en-US"/>
               <a:t>Third level</a:t>
             </a:r>
           </a:p>
           <a:p>
             <a:pPr lvl="3"/>
             <a:r>
-              <a:rPr lang="en-US" smtClean="0"/>
+              <a:rPr lang="en-US"/>
               <a:t>Fourth level</a:t>
             </a:r>
           </a:p>
           <a:p>
             <a:pPr lvl="4"/>
             <a:r>
-              <a:rPr lang="en-US" smtClean="0"/>
+              <a:rPr lang="en-US"/>
               <a:t>Fifth level</a:t>
             </a:r>
-            <a:endParaRPr lang="en-US"/>
           </a:p>
         </p:txBody>
       </p:sp>
@@ -646,7 +656,7 @@
           <a:p>
             <a:fld id="{5BCAD085-E8A6-8845-BD4E-CB4CCA059FC4}" type="datetimeFigureOut">
               <a:rPr lang="en-US" smtClean="0"/>
-              <a:t>1/27/13</a:t>
+              <a:t>6/18/26</a:t>
             </a:fld>
             <a:endParaRPr lang="en-US"/>
           </a:p>
@@ -740,10 +750,9 @@
           <a:lstStyle/>
           <a:p>
             <a:r>
-              <a:rPr lang="en-US" smtClean="0"/>
+              <a:rPr lang="en-US"/>
               <a:t>Click to edit Master title style</a:t>
             </a:r>
-            <a:endParaRPr lang="en-US"/>
           </a:p>
         </p:txBody>
       </p:sp>
@@ -764,38 +773,37 @@
           <a:p>
             <a:pPr lvl="0"/>
             <a:r>
-              <a:rPr lang="en-US" smtClean="0"/>
+              <a:rPr lang="en-US"/>
               <a:t>Click to edit Master text styles</a:t>
             </a:r>
           </a:p>
           <a:p>
             <a:pPr lvl="1"/>
             <a:r>
-              <a:rPr lang="en-US" smtClean="0"/>
+              <a:rPr lang="en-US"/>
               <a:t>Second level</a:t>
             </a:r>
           </a:p>
           <a:p>
             <a:pPr lvl="2"/>
             <a:r>
-              <a:rPr lang="en-US" smtClean="0"/>
+              <a:rPr lang="en-US"/>
               <a:t>Third level</a:t>
             </a:r>
           </a:p>
           <a:p>
             <a:pPr lvl="3"/>
             <a:r>
-              <a:rPr lang="en-US" smtClean="0"/>
+              <a:rPr lang="en-US"/>
               <a:t>Fourth level</a:t>
             </a:r>
           </a:p>
           <a:p>
             <a:pPr lvl="4"/>
             <a:r>
-              <a:rPr lang="en-US" smtClean="0"/>
+              <a:rPr lang="en-US"/>
               <a:t>Fifth level</a:t>
             </a:r>
-            <a:endParaRPr lang="en-US"/>
           </a:p>
         </p:txBody>
       </p:sp>
@@ -816,7 +824,7 @@
           <a:p>
             <a:fld id="{5BCAD085-E8A6-8845-BD4E-CB4CCA059FC4}" type="datetimeFigureOut">
               <a:rPr lang="en-US" smtClean="0"/>
-              <a:t>1/27/13</a:t>
+              <a:t>6/18/26</a:t>
             </a:fld>
             <a:endParaRPr lang="en-US"/>
           </a:p>
@@ -919,10 +927,9 @@
           </a:lstStyle>
           <a:p>
             <a:r>
-              <a:rPr lang="en-US" smtClean="0"/>
+              <a:rPr lang="en-US"/>
               <a:t>Click to edit Master title style</a:t>
             </a:r>
-            <a:endParaRPr lang="en-US"/>
           </a:p>
         </p:txBody>
       </p:sp>
@@ -1039,7 +1046,7 @@
           <a:p>
             <a:pPr lvl="0"/>
             <a:r>
-              <a:rPr lang="en-US" smtClean="0"/>
+              <a:rPr lang="en-US"/>
               <a:t>Click to edit Master text styles</a:t>
             </a:r>
           </a:p>
@@ -1062,7 +1069,7 @@
           <a:p>
             <a:fld id="{5BCAD085-E8A6-8845-BD4E-CB4CCA059FC4}" type="datetimeFigureOut">
               <a:rPr lang="en-US" smtClean="0"/>
-              <a:t>1/27/13</a:t>
+              <a:t>6/18/26</a:t>
             </a:fld>
             <a:endParaRPr lang="en-US"/>
           </a:p>
@@ -1156,10 +1163,9 @@
           <a:lstStyle/>
           <a:p>
             <a:r>
-              <a:rPr lang="en-US" smtClean="0"/>
+              <a:rPr lang="en-US"/>
               <a:t>Click to edit Master title style</a:t>
             </a:r>
-            <a:endParaRPr lang="en-US"/>
           </a:p>
         </p:txBody>
       </p:sp>
@@ -1213,38 +1219,37 @@
           <a:p>
             <a:pPr lvl="0"/>
             <a:r>
-              <a:rPr lang="en-US" smtClean="0"/>
+              <a:rPr lang="en-US"/>
               <a:t>Click to edit Master text styles</a:t>
             </a:r>
           </a:p>
           <a:p>
             <a:pPr lvl="1"/>
             <a:r>
-              <a:rPr lang="en-US" smtClean="0"/>
+              <a:rPr lang="en-US"/>
               <a:t>Second level</a:t>
             </a:r>
           </a:p>
           <a:p>
             <a:pPr lvl="2"/>
             <a:r>
-              <a:rPr lang="en-US" smtClean="0"/>
+              <a:rPr lang="en-US"/>
               <a:t>Third level</a:t>
             </a:r>
           </a:p>
           <a:p>
             <a:pPr lvl="3"/>
             <a:r>
-              <a:rPr lang="en-US" smtClean="0"/>
+              <a:rPr lang="en-US"/>
               <a:t>Fourth level</a:t>
             </a:r>
           </a:p>
           <a:p>
             <a:pPr lvl="4"/>
             <a:r>
-              <a:rPr lang="en-US" smtClean="0"/>
+              <a:rPr lang="en-US"/>
               <a:t>Fifth level</a:t>
             </a:r>
-            <a:endParaRPr lang="en-US"/>
           </a:p>
         </p:txBody>
       </p:sp>
@@ -1298,38 +1303,37 @@
           <a:p>
             <a:pPr lvl="0"/>
             <a:r>
-              <a:rPr lang="en-US" smtClean="0"/>
+              <a:rPr lang="en-US"/>
               <a:t>Click to edit Master text styles</a:t>
             </a:r>
           </a:p>
           <a:p>
             <a:pPr lvl="1"/>
             <a:r>
-              <a:rPr lang="en-US" smtClean="0"/>
+              <a:rPr lang="en-US"/>
               <a:t>Second level</a:t>
             </a:r>
           </a:p>
           <a:p>
             <a:pPr lvl="2"/>
             <a:r>
-              <a:rPr lang="en-US" smtClean="0"/>
+              <a:rPr lang="en-US"/>
               <a:t>Third level</a:t>
             </a:r>
           </a:p>
           <a:p>
             <a:pPr lvl="3"/>
             <a:r>
-              <a:rPr lang="en-US" smtClean="0"/>
+              <a:rPr lang="en-US"/>
               <a:t>Fourth level</a:t>
             </a:r>
           </a:p>
           <a:p>
             <a:pPr lvl="4"/>
             <a:r>
-              <a:rPr lang="en-US" smtClean="0"/>
+              <a:rPr lang="en-US"/>
               <a:t>Fifth level</a:t>
             </a:r>
-            <a:endParaRPr lang="en-US"/>
           </a:p>
         </p:txBody>
       </p:sp>
@@ -1350,7 +1354,7 @@
           <a:p>
             <a:fld id="{5BCAD085-E8A6-8845-BD4E-CB4CCA059FC4}" type="datetimeFigureOut">
               <a:rPr lang="en-US" smtClean="0"/>
-              <a:t>1/27/13</a:t>
+              <a:t>6/18/26</a:t>
             </a:fld>
             <a:endParaRPr lang="en-US"/>
           </a:p>
@@ -1448,10 +1452,9 @@
           </a:lstStyle>
           <a:p>
             <a:r>
-              <a:rPr lang="en-US" smtClean="0"/>
+              <a:rPr lang="en-US"/>
               <a:t>Click to edit Master title style</a:t>
             </a:r>
-            <a:endParaRPr lang="en-US"/>
           </a:p>
         </p:txBody>
       </p:sp>
@@ -1514,7 +1517,7 @@
           <a:p>
             <a:pPr lvl="0"/>
             <a:r>
-              <a:rPr lang="en-US" smtClean="0"/>
+              <a:rPr lang="en-US"/>
               <a:t>Click to edit Master text styles</a:t>
             </a:r>
           </a:p>
@@ -1570,38 +1573,37 @@
           <a:p>
             <a:pPr lvl="0"/>
             <a:r>
-              <a:rPr lang="en-US" smtClean="0"/>
+              <a:rPr lang="en-US"/>
               <a:t>Click to edit Master text styles</a:t>
             </a:r>
           </a:p>
           <a:p>
             <a:pPr lvl="1"/>
             <a:r>
-              <a:rPr lang="en-US" smtClean="0"/>
+              <a:rPr lang="en-US"/>
               <a:t>Second level</a:t>
             </a:r>
           </a:p>
           <a:p>
             <a:pPr lvl="2"/>
             <a:r>
-              <a:rPr lang="en-US" smtClean="0"/>
+              <a:rPr lang="en-US"/>
               <a:t>Third level</a:t>
             </a:r>
           </a:p>
           <a:p>
             <a:pPr lvl="3"/>
             <a:r>
-              <a:rPr lang="en-US" smtClean="0"/>
+              <a:rPr lang="en-US"/>
               <a:t>Fourth level</a:t>
             </a:r>
           </a:p>
           <a:p>
             <a:pPr lvl="4"/>
             <a:r>
-              <a:rPr lang="en-US" smtClean="0"/>
+              <a:rPr lang="en-US"/>
               <a:t>Fifth level</a:t>
             </a:r>
-            <a:endParaRPr lang="en-US"/>
           </a:p>
         </p:txBody>
       </p:sp>
@@ -1664,7 +1666,7 @@
           <a:p>
             <a:pPr lvl="0"/>
             <a:r>
-              <a:rPr lang="en-US" smtClean="0"/>
+              <a:rPr lang="en-US"/>
               <a:t>Click to edit Master text styles</a:t>
             </a:r>
           </a:p>
@@ -1720,38 +1722,37 @@
           <a:p>
             <a:pPr lvl="0"/>
             <a:r>
-              <a:rPr lang="en-US" smtClean="0"/>
+              <a:rPr lang="en-US"/>
               <a:t>Click to edit Master text styles</a:t>
             </a:r>
           </a:p>
           <a:p>
             <a:pPr lvl="1"/>
             <a:r>
-              <a:rPr lang="en-US" smtClean="0"/>
+              <a:rPr lang="en-US"/>
               <a:t>Second level</a:t>
             </a:r>
           </a:p>
           <a:p>
             <a:pPr lvl="2"/>
             <a:r>
-              <a:rPr lang="en-US" smtClean="0"/>
+              <a:rPr lang="en-US"/>
               <a:t>Third level</a:t>
             </a:r>
           </a:p>
           <a:p>
             <a:pPr lvl="3"/>
             <a:r>
-              <a:rPr lang="en-US" smtClean="0"/>
+              <a:rPr lang="en-US"/>
               <a:t>Fourth level</a:t>
             </a:r>
           </a:p>
           <a:p>
             <a:pPr lvl="4"/>
             <a:r>
-              <a:rPr lang="en-US" smtClean="0"/>
+              <a:rPr lang="en-US"/>
               <a:t>Fifth level</a:t>
             </a:r>
-            <a:endParaRPr lang="en-US"/>
           </a:p>
         </p:txBody>
       </p:sp>
@@ -1772,7 +1773,7 @@
           <a:p>
             <a:fld id="{5BCAD085-E8A6-8845-BD4E-CB4CCA059FC4}" type="datetimeFigureOut">
               <a:rPr lang="en-US" smtClean="0"/>
-              <a:t>1/27/13</a:t>
+              <a:t>6/18/26</a:t>
             </a:fld>
             <a:endParaRPr lang="en-US"/>
           </a:p>
@@ -1866,10 +1867,9 @@
           <a:lstStyle/>
           <a:p>
             <a:r>
-              <a:rPr lang="en-US" smtClean="0"/>
+              <a:rPr lang="en-US"/>
               <a:t>Click to edit Master title style</a:t>
             </a:r>
-            <a:endParaRPr lang="en-US"/>
           </a:p>
         </p:txBody>
       </p:sp>
@@ -1890,7 +1890,7 @@
           <a:p>
             <a:fld id="{5BCAD085-E8A6-8845-BD4E-CB4CCA059FC4}" type="datetimeFigureOut">
               <a:rPr lang="en-US" smtClean="0"/>
-              <a:t>1/27/13</a:t>
+              <a:t>6/18/26</a:t>
             </a:fld>
             <a:endParaRPr lang="en-US"/>
           </a:p>
@@ -1985,7 +1985,7 @@
           <a:p>
             <a:fld id="{5BCAD085-E8A6-8845-BD4E-CB4CCA059FC4}" type="datetimeFigureOut">
               <a:rPr lang="en-US" smtClean="0"/>
-              <a:t>1/27/13</a:t>
+              <a:t>6/18/26</a:t>
             </a:fld>
             <a:endParaRPr lang="en-US"/>
           </a:p>
@@ -2088,10 +2088,9 @@
           </a:lstStyle>
           <a:p>
             <a:r>
-              <a:rPr lang="en-US" smtClean="0"/>
+              <a:rPr lang="en-US"/>
               <a:t>Click to edit Master title style</a:t>
             </a:r>
-            <a:endParaRPr lang="en-US"/>
           </a:p>
         </p:txBody>
       </p:sp>
@@ -2145,38 +2144,37 @@
           <a:p>
             <a:pPr lvl="0"/>
             <a:r>
-              <a:rPr lang="en-US" smtClean="0"/>
+              <a:rPr lang="en-US"/>
               <a:t>Click to edit Master text styles</a:t>
             </a:r>
           </a:p>
           <a:p>
             <a:pPr lvl="1"/>
             <a:r>
-              <a:rPr lang="en-US" smtClean="0"/>
+              <a:rPr lang="en-US"/>
               <a:t>Second level</a:t>
             </a:r>
           </a:p>
           <a:p>
             <a:pPr lvl="2"/>
             <a:r>
-              <a:rPr lang="en-US" smtClean="0"/>
+              <a:rPr lang="en-US"/>
               <a:t>Third level</a:t>
             </a:r>
           </a:p>
           <a:p>
             <a:pPr lvl="3"/>
             <a:r>
-              <a:rPr lang="en-US" smtClean="0"/>
+              <a:rPr lang="en-US"/>
               <a:t>Fourth level</a:t>
             </a:r>
           </a:p>
           <a:p>
             <a:pPr lvl="4"/>
             <a:r>
-              <a:rPr lang="en-US" smtClean="0"/>
+              <a:rPr lang="en-US"/>
               <a:t>Fifth level</a:t>
             </a:r>
-            <a:endParaRPr lang="en-US"/>
           </a:p>
         </p:txBody>
       </p:sp>
@@ -2239,7 +2237,7 @@
           <a:p>
             <a:pPr lvl="0"/>
             <a:r>
-              <a:rPr lang="en-US" smtClean="0"/>
+              <a:rPr lang="en-US"/>
               <a:t>Click to edit Master text styles</a:t>
             </a:r>
           </a:p>
@@ -2262,7 +2260,7 @@
           <a:p>
             <a:fld id="{5BCAD085-E8A6-8845-BD4E-CB4CCA059FC4}" type="datetimeFigureOut">
               <a:rPr lang="en-US" smtClean="0"/>
-              <a:t>1/27/13</a:t>
+              <a:t>6/18/26</a:t>
             </a:fld>
             <a:endParaRPr lang="en-US"/>
           </a:p>
@@ -2365,10 +2363,9 @@
           </a:lstStyle>
           <a:p>
             <a:r>
-              <a:rPr lang="en-US" smtClean="0"/>
+              <a:rPr lang="en-US"/>
               <a:t>Click to edit Master title style</a:t>
             </a:r>
-            <a:endParaRPr lang="en-US"/>
           </a:p>
         </p:txBody>
       </p:sp>
@@ -2492,7 +2489,7 @@
           <a:p>
             <a:pPr lvl="0"/>
             <a:r>
-              <a:rPr lang="en-US" smtClean="0"/>
+              <a:rPr lang="en-US"/>
               <a:t>Click to edit Master text styles</a:t>
             </a:r>
           </a:p>
@@ -2515,7 +2512,7 @@
           <a:p>
             <a:fld id="{5BCAD085-E8A6-8845-BD4E-CB4CCA059FC4}" type="datetimeFigureOut">
               <a:rPr lang="en-US" smtClean="0"/>
-              <a:t>1/27/13</a:t>
+              <a:t>6/18/26</a:t>
             </a:fld>
             <a:endParaRPr lang="en-US"/>
           </a:p>
@@ -2624,10 +2621,9 @@
           <a:lstStyle/>
           <a:p>
             <a:r>
-              <a:rPr lang="en-US" smtClean="0"/>
+              <a:rPr lang="en-US"/>
               <a:t>Click to edit Master title style</a:t>
             </a:r>
-            <a:endParaRPr lang="en-US"/>
           </a:p>
         </p:txBody>
       </p:sp>
@@ -2658,38 +2654,37 @@
           <a:p>
             <a:pPr lvl="0"/>
             <a:r>
-              <a:rPr lang="en-US" smtClean="0"/>
+              <a:rPr lang="en-US"/>
               <a:t>Click to edit Master text styles</a:t>
             </a:r>
           </a:p>
           <a:p>
             <a:pPr lvl="1"/>
             <a:r>
-              <a:rPr lang="en-US" smtClean="0"/>
+              <a:rPr lang="en-US"/>
               <a:t>Second level</a:t>
             </a:r>
           </a:p>
           <a:p>
             <a:pPr lvl="2"/>
             <a:r>
-              <a:rPr lang="en-US" smtClean="0"/>
+              <a:rPr lang="en-US"/>
               <a:t>Third level</a:t>
             </a:r>
           </a:p>
           <a:p>
             <a:pPr lvl="3"/>
             <a:r>
-              <a:rPr lang="en-US" smtClean="0"/>
+              <a:rPr lang="en-US"/>
               <a:t>Fourth level</a:t>
             </a:r>
           </a:p>
           <a:p>
             <a:pPr lvl="4"/>
             <a:r>
-              <a:rPr lang="en-US" smtClean="0"/>
+              <a:rPr lang="en-US"/>
               <a:t>Fifth level</a:t>
             </a:r>
-            <a:endParaRPr lang="en-US"/>
           </a:p>
         </p:txBody>
       </p:sp>
@@ -2728,7 +2723,7 @@
           <a:p>
             <a:fld id="{5BCAD085-E8A6-8845-BD4E-CB4CCA059FC4}" type="datetimeFigureOut">
               <a:rPr lang="en-US" smtClean="0"/>
-              <a:t>1/27/13</a:t>
+              <a:t>6/18/26</a:t>
             </a:fld>
             <a:endParaRPr lang="en-US"/>
           </a:p>
@@ -3087,7 +3082,7 @@
 </file>
 
 <file path=ppt/slides/slide1.xml><?xml version="1.0" encoding="utf-8"?>
-<p:sld xmlns:a="http://schemas.openxmlformats.org/drawingml/2006/main" xmlns:p="http://schemas.openxmlformats.org/presentationml/2006/main" xmlns:r="http://schemas.openxmlformats.org/officeDocument/2006/relationships">
+<p:sld xmlns:a="http://schemas.openxmlformats.org/drawingml/2006/main" xmlns:r="http://schemas.openxmlformats.org/officeDocument/2006/relationships" xmlns:p="http://schemas.openxmlformats.org/presentationml/2006/main">
   <p:cSld>
     <p:bg>
       <p:bgPr>
@@ -3103,7 +3098,14 @@
         <p:cNvGrpSpPr/>
         <p:nvPr/>
       </p:nvGrpSpPr>
-      <p:grpSpPr/>
+      <p:grpSpPr>
+        <a:xfrm>
+          <a:off x="0" y="0"/>
+          <a:ext cx="0" cy="0"/>
+          <a:chOff x="0" y="0"/>
+          <a:chExt cx="0" cy="0"/>
+        </a:xfrm>
+      </p:grpSpPr>
       <p:sp>
         <p:nvSpPr>
           <p:cNvPr id="2" name="Rectangle 1"/>
@@ -3144,6 +3146,7 @@
           <a:lstStyle/>
           <a:p>
             <a:pPr algn="ctr"/>
+            <a:endParaRPr/>
           </a:p>
         </p:txBody>
       </p:sp>
@@ -3187,6 +3190,7 @@
           <a:lstStyle/>
           <a:p>
             <a:pPr algn="ctr"/>
+            <a:endParaRPr/>
           </a:p>
         </p:txBody>
       </p:sp>
@@ -3243,7 +3247,7 @@
         </p:spPr>
         <p:txBody>
           <a:bodyPr wrap="square">
-            <a:normAutofit/>
+            <a:normAutofit fontScale="92500" lnSpcReduction="10000"/>
           </a:bodyPr>
           <a:lstStyle/>
           <a:p>
@@ -3278,7 +3282,7 @@
         </p:spPr>
         <p:txBody>
           <a:bodyPr wrap="square">
-            <a:normAutofit/>
+            <a:normAutofit fontScale="92500" lnSpcReduction="20000"/>
           </a:bodyPr>
           <a:lstStyle/>
           <a:p>
@@ -3370,6 +3374,7 @@
           <a:lstStyle/>
           <a:p>
             <a:pPr algn="ctr"/>
+            <a:endParaRPr/>
           </a:p>
         </p:txBody>
       </p:sp>
@@ -3413,6 +3418,7 @@
           <a:lstStyle/>
           <a:p>
             <a:pPr algn="ctr"/>
+            <a:endParaRPr/>
           </a:p>
         </p:txBody>
       </p:sp>
@@ -3456,6 +3462,7 @@
           <a:lstStyle/>
           <a:p>
             <a:pPr algn="ctr"/>
+            <a:endParaRPr/>
           </a:p>
         </p:txBody>
       </p:sp>
@@ -3604,6 +3611,7 @@
           <a:lstStyle/>
           <a:p>
             <a:pPr algn="ctr"/>
+            <a:endParaRPr/>
           </a:p>
         </p:txBody>
       </p:sp>
@@ -3647,6 +3655,7 @@
           <a:lstStyle/>
           <a:p>
             <a:pPr algn="ctr"/>
+            <a:endParaRPr/>
           </a:p>
         </p:txBody>
       </p:sp>
@@ -3795,6 +3804,7 @@
           <a:lstStyle/>
           <a:p>
             <a:pPr algn="ctr"/>
+            <a:endParaRPr/>
           </a:p>
         </p:txBody>
       </p:sp>
@@ -3838,6 +3848,7 @@
           <a:lstStyle/>
           <a:p>
             <a:pPr algn="ctr"/>
+            <a:endParaRPr/>
           </a:p>
         </p:txBody>
       </p:sp>
@@ -3964,7 +3975,7 @@
         </p:spPr>
         <p:txBody>
           <a:bodyPr wrap="square">
-            <a:normAutofit/>
+            <a:normAutofit lnSpcReduction="10000"/>
           </a:bodyPr>
           <a:lstStyle/>
           <a:p>
@@ -4034,7 +4045,7 @@
         </p:spPr>
         <p:txBody>
           <a:bodyPr wrap="square">
-            <a:normAutofit/>
+            <a:normAutofit lnSpcReduction="10000"/>
           </a:bodyPr>
           <a:lstStyle/>
           <a:p>
@@ -4104,7 +4115,7 @@
         </p:spPr>
         <p:txBody>
           <a:bodyPr wrap="square">
-            <a:normAutofit/>
+            <a:normAutofit lnSpcReduction="10000"/>
           </a:bodyPr>
           <a:lstStyle/>
           <a:p>
@@ -4196,6 +4207,7 @@
           <a:lstStyle/>
           <a:p>
             <a:pPr algn="ctr"/>
+            <a:endParaRPr/>
           </a:p>
         </p:txBody>
       </p:sp>
@@ -4278,7 +4290,7 @@
 </file>
 
 <file path=ppt/slides/slide2.xml><?xml version="1.0" encoding="utf-8"?>
-<p:sld xmlns:a="http://schemas.openxmlformats.org/drawingml/2006/main" xmlns:p="http://schemas.openxmlformats.org/presentationml/2006/main" xmlns:r="http://schemas.openxmlformats.org/officeDocument/2006/relationships">
+<p:sld xmlns:a="http://schemas.openxmlformats.org/drawingml/2006/main" xmlns:r="http://schemas.openxmlformats.org/officeDocument/2006/relationships" xmlns:p="http://schemas.openxmlformats.org/presentationml/2006/main">
   <p:cSld>
     <p:bg>
       <p:bgPr>
@@ -4294,7 +4306,14 @@
         <p:cNvGrpSpPr/>
         <p:nvPr/>
       </p:nvGrpSpPr>
-      <p:grpSpPr/>
+      <p:grpSpPr>
+        <a:xfrm>
+          <a:off x="0" y="0"/>
+          <a:ext cx="0" cy="0"/>
+          <a:chOff x="0" y="0"/>
+          <a:chExt cx="0" cy="0"/>
+        </a:xfrm>
+      </p:grpSpPr>
       <p:sp>
         <p:nvSpPr>
           <p:cNvPr id="2" name="Rectangle 1"/>
@@ -4335,6 +4354,7 @@
           <a:lstStyle/>
           <a:p>
             <a:pPr algn="ctr"/>
+            <a:endParaRPr/>
           </a:p>
         </p:txBody>
       </p:sp>
@@ -4378,6 +4398,7 @@
           <a:lstStyle/>
           <a:p>
             <a:pPr algn="ctr"/>
+            <a:endParaRPr/>
           </a:p>
         </p:txBody>
       </p:sp>
@@ -4459,7 +4480,7 @@
         </p:nvSpPr>
         <p:spPr>
           <a:xfrm>
-            <a:off x="237744" y="1645920"/>
+            <a:off x="246761" y="1486662"/>
             <a:ext cx="11704320" cy="25400"/>
           </a:xfrm>
           <a:prstGeom prst="rect">
@@ -4491,6 +4512,7 @@
           <a:lstStyle/>
           <a:p>
             <a:pPr algn="ctr"/>
+            <a:endParaRPr/>
           </a:p>
         </p:txBody>
       </p:sp>
@@ -4534,6 +4556,7 @@
           <a:lstStyle/>
           <a:p>
             <a:pPr algn="ctr"/>
+            <a:endParaRPr/>
           </a:p>
         </p:txBody>
       </p:sp>
@@ -4577,6 +4600,7 @@
           <a:lstStyle/>
           <a:p>
             <a:pPr algn="ctr"/>
+            <a:endParaRPr/>
           </a:p>
         </p:txBody>
       </p:sp>
@@ -4655,6 +4679,7 @@
           <a:lstStyle/>
           <a:p>
             <a:pPr algn="ctr"/>
+            <a:endParaRPr/>
           </a:p>
         </p:txBody>
       </p:sp>
@@ -4698,6 +4723,7 @@
           <a:lstStyle/>
           <a:p>
             <a:pPr algn="ctr"/>
+            <a:endParaRPr/>
           </a:p>
         </p:txBody>
       </p:sp>
@@ -4719,7 +4745,7 @@
         </p:spPr>
         <p:txBody>
           <a:bodyPr wrap="square">
-            <a:normAutofit/>
+            <a:normAutofit lnSpcReduction="10000"/>
           </a:bodyPr>
           <a:lstStyle/>
           <a:p>
@@ -4846,6 +4872,7 @@
           <a:lstStyle/>
           <a:p>
             <a:pPr algn="ctr"/>
+            <a:endParaRPr/>
           </a:p>
         </p:txBody>
       </p:sp>
@@ -4889,6 +4916,7 @@
           <a:lstStyle/>
           <a:p>
             <a:pPr algn="ctr"/>
+            <a:endParaRPr/>
           </a:p>
         </p:txBody>
       </p:sp>
@@ -4910,7 +4938,7 @@
         </p:spPr>
         <p:txBody>
           <a:bodyPr wrap="square">
-            <a:normAutofit/>
+            <a:normAutofit lnSpcReduction="10000"/>
           </a:bodyPr>
           <a:lstStyle/>
           <a:p>
@@ -5037,6 +5065,7 @@
           <a:lstStyle/>
           <a:p>
             <a:pPr algn="ctr"/>
+            <a:endParaRPr/>
           </a:p>
         </p:txBody>
       </p:sp>
@@ -5080,6 +5109,7 @@
           <a:lstStyle/>
           <a:p>
             <a:pPr algn="ctr"/>
+            <a:endParaRPr/>
           </a:p>
         </p:txBody>
       </p:sp>
@@ -5101,7 +5131,7 @@
         </p:spPr>
         <p:txBody>
           <a:bodyPr wrap="square">
-            <a:normAutofit/>
+            <a:normAutofit lnSpcReduction="10000"/>
           </a:bodyPr>
           <a:lstStyle/>
           <a:p>
@@ -5228,6 +5258,7 @@
           <a:lstStyle/>
           <a:p>
             <a:pPr algn="ctr"/>
+            <a:endParaRPr/>
           </a:p>
         </p:txBody>
       </p:sp>
@@ -5271,6 +5302,7 @@
           <a:lstStyle/>
           <a:p>
             <a:pPr algn="ctr"/>
+            <a:endParaRPr/>
           </a:p>
         </p:txBody>
       </p:sp>
@@ -5292,7 +5324,7 @@
         </p:spPr>
         <p:txBody>
           <a:bodyPr wrap="square">
-            <a:normAutofit/>
+            <a:normAutofit lnSpcReduction="10000"/>
           </a:bodyPr>
           <a:lstStyle/>
           <a:p>
@@ -5419,6 +5451,7 @@
           <a:lstStyle/>
           <a:p>
             <a:pPr algn="ctr"/>
+            <a:endParaRPr/>
           </a:p>
         </p:txBody>
       </p:sp>
@@ -5462,6 +5495,7 @@
           <a:lstStyle/>
           <a:p>
             <a:pPr algn="ctr"/>
+            <a:endParaRPr/>
           </a:p>
         </p:txBody>
       </p:sp>
@@ -5483,7 +5517,7 @@
         </p:spPr>
         <p:txBody>
           <a:bodyPr wrap="square">
-            <a:normAutofit/>
+            <a:normAutofit lnSpcReduction="10000"/>
           </a:bodyPr>
           <a:lstStyle/>
           <a:p>
@@ -5610,6 +5644,7 @@
           <a:lstStyle/>
           <a:p>
             <a:pPr algn="ctr"/>
+            <a:endParaRPr/>
           </a:p>
         </p:txBody>
       </p:sp>
@@ -5692,7 +5727,7 @@
 </file>
 
 <file path=ppt/slides/slide3.xml><?xml version="1.0" encoding="utf-8"?>
-<p:sld xmlns:a="http://schemas.openxmlformats.org/drawingml/2006/main" xmlns:p="http://schemas.openxmlformats.org/presentationml/2006/main" xmlns:r="http://schemas.openxmlformats.org/officeDocument/2006/relationships">
+<p:sld xmlns:a="http://schemas.openxmlformats.org/drawingml/2006/main" xmlns:r="http://schemas.openxmlformats.org/officeDocument/2006/relationships" xmlns:p="http://schemas.openxmlformats.org/presentationml/2006/main">
   <p:cSld>
     <p:bg>
       <p:bgPr>
@@ -5708,7 +5743,14 @@
         <p:cNvGrpSpPr/>
         <p:nvPr/>
       </p:nvGrpSpPr>
-      <p:grpSpPr/>
+      <p:grpSpPr>
+        <a:xfrm>
+          <a:off x="0" y="0"/>
+          <a:ext cx="0" cy="0"/>
+          <a:chOff x="0" y="0"/>
+          <a:chExt cx="0" cy="0"/>
+        </a:xfrm>
+      </p:grpSpPr>
       <p:sp>
         <p:nvSpPr>
           <p:cNvPr id="2" name="Rectangle 1"/>
@@ -5749,6 +5791,7 @@
           <a:lstStyle/>
           <a:p>
             <a:pPr algn="ctr"/>
+            <a:endParaRPr/>
           </a:p>
         </p:txBody>
       </p:sp>
@@ -5792,6 +5835,7 @@
           <a:lstStyle/>
           <a:p>
             <a:pPr algn="ctr"/>
+            <a:endParaRPr/>
           </a:p>
         </p:txBody>
       </p:sp>
@@ -5873,7 +5917,7 @@
         </p:nvSpPr>
         <p:spPr>
           <a:xfrm>
-            <a:off x="237744" y="1645920"/>
+            <a:off x="237744" y="1486916"/>
             <a:ext cx="11704320" cy="25400"/>
           </a:xfrm>
           <a:prstGeom prst="rect">
@@ -5905,6 +5949,7 @@
           <a:lstStyle/>
           <a:p>
             <a:pPr algn="ctr"/>
+            <a:endParaRPr/>
           </a:p>
         </p:txBody>
       </p:sp>
@@ -5948,6 +5993,7 @@
           <a:lstStyle/>
           <a:p>
             <a:pPr algn="ctr"/>
+            <a:endParaRPr/>
           </a:p>
         </p:txBody>
       </p:sp>
@@ -5991,6 +6037,7 @@
           <a:lstStyle/>
           <a:p>
             <a:pPr algn="ctr"/>
+            <a:endParaRPr/>
           </a:p>
         </p:txBody>
       </p:sp>
@@ -6047,7 +6094,7 @@
         </p:spPr>
         <p:txBody>
           <a:bodyPr wrap="square">
-            <a:normAutofit/>
+            <a:normAutofit fontScale="92500" lnSpcReduction="10000"/>
           </a:bodyPr>
           <a:lstStyle/>
           <a:p>
@@ -6104,6 +6151,7 @@
           <a:lstStyle/>
           <a:p>
             <a:pPr algn="ctr"/>
+            <a:endParaRPr/>
           </a:p>
         </p:txBody>
       </p:sp>
@@ -6125,7 +6173,7 @@
         </p:spPr>
         <p:txBody>
           <a:bodyPr wrap="square">
-            <a:normAutofit/>
+            <a:normAutofit lnSpcReduction="10000"/>
           </a:bodyPr>
           <a:lstStyle/>
           <a:p>
@@ -6182,6 +6230,7 @@
           <a:lstStyle/>
           <a:p>
             <a:pPr algn="ctr"/>
+            <a:endParaRPr/>
           </a:p>
         </p:txBody>
       </p:sp>
@@ -6260,6 +6309,7 @@
           <a:lstStyle/>
           <a:p>
             <a:pPr algn="ctr"/>
+            <a:endParaRPr/>
           </a:p>
         </p:txBody>
       </p:sp>
@@ -6338,6 +6388,7 @@
           <a:lstStyle/>
           <a:p>
             <a:pPr algn="ctr"/>
+            <a:endParaRPr/>
           </a:p>
         </p:txBody>
       </p:sp>
@@ -6416,6 +6467,7 @@
           <a:lstStyle/>
           <a:p>
             <a:pPr algn="ctr"/>
+            <a:endParaRPr/>
           </a:p>
         </p:txBody>
       </p:sp>
@@ -6494,6 +6546,7 @@
           <a:lstStyle/>
           <a:p>
             <a:pPr algn="ctr"/>
+            <a:endParaRPr/>
           </a:p>
         </p:txBody>
       </p:sp>
@@ -6515,7 +6568,7 @@
         </p:spPr>
         <p:txBody>
           <a:bodyPr wrap="square">
-            <a:normAutofit/>
+            <a:normAutofit lnSpcReduction="10000"/>
           </a:bodyPr>
           <a:lstStyle/>
           <a:p>
@@ -6572,6 +6625,7 @@
           <a:lstStyle/>
           <a:p>
             <a:pPr algn="ctr"/>
+            <a:endParaRPr/>
           </a:p>
         </p:txBody>
       </p:sp>
@@ -6615,6 +6669,7 @@
           <a:lstStyle/>
           <a:p>
             <a:pPr algn="ctr"/>
+            <a:endParaRPr/>
           </a:p>
         </p:txBody>
       </p:sp>
@@ -6671,7 +6726,7 @@
         </p:spPr>
         <p:txBody>
           <a:bodyPr wrap="square">
-            <a:normAutofit/>
+            <a:normAutofit fontScale="92500" lnSpcReduction="10000"/>
           </a:bodyPr>
           <a:lstStyle/>
           <a:p>
@@ -6728,6 +6783,7 @@
           <a:lstStyle/>
           <a:p>
             <a:pPr algn="ctr"/>
+            <a:endParaRPr/>
           </a:p>
         </p:txBody>
       </p:sp>
@@ -6749,7 +6805,7 @@
         </p:spPr>
         <p:txBody>
           <a:bodyPr wrap="square">
-            <a:normAutofit/>
+            <a:normAutofit lnSpcReduction="10000"/>
           </a:bodyPr>
           <a:lstStyle/>
           <a:p>
@@ -6806,6 +6862,7 @@
           <a:lstStyle/>
           <a:p>
             <a:pPr algn="ctr"/>
+            <a:endParaRPr/>
           </a:p>
         </p:txBody>
       </p:sp>
@@ -6884,6 +6941,7 @@
           <a:lstStyle/>
           <a:p>
             <a:pPr algn="ctr"/>
+            <a:endParaRPr/>
           </a:p>
         </p:txBody>
       </p:sp>
@@ -6962,6 +7020,7 @@
           <a:lstStyle/>
           <a:p>
             <a:pPr algn="ctr"/>
+            <a:endParaRPr/>
           </a:p>
         </p:txBody>
       </p:sp>
@@ -7040,6 +7099,7 @@
           <a:lstStyle/>
           <a:p>
             <a:pPr algn="ctr"/>
+            <a:endParaRPr/>
           </a:p>
         </p:txBody>
       </p:sp>
@@ -7118,6 +7178,7 @@
           <a:lstStyle/>
           <a:p>
             <a:pPr algn="ctr"/>
+            <a:endParaRPr/>
           </a:p>
         </p:txBody>
       </p:sp>
@@ -7139,7 +7200,7 @@
         </p:spPr>
         <p:txBody>
           <a:bodyPr wrap="square">
-            <a:normAutofit/>
+            <a:normAutofit lnSpcReduction="10000"/>
           </a:bodyPr>
           <a:lstStyle/>
           <a:p>
@@ -7196,6 +7257,7 @@
           <a:lstStyle/>
           <a:p>
             <a:pPr algn="ctr"/>
+            <a:endParaRPr/>
           </a:p>
         </p:txBody>
       </p:sp>
@@ -7239,6 +7301,7 @@
           <a:lstStyle/>
           <a:p>
             <a:pPr algn="ctr"/>
+            <a:endParaRPr/>
           </a:p>
         </p:txBody>
       </p:sp>
@@ -7295,7 +7358,7 @@
         </p:spPr>
         <p:txBody>
           <a:bodyPr wrap="square">
-            <a:normAutofit/>
+            <a:normAutofit fontScale="92500" lnSpcReduction="10000"/>
           </a:bodyPr>
           <a:lstStyle/>
           <a:p>
@@ -7352,6 +7415,7 @@
           <a:lstStyle/>
           <a:p>
             <a:pPr algn="ctr"/>
+            <a:endParaRPr/>
           </a:p>
         </p:txBody>
       </p:sp>
@@ -7373,7 +7437,7 @@
         </p:spPr>
         <p:txBody>
           <a:bodyPr wrap="square">
-            <a:normAutofit/>
+            <a:normAutofit lnSpcReduction="10000"/>
           </a:bodyPr>
           <a:lstStyle/>
           <a:p>
@@ -7430,6 +7494,7 @@
           <a:lstStyle/>
           <a:p>
             <a:pPr algn="ctr"/>
+            <a:endParaRPr/>
           </a:p>
         </p:txBody>
       </p:sp>
@@ -7508,6 +7573,7 @@
           <a:lstStyle/>
           <a:p>
             <a:pPr algn="ctr"/>
+            <a:endParaRPr/>
           </a:p>
         </p:txBody>
       </p:sp>
@@ -7586,6 +7652,7 @@
           <a:lstStyle/>
           <a:p>
             <a:pPr algn="ctr"/>
+            <a:endParaRPr/>
           </a:p>
         </p:txBody>
       </p:sp>
@@ -7664,6 +7731,7 @@
           <a:lstStyle/>
           <a:p>
             <a:pPr algn="ctr"/>
+            <a:endParaRPr/>
           </a:p>
         </p:txBody>
       </p:sp>
@@ -7742,6 +7810,7 @@
           <a:lstStyle/>
           <a:p>
             <a:pPr algn="ctr"/>
+            <a:endParaRPr/>
           </a:p>
         </p:txBody>
       </p:sp>
@@ -7763,7 +7832,7 @@
         </p:spPr>
         <p:txBody>
           <a:bodyPr wrap="square">
-            <a:normAutofit/>
+            <a:normAutofit lnSpcReduction="10000"/>
           </a:bodyPr>
           <a:lstStyle/>
           <a:p>
@@ -7820,6 +7889,7 @@
           <a:lstStyle/>
           <a:p>
             <a:pPr algn="ctr"/>
+            <a:endParaRPr/>
           </a:p>
         </p:txBody>
       </p:sp>
@@ -7902,7 +7972,7 @@
 </file>
 
 <file path=ppt/slides/slide4.xml><?xml version="1.0" encoding="utf-8"?>
-<p:sld xmlns:a="http://schemas.openxmlformats.org/drawingml/2006/main" xmlns:p="http://schemas.openxmlformats.org/presentationml/2006/main" xmlns:r="http://schemas.openxmlformats.org/officeDocument/2006/relationships">
+<p:sld xmlns:a="http://schemas.openxmlformats.org/drawingml/2006/main" xmlns:r="http://schemas.openxmlformats.org/officeDocument/2006/relationships" xmlns:p="http://schemas.openxmlformats.org/presentationml/2006/main">
   <p:cSld>
     <p:bg>
       <p:bgPr>
@@ -7918,7 +7988,14 @@
         <p:cNvGrpSpPr/>
         <p:nvPr/>
       </p:nvGrpSpPr>
-      <p:grpSpPr/>
+      <p:grpSpPr>
+        <a:xfrm>
+          <a:off x="0" y="0"/>
+          <a:ext cx="0" cy="0"/>
+          <a:chOff x="0" y="0"/>
+          <a:chExt cx="0" cy="0"/>
+        </a:xfrm>
+      </p:grpSpPr>
       <p:sp>
         <p:nvSpPr>
           <p:cNvPr id="2" name="Rectangle 1"/>
@@ -7959,6 +8036,7 @@
           <a:lstStyle/>
           <a:p>
             <a:pPr algn="ctr"/>
+            <a:endParaRPr/>
           </a:p>
         </p:txBody>
       </p:sp>
@@ -8002,6 +8080,7 @@
           <a:lstStyle/>
           <a:p>
             <a:pPr algn="ctr"/>
+            <a:endParaRPr/>
           </a:p>
         </p:txBody>
       </p:sp>
@@ -8064,7 +8143,7 @@
           <a:p>
             <a:pPr algn="l"/>
             <a:r>
-              <a:rPr sz="900" b="0" i="1">
+              <a:rPr sz="900" b="0" i="1" dirty="0">
                 <a:solidFill>
                   <a:srgbClr val="9CA3AF"/>
                 </a:solidFill>
@@ -8083,7 +8162,7 @@
         </p:nvSpPr>
         <p:spPr>
           <a:xfrm>
-            <a:off x="237744" y="1645920"/>
+            <a:off x="250712" y="1477772"/>
             <a:ext cx="11704320" cy="25400"/>
           </a:xfrm>
           <a:prstGeom prst="rect">
@@ -8115,6 +8194,7 @@
           <a:lstStyle/>
           <a:p>
             <a:pPr algn="ctr"/>
+            <a:endParaRPr/>
           </a:p>
         </p:txBody>
       </p:sp>
@@ -8158,6 +8238,7 @@
           <a:lstStyle/>
           <a:p>
             <a:pPr algn="ctr"/>
+            <a:endParaRPr/>
           </a:p>
         </p:txBody>
       </p:sp>
@@ -8236,6 +8317,7 @@
           <a:lstStyle/>
           <a:p>
             <a:pPr algn="ctr"/>
+            <a:endParaRPr/>
           </a:p>
         </p:txBody>
       </p:sp>
@@ -8314,6 +8396,7 @@
           <a:lstStyle/>
           <a:p>
             <a:pPr algn="ctr"/>
+            <a:endParaRPr/>
           </a:p>
         </p:txBody>
       </p:sp>
@@ -8392,6 +8475,7 @@
           <a:lstStyle/>
           <a:p>
             <a:pPr algn="ctr"/>
+            <a:endParaRPr/>
           </a:p>
         </p:txBody>
       </p:sp>
@@ -8470,6 +8554,7 @@
           <a:lstStyle/>
           <a:p>
             <a:pPr algn="ctr"/>
+            <a:endParaRPr/>
           </a:p>
         </p:txBody>
       </p:sp>
@@ -8513,6 +8598,7 @@
           <a:lstStyle/>
           <a:p>
             <a:pPr algn="ctr"/>
+            <a:endParaRPr/>
           </a:p>
         </p:txBody>
       </p:sp>
@@ -8556,6 +8642,7 @@
           <a:lstStyle/>
           <a:p>
             <a:pPr algn="ctr"/>
+            <a:endParaRPr/>
           </a:p>
         </p:txBody>
       </p:sp>
@@ -8599,6 +8686,7 @@
           <a:lstStyle/>
           <a:p>
             <a:pPr algn="ctr"/>
+            <a:endParaRPr/>
           </a:p>
         </p:txBody>
       </p:sp>
@@ -8642,6 +8730,7 @@
           <a:lstStyle/>
           <a:p>
             <a:pPr algn="ctr"/>
+            <a:endParaRPr/>
           </a:p>
         </p:txBody>
       </p:sp>
@@ -8755,6 +8844,7 @@
           <a:lstStyle/>
           <a:p>
             <a:pPr algn="ctr"/>
+            <a:endParaRPr/>
           </a:p>
         </p:txBody>
       </p:sp>
@@ -8868,6 +8958,7 @@
           <a:lstStyle/>
           <a:p>
             <a:pPr algn="ctr"/>
+            <a:endParaRPr/>
           </a:p>
         </p:txBody>
       </p:sp>
@@ -8911,6 +9002,7 @@
           <a:lstStyle/>
           <a:p>
             <a:pPr algn="ctr"/>
+            <a:endParaRPr/>
           </a:p>
         </p:txBody>
       </p:sp>
@@ -8954,6 +9046,7 @@
           <a:lstStyle/>
           <a:p>
             <a:pPr algn="ctr"/>
+            <a:endParaRPr/>
           </a:p>
         </p:txBody>
       </p:sp>
@@ -8997,6 +9090,7 @@
           <a:lstStyle/>
           <a:p>
             <a:pPr algn="ctr"/>
+            <a:endParaRPr/>
           </a:p>
         </p:txBody>
       </p:sp>
@@ -9040,6 +9134,7 @@
           <a:lstStyle/>
           <a:p>
             <a:pPr algn="ctr"/>
+            <a:endParaRPr/>
           </a:p>
         </p:txBody>
       </p:sp>
@@ -9153,6 +9248,7 @@
           <a:lstStyle/>
           <a:p>
             <a:pPr algn="ctr"/>
+            <a:endParaRPr/>
           </a:p>
         </p:txBody>
       </p:sp>
@@ -9266,6 +9362,7 @@
           <a:lstStyle/>
           <a:p>
             <a:pPr algn="ctr"/>
+            <a:endParaRPr/>
           </a:p>
         </p:txBody>
       </p:sp>
@@ -9309,6 +9406,7 @@
           <a:lstStyle/>
           <a:p>
             <a:pPr algn="ctr"/>
+            <a:endParaRPr/>
           </a:p>
         </p:txBody>
       </p:sp>
@@ -9352,6 +9450,7 @@
           <a:lstStyle/>
           <a:p>
             <a:pPr algn="ctr"/>
+            <a:endParaRPr/>
           </a:p>
         </p:txBody>
       </p:sp>
@@ -9395,6 +9494,7 @@
           <a:lstStyle/>
           <a:p>
             <a:pPr algn="ctr"/>
+            <a:endParaRPr/>
           </a:p>
         </p:txBody>
       </p:sp>
@@ -9438,6 +9538,7 @@
           <a:lstStyle/>
           <a:p>
             <a:pPr algn="ctr"/>
+            <a:endParaRPr/>
           </a:p>
         </p:txBody>
       </p:sp>
@@ -9551,6 +9652,7 @@
           <a:lstStyle/>
           <a:p>
             <a:pPr algn="ctr"/>
+            <a:endParaRPr/>
           </a:p>
         </p:txBody>
       </p:sp>
@@ -9664,6 +9766,7 @@
           <a:lstStyle/>
           <a:p>
             <a:pPr algn="ctr"/>
+            <a:endParaRPr/>
           </a:p>
         </p:txBody>
       </p:sp>
@@ -9707,6 +9810,7 @@
           <a:lstStyle/>
           <a:p>
             <a:pPr algn="ctr"/>
+            <a:endParaRPr/>
           </a:p>
         </p:txBody>
       </p:sp>
@@ -9750,6 +9854,7 @@
           <a:lstStyle/>
           <a:p>
             <a:pPr algn="ctr"/>
+            <a:endParaRPr/>
           </a:p>
         </p:txBody>
       </p:sp>
@@ -9793,6 +9898,7 @@
           <a:lstStyle/>
           <a:p>
             <a:pPr algn="ctr"/>
+            <a:endParaRPr/>
           </a:p>
         </p:txBody>
       </p:sp>
@@ -9836,6 +9942,7 @@
           <a:lstStyle/>
           <a:p>
             <a:pPr algn="ctr"/>
+            <a:endParaRPr/>
           </a:p>
         </p:txBody>
       </p:sp>
@@ -9949,6 +10056,7 @@
           <a:lstStyle/>
           <a:p>
             <a:pPr algn="ctr"/>
+            <a:endParaRPr/>
           </a:p>
         </p:txBody>
       </p:sp>
@@ -10062,6 +10170,7 @@
           <a:lstStyle/>
           <a:p>
             <a:pPr algn="ctr"/>
+            <a:endParaRPr/>
           </a:p>
         </p:txBody>
       </p:sp>
@@ -10105,6 +10214,7 @@
           <a:lstStyle/>
           <a:p>
             <a:pPr algn="ctr"/>
+            <a:endParaRPr/>
           </a:p>
         </p:txBody>
       </p:sp>
@@ -10148,6 +10258,7 @@
           <a:lstStyle/>
           <a:p>
             <a:pPr algn="ctr"/>
+            <a:endParaRPr/>
           </a:p>
         </p:txBody>
       </p:sp>
@@ -10191,6 +10302,7 @@
           <a:lstStyle/>
           <a:p>
             <a:pPr algn="ctr"/>
+            <a:endParaRPr/>
           </a:p>
         </p:txBody>
       </p:sp>
@@ -10234,6 +10346,7 @@
           <a:lstStyle/>
           <a:p>
             <a:pPr algn="ctr"/>
+            <a:endParaRPr/>
           </a:p>
         </p:txBody>
       </p:sp>
@@ -10347,6 +10460,7 @@
           <a:lstStyle/>
           <a:p>
             <a:pPr algn="ctr"/>
+            <a:endParaRPr/>
           </a:p>
         </p:txBody>
       </p:sp>
@@ -10460,6 +10574,7 @@
           <a:lstStyle/>
           <a:p>
             <a:pPr algn="ctr"/>
+            <a:endParaRPr/>
           </a:p>
         </p:txBody>
       </p:sp>
@@ -10503,6 +10618,7 @@
           <a:lstStyle/>
           <a:p>
             <a:pPr algn="ctr"/>
+            <a:endParaRPr/>
           </a:p>
         </p:txBody>
       </p:sp>
@@ -10546,6 +10662,7 @@
           <a:lstStyle/>
           <a:p>
             <a:pPr algn="ctr"/>
+            <a:endParaRPr/>
           </a:p>
         </p:txBody>
       </p:sp>
@@ -10589,6 +10706,7 @@
           <a:lstStyle/>
           <a:p>
             <a:pPr algn="ctr"/>
+            <a:endParaRPr/>
           </a:p>
         </p:txBody>
       </p:sp>
@@ -10632,6 +10750,7 @@
           <a:lstStyle/>
           <a:p>
             <a:pPr algn="ctr"/>
+            <a:endParaRPr/>
           </a:p>
         </p:txBody>
       </p:sp>
@@ -10745,6 +10864,7 @@
           <a:lstStyle/>
           <a:p>
             <a:pPr algn="ctr"/>
+            <a:endParaRPr/>
           </a:p>
         </p:txBody>
       </p:sp>
@@ -10858,6 +10978,7 @@
           <a:lstStyle/>
           <a:p>
             <a:pPr algn="ctr"/>
+            <a:endParaRPr/>
           </a:p>
         </p:txBody>
       </p:sp>
@@ -10901,6 +11022,7 @@
           <a:lstStyle/>
           <a:p>
             <a:pPr algn="ctr"/>
+            <a:endParaRPr/>
           </a:p>
         </p:txBody>
       </p:sp>
@@ -10944,6 +11066,7 @@
           <a:lstStyle/>
           <a:p>
             <a:pPr algn="ctr"/>
+            <a:endParaRPr/>
           </a:p>
         </p:txBody>
       </p:sp>
@@ -10987,6 +11110,7 @@
           <a:lstStyle/>
           <a:p>
             <a:pPr algn="ctr"/>
+            <a:endParaRPr/>
           </a:p>
         </p:txBody>
       </p:sp>
@@ -11030,6 +11154,7 @@
           <a:lstStyle/>
           <a:p>
             <a:pPr algn="ctr"/>
+            <a:endParaRPr/>
           </a:p>
         </p:txBody>
       </p:sp>
@@ -11143,6 +11268,7 @@
           <a:lstStyle/>
           <a:p>
             <a:pPr algn="ctr"/>
+            <a:endParaRPr/>
           </a:p>
         </p:txBody>
       </p:sp>
@@ -11256,6 +11382,7 @@
           <a:lstStyle/>
           <a:p>
             <a:pPr algn="ctr"/>
+            <a:endParaRPr/>
           </a:p>
         </p:txBody>
       </p:sp>
@@ -11299,6 +11426,7 @@
           <a:lstStyle/>
           <a:p>
             <a:pPr algn="ctr"/>
+            <a:endParaRPr/>
           </a:p>
         </p:txBody>
       </p:sp>
@@ -11342,6 +11470,7 @@
           <a:lstStyle/>
           <a:p>
             <a:pPr algn="ctr"/>
+            <a:endParaRPr/>
           </a:p>
         </p:txBody>
       </p:sp>
@@ -11385,6 +11514,7 @@
           <a:lstStyle/>
           <a:p>
             <a:pPr algn="ctr"/>
+            <a:endParaRPr/>
           </a:p>
         </p:txBody>
       </p:sp>
@@ -11428,6 +11558,7 @@
           <a:lstStyle/>
           <a:p>
             <a:pPr algn="ctr"/>
+            <a:endParaRPr/>
           </a:p>
         </p:txBody>
       </p:sp>
@@ -11541,6 +11672,7 @@
           <a:lstStyle/>
           <a:p>
             <a:pPr algn="ctr"/>
+            <a:endParaRPr/>
           </a:p>
         </p:txBody>
       </p:sp>
@@ -11654,6 +11786,7 @@
           <a:lstStyle/>
           <a:p>
             <a:pPr algn="ctr"/>
+            <a:endParaRPr/>
           </a:p>
         </p:txBody>
       </p:sp>
@@ -11697,6 +11830,7 @@
           <a:lstStyle/>
           <a:p>
             <a:pPr algn="ctr"/>
+            <a:endParaRPr/>
           </a:p>
         </p:txBody>
       </p:sp>
@@ -11740,6 +11874,7 @@
           <a:lstStyle/>
           <a:p>
             <a:pPr algn="ctr"/>
+            <a:endParaRPr/>
           </a:p>
         </p:txBody>
       </p:sp>
@@ -11783,6 +11918,7 @@
           <a:lstStyle/>
           <a:p>
             <a:pPr algn="ctr"/>
+            <a:endParaRPr/>
           </a:p>
         </p:txBody>
       </p:sp>
@@ -11826,6 +11962,7 @@
           <a:lstStyle/>
           <a:p>
             <a:pPr algn="ctr"/>
+            <a:endParaRPr/>
           </a:p>
         </p:txBody>
       </p:sp>
@@ -11939,6 +12076,7 @@
           <a:lstStyle/>
           <a:p>
             <a:pPr algn="ctr"/>
+            <a:endParaRPr/>
           </a:p>
         </p:txBody>
       </p:sp>
@@ -12052,6 +12190,7 @@
           <a:lstStyle/>
           <a:p>
             <a:pPr algn="ctr"/>
+            <a:endParaRPr/>
           </a:p>
         </p:txBody>
       </p:sp>
@@ -12095,6 +12234,7 @@
           <a:lstStyle/>
           <a:p>
             <a:pPr algn="ctr"/>
+            <a:endParaRPr/>
           </a:p>
         </p:txBody>
       </p:sp>
@@ -12138,6 +12278,7 @@
           <a:lstStyle/>
           <a:p>
             <a:pPr algn="ctr"/>
+            <a:endParaRPr/>
           </a:p>
         </p:txBody>
       </p:sp>
@@ -12181,6 +12322,7 @@
           <a:lstStyle/>
           <a:p>
             <a:pPr algn="ctr"/>
+            <a:endParaRPr/>
           </a:p>
         </p:txBody>
       </p:sp>
@@ -12202,7 +12344,7 @@
         </p:spPr>
         <p:txBody>
           <a:bodyPr wrap="square">
-            <a:normAutofit/>
+            <a:normAutofit fontScale="92500" lnSpcReduction="10000"/>
           </a:bodyPr>
           <a:lstStyle/>
           <a:p>
@@ -12237,7 +12379,7 @@
         </p:spPr>
         <p:txBody>
           <a:bodyPr wrap="square">
-            <a:normAutofit/>
+            <a:normAutofit fontScale="92500" lnSpcReduction="10000"/>
           </a:bodyPr>
           <a:lstStyle/>
           <a:p>
@@ -12294,6 +12436,7 @@
           <a:lstStyle/>
           <a:p>
             <a:pPr algn="ctr"/>
+            <a:endParaRPr/>
           </a:p>
         </p:txBody>
       </p:sp>
@@ -12376,7 +12519,7 @@
 </file>
 
 <file path=ppt/slides/slide5.xml><?xml version="1.0" encoding="utf-8"?>
-<p:sld xmlns:a="http://schemas.openxmlformats.org/drawingml/2006/main" xmlns:p="http://schemas.openxmlformats.org/presentationml/2006/main" xmlns:r="http://schemas.openxmlformats.org/officeDocument/2006/relationships">
+<p:sld xmlns:a="http://schemas.openxmlformats.org/drawingml/2006/main" xmlns:r="http://schemas.openxmlformats.org/officeDocument/2006/relationships" xmlns:p="http://schemas.openxmlformats.org/presentationml/2006/main">
   <p:cSld>
     <p:bg>
       <p:bgPr>
@@ -12392,7 +12535,14 @@
         <p:cNvGrpSpPr/>
         <p:nvPr/>
       </p:nvGrpSpPr>
-      <p:grpSpPr/>
+      <p:grpSpPr>
+        <a:xfrm>
+          <a:off x="0" y="0"/>
+          <a:ext cx="0" cy="0"/>
+          <a:chOff x="0" y="0"/>
+          <a:chExt cx="0" cy="0"/>
+        </a:xfrm>
+      </p:grpSpPr>
       <p:sp>
         <p:nvSpPr>
           <p:cNvPr id="2" name="Rectangle 1"/>
@@ -12433,6 +12583,7 @@
           <a:lstStyle/>
           <a:p>
             <a:pPr algn="ctr"/>
+            <a:endParaRPr/>
           </a:p>
         </p:txBody>
       </p:sp>
@@ -12476,6 +12627,7 @@
           <a:lstStyle/>
           <a:p>
             <a:pPr algn="ctr"/>
+            <a:endParaRPr/>
           </a:p>
         </p:txBody>
       </p:sp>
@@ -12557,7 +12709,7 @@
         </p:nvSpPr>
         <p:spPr>
           <a:xfrm>
-            <a:off x="237744" y="1645920"/>
+            <a:off x="237744" y="1454517"/>
             <a:ext cx="11704320" cy="25400"/>
           </a:xfrm>
           <a:prstGeom prst="rect">
@@ -12589,6 +12741,7 @@
           <a:lstStyle/>
           <a:p>
             <a:pPr algn="ctr"/>
+            <a:endParaRPr/>
           </a:p>
         </p:txBody>
       </p:sp>
@@ -12632,6 +12785,7 @@
           <a:lstStyle/>
           <a:p>
             <a:pPr algn="ctr"/>
+            <a:endParaRPr/>
           </a:p>
         </p:txBody>
       </p:sp>
@@ -12653,7 +12807,7 @@
         </p:spPr>
         <p:txBody>
           <a:bodyPr wrap="square">
-            <a:normAutofit/>
+            <a:normAutofit fontScale="92500" lnSpcReduction="10000"/>
           </a:bodyPr>
           <a:lstStyle/>
           <a:p>
@@ -12688,7 +12842,7 @@
         </p:spPr>
         <p:txBody>
           <a:bodyPr wrap="square">
-            <a:normAutofit/>
+            <a:normAutofit fontScale="92500" lnSpcReduction="10000"/>
           </a:bodyPr>
           <a:lstStyle/>
           <a:p>
@@ -12723,7 +12877,7 @@
         </p:spPr>
         <p:txBody>
           <a:bodyPr wrap="square">
-            <a:normAutofit/>
+            <a:normAutofit fontScale="92500" lnSpcReduction="10000"/>
           </a:bodyPr>
           <a:lstStyle/>
           <a:p>
@@ -12758,7 +12912,7 @@
         </p:spPr>
         <p:txBody>
           <a:bodyPr wrap="square">
-            <a:normAutofit/>
+            <a:normAutofit fontScale="92500" lnSpcReduction="10000"/>
           </a:bodyPr>
           <a:lstStyle/>
           <a:p>
@@ -12815,6 +12969,7 @@
           <a:lstStyle/>
           <a:p>
             <a:pPr algn="ctr"/>
+            <a:endParaRPr/>
           </a:p>
         </p:txBody>
       </p:sp>
@@ -12858,6 +13013,7 @@
           <a:lstStyle/>
           <a:p>
             <a:pPr algn="ctr"/>
+            <a:endParaRPr/>
           </a:p>
         </p:txBody>
       </p:sp>
@@ -12901,6 +13057,7 @@
           <a:lstStyle/>
           <a:p>
             <a:pPr algn="ctr"/>
+            <a:endParaRPr/>
           </a:p>
         </p:txBody>
       </p:sp>
@@ -12944,6 +13101,7 @@
           <a:lstStyle/>
           <a:p>
             <a:pPr algn="ctr"/>
+            <a:endParaRPr/>
           </a:p>
         </p:txBody>
       </p:sp>
@@ -12987,6 +13145,7 @@
           <a:lstStyle/>
           <a:p>
             <a:pPr algn="ctr"/>
+            <a:endParaRPr/>
           </a:p>
         </p:txBody>
       </p:sp>
@@ -13135,6 +13294,7 @@
           <a:lstStyle/>
           <a:p>
             <a:pPr algn="ctr"/>
+            <a:endParaRPr/>
           </a:p>
         </p:txBody>
       </p:sp>
@@ -13191,7 +13351,7 @@
         </p:spPr>
         <p:txBody>
           <a:bodyPr wrap="square">
-            <a:normAutofit/>
+            <a:normAutofit lnSpcReduction="10000"/>
           </a:bodyPr>
           <a:lstStyle/>
           <a:p>
@@ -13283,6 +13443,7 @@
           <a:lstStyle/>
           <a:p>
             <a:pPr algn="ctr"/>
+            <a:endParaRPr/>
           </a:p>
         </p:txBody>
       </p:sp>
@@ -13326,6 +13487,7 @@
           <a:lstStyle/>
           <a:p>
             <a:pPr algn="ctr"/>
+            <a:endParaRPr/>
           </a:p>
         </p:txBody>
       </p:sp>
@@ -13369,6 +13531,7 @@
           <a:lstStyle/>
           <a:p>
             <a:pPr algn="ctr"/>
+            <a:endParaRPr/>
           </a:p>
         </p:txBody>
       </p:sp>
@@ -13412,6 +13575,7 @@
           <a:lstStyle/>
           <a:p>
             <a:pPr algn="ctr"/>
+            <a:endParaRPr/>
           </a:p>
         </p:txBody>
       </p:sp>
@@ -13455,6 +13619,7 @@
           <a:lstStyle/>
           <a:p>
             <a:pPr algn="ctr"/>
+            <a:endParaRPr/>
           </a:p>
         </p:txBody>
       </p:sp>
@@ -13603,6 +13768,7 @@
           <a:lstStyle/>
           <a:p>
             <a:pPr algn="ctr"/>
+            <a:endParaRPr/>
           </a:p>
         </p:txBody>
       </p:sp>
@@ -13659,7 +13825,7 @@
         </p:spPr>
         <p:txBody>
           <a:bodyPr wrap="square">
-            <a:normAutofit/>
+            <a:normAutofit lnSpcReduction="10000"/>
           </a:bodyPr>
           <a:lstStyle/>
           <a:p>
@@ -13751,6 +13917,7 @@
           <a:lstStyle/>
           <a:p>
             <a:pPr algn="ctr"/>
+            <a:endParaRPr/>
           </a:p>
         </p:txBody>
       </p:sp>
@@ -13794,6 +13961,7 @@
           <a:lstStyle/>
           <a:p>
             <a:pPr algn="ctr"/>
+            <a:endParaRPr/>
           </a:p>
         </p:txBody>
       </p:sp>
@@ -13837,6 +14005,7 @@
           <a:lstStyle/>
           <a:p>
             <a:pPr algn="ctr"/>
+            <a:endParaRPr/>
           </a:p>
         </p:txBody>
       </p:sp>
@@ -13880,6 +14049,7 @@
           <a:lstStyle/>
           <a:p>
             <a:pPr algn="ctr"/>
+            <a:endParaRPr/>
           </a:p>
         </p:txBody>
       </p:sp>
@@ -13923,6 +14093,7 @@
           <a:lstStyle/>
           <a:p>
             <a:pPr algn="ctr"/>
+            <a:endParaRPr/>
           </a:p>
         </p:txBody>
       </p:sp>
@@ -14071,6 +14242,7 @@
           <a:lstStyle/>
           <a:p>
             <a:pPr algn="ctr"/>
+            <a:endParaRPr/>
           </a:p>
         </p:txBody>
       </p:sp>
@@ -14127,7 +14299,7 @@
         </p:spPr>
         <p:txBody>
           <a:bodyPr wrap="square">
-            <a:normAutofit/>
+            <a:normAutofit lnSpcReduction="10000"/>
           </a:bodyPr>
           <a:lstStyle/>
           <a:p>
@@ -14219,6 +14391,7 @@
           <a:lstStyle/>
           <a:p>
             <a:pPr algn="ctr"/>
+            <a:endParaRPr/>
           </a:p>
         </p:txBody>
       </p:sp>
@@ -14262,6 +14435,7 @@
           <a:lstStyle/>
           <a:p>
             <a:pPr algn="ctr"/>
+            <a:endParaRPr/>
           </a:p>
         </p:txBody>
       </p:sp>
@@ -14305,6 +14479,7 @@
           <a:lstStyle/>
           <a:p>
             <a:pPr algn="ctr"/>
+            <a:endParaRPr/>
           </a:p>
         </p:txBody>
       </p:sp>
@@ -14348,6 +14523,7 @@
           <a:lstStyle/>
           <a:p>
             <a:pPr algn="ctr"/>
+            <a:endParaRPr/>
           </a:p>
         </p:txBody>
       </p:sp>
@@ -14369,7 +14545,7 @@
         </p:spPr>
         <p:txBody>
           <a:bodyPr wrap="square">
-            <a:normAutofit/>
+            <a:normAutofit fontScale="92500" lnSpcReduction="10000"/>
           </a:bodyPr>
           <a:lstStyle/>
           <a:p>
@@ -14404,7 +14580,7 @@
         </p:spPr>
         <p:txBody>
           <a:bodyPr wrap="square">
-            <a:normAutofit/>
+            <a:normAutofit fontScale="92500" lnSpcReduction="10000"/>
           </a:bodyPr>
           <a:lstStyle/>
           <a:p>
@@ -14461,6 +14637,7 @@
           <a:lstStyle/>
           <a:p>
             <a:pPr algn="ctr"/>
+            <a:endParaRPr/>
           </a:p>
         </p:txBody>
       </p:sp>
@@ -14504,6 +14681,7 @@
           <a:lstStyle/>
           <a:p>
             <a:pPr algn="ctr"/>
+            <a:endParaRPr/>
           </a:p>
         </p:txBody>
       </p:sp>
@@ -14525,7 +14703,7 @@
         </p:spPr>
         <p:txBody>
           <a:bodyPr wrap="square">
-            <a:normAutofit/>
+            <a:normAutofit fontScale="92500" lnSpcReduction="10000"/>
           </a:bodyPr>
           <a:lstStyle/>
           <a:p>
@@ -14582,6 +14760,7 @@
           <a:lstStyle/>
           <a:p>
             <a:pPr algn="ctr"/>
+            <a:endParaRPr/>
           </a:p>
         </p:txBody>
       </p:sp>
@@ -14625,6 +14804,7 @@
           <a:lstStyle/>
           <a:p>
             <a:pPr algn="ctr"/>
+            <a:endParaRPr/>
           </a:p>
         </p:txBody>
       </p:sp>
@@ -14646,7 +14826,7 @@
         </p:spPr>
         <p:txBody>
           <a:bodyPr wrap="square">
-            <a:normAutofit/>
+            <a:normAutofit lnSpcReduction="10000"/>
           </a:bodyPr>
           <a:lstStyle/>
           <a:p>
@@ -14738,6 +14918,7 @@
           <a:lstStyle/>
           <a:p>
             <a:pPr algn="ctr"/>
+            <a:endParaRPr/>
           </a:p>
         </p:txBody>
       </p:sp>
@@ -14781,6 +14962,7 @@
           <a:lstStyle/>
           <a:p>
             <a:pPr algn="ctr"/>
+            <a:endParaRPr/>
           </a:p>
         </p:txBody>
       </p:sp>
@@ -14802,7 +14984,7 @@
         </p:spPr>
         <p:txBody>
           <a:bodyPr wrap="square">
-            <a:normAutofit/>
+            <a:normAutofit lnSpcReduction="10000"/>
           </a:bodyPr>
           <a:lstStyle/>
           <a:p>
@@ -14894,6 +15076,7 @@
           <a:lstStyle/>
           <a:p>
             <a:pPr algn="ctr"/>
+            <a:endParaRPr/>
           </a:p>
         </p:txBody>
       </p:sp>
@@ -14937,6 +15120,7 @@
           <a:lstStyle/>
           <a:p>
             <a:pPr algn="ctr"/>
+            <a:endParaRPr/>
           </a:p>
         </p:txBody>
       </p:sp>
@@ -14958,7 +15142,7 @@
         </p:spPr>
         <p:txBody>
           <a:bodyPr wrap="square">
-            <a:normAutofit/>
+            <a:normAutofit lnSpcReduction="10000"/>
           </a:bodyPr>
           <a:lstStyle/>
           <a:p>
@@ -15050,6 +15234,7 @@
           <a:lstStyle/>
           <a:p>
             <a:pPr algn="ctr"/>
+            <a:endParaRPr/>
           </a:p>
         </p:txBody>
       </p:sp>
@@ -15093,6 +15278,7 @@
           <a:lstStyle/>
           <a:p>
             <a:pPr algn="ctr"/>
+            <a:endParaRPr/>
           </a:p>
         </p:txBody>
       </p:sp>
@@ -15114,7 +15300,7 @@
         </p:spPr>
         <p:txBody>
           <a:bodyPr wrap="square">
-            <a:normAutofit/>
+            <a:normAutofit lnSpcReduction="10000"/>
           </a:bodyPr>
           <a:lstStyle/>
           <a:p>
@@ -15206,6 +15392,7 @@
           <a:lstStyle/>
           <a:p>
             <a:pPr algn="ctr"/>
+            <a:endParaRPr/>
           </a:p>
         </p:txBody>
       </p:sp>
@@ -15288,7 +15475,7 @@
 </file>
 
 <file path=ppt/slides/slide6.xml><?xml version="1.0" encoding="utf-8"?>
-<p:sld xmlns:a="http://schemas.openxmlformats.org/drawingml/2006/main" xmlns:p="http://schemas.openxmlformats.org/presentationml/2006/main" xmlns:r="http://schemas.openxmlformats.org/officeDocument/2006/relationships">
+<p:sld xmlns:a="http://schemas.openxmlformats.org/drawingml/2006/main" xmlns:r="http://schemas.openxmlformats.org/officeDocument/2006/relationships" xmlns:p="http://schemas.openxmlformats.org/presentationml/2006/main">
   <p:cSld>
     <p:bg>
       <p:bgPr>
@@ -15304,7 +15491,14 @@
         <p:cNvGrpSpPr/>
         <p:nvPr/>
       </p:nvGrpSpPr>
-      <p:grpSpPr/>
+      <p:grpSpPr>
+        <a:xfrm>
+          <a:off x="0" y="0"/>
+          <a:ext cx="0" cy="0"/>
+          <a:chOff x="0" y="0"/>
+          <a:chExt cx="0" cy="0"/>
+        </a:xfrm>
+      </p:grpSpPr>
       <p:sp>
         <p:nvSpPr>
           <p:cNvPr id="2" name="Rectangle 1"/>
@@ -15345,6 +15539,7 @@
           <a:lstStyle/>
           <a:p>
             <a:pPr algn="ctr"/>
+            <a:endParaRPr/>
           </a:p>
         </p:txBody>
       </p:sp>
@@ -15388,6 +15583,7 @@
           <a:lstStyle/>
           <a:p>
             <a:pPr algn="ctr"/>
+            <a:endParaRPr/>
           </a:p>
         </p:txBody>
       </p:sp>
@@ -15469,7 +15665,7 @@
         </p:nvSpPr>
         <p:spPr>
           <a:xfrm>
-            <a:off x="237744" y="1645920"/>
+            <a:off x="237744" y="1432052"/>
             <a:ext cx="11704320" cy="25400"/>
           </a:xfrm>
           <a:prstGeom prst="rect">
@@ -15501,6 +15697,7 @@
           <a:lstStyle/>
           <a:p>
             <a:pPr algn="ctr"/>
+            <a:endParaRPr/>
           </a:p>
         </p:txBody>
       </p:sp>
@@ -15544,6 +15741,7 @@
           <a:lstStyle/>
           <a:p>
             <a:pPr algn="ctr"/>
+            <a:endParaRPr/>
           </a:p>
         </p:txBody>
       </p:sp>
@@ -15565,7 +15763,7 @@
         </p:spPr>
         <p:txBody>
           <a:bodyPr wrap="square">
-            <a:normAutofit/>
+            <a:normAutofit fontScale="92500" lnSpcReduction="10000"/>
           </a:bodyPr>
           <a:lstStyle/>
           <a:p>
@@ -15600,7 +15798,7 @@
         </p:spPr>
         <p:txBody>
           <a:bodyPr wrap="square">
-            <a:normAutofit/>
+            <a:normAutofit fontScale="92500" lnSpcReduction="10000"/>
           </a:bodyPr>
           <a:lstStyle/>
           <a:p>
@@ -15635,7 +15833,7 @@
         </p:spPr>
         <p:txBody>
           <a:bodyPr wrap="square">
-            <a:normAutofit/>
+            <a:normAutofit fontScale="92500" lnSpcReduction="10000"/>
           </a:bodyPr>
           <a:lstStyle/>
           <a:p>
@@ -15670,7 +15868,7 @@
         </p:spPr>
         <p:txBody>
           <a:bodyPr wrap="square">
-            <a:normAutofit/>
+            <a:normAutofit fontScale="92500" lnSpcReduction="10000"/>
           </a:bodyPr>
           <a:lstStyle/>
           <a:p>
@@ -15727,6 +15925,7 @@
           <a:lstStyle/>
           <a:p>
             <a:pPr algn="ctr"/>
+            <a:endParaRPr/>
           </a:p>
         </p:txBody>
       </p:sp>
@@ -15770,6 +15969,7 @@
           <a:lstStyle/>
           <a:p>
             <a:pPr algn="ctr"/>
+            <a:endParaRPr/>
           </a:p>
         </p:txBody>
       </p:sp>
@@ -15813,6 +16013,7 @@
           <a:lstStyle/>
           <a:p>
             <a:pPr algn="ctr"/>
+            <a:endParaRPr/>
           </a:p>
         </p:txBody>
       </p:sp>
@@ -15856,6 +16057,7 @@
           <a:lstStyle/>
           <a:p>
             <a:pPr algn="ctr"/>
+            <a:endParaRPr/>
           </a:p>
         </p:txBody>
       </p:sp>
@@ -15899,6 +16101,7 @@
           <a:lstStyle/>
           <a:p>
             <a:pPr algn="ctr"/>
+            <a:endParaRPr/>
           </a:p>
         </p:txBody>
       </p:sp>
@@ -16047,6 +16250,7 @@
           <a:lstStyle/>
           <a:p>
             <a:pPr algn="ctr"/>
+            <a:endParaRPr/>
           </a:p>
         </p:txBody>
       </p:sp>
@@ -16160,6 +16364,7 @@
           <a:lstStyle/>
           <a:p>
             <a:pPr algn="ctr"/>
+            <a:endParaRPr/>
           </a:p>
         </p:txBody>
       </p:sp>
@@ -16203,6 +16408,7 @@
           <a:lstStyle/>
           <a:p>
             <a:pPr algn="ctr"/>
+            <a:endParaRPr/>
           </a:p>
         </p:txBody>
       </p:sp>
@@ -16246,6 +16452,7 @@
           <a:lstStyle/>
           <a:p>
             <a:pPr algn="ctr"/>
+            <a:endParaRPr/>
           </a:p>
         </p:txBody>
       </p:sp>
@@ -16289,6 +16496,7 @@
           <a:lstStyle/>
           <a:p>
             <a:pPr algn="ctr"/>
+            <a:endParaRPr/>
           </a:p>
         </p:txBody>
       </p:sp>
@@ -16332,6 +16540,7 @@
           <a:lstStyle/>
           <a:p>
             <a:pPr algn="ctr"/>
+            <a:endParaRPr/>
           </a:p>
         </p:txBody>
       </p:sp>
@@ -16480,6 +16689,7 @@
           <a:lstStyle/>
           <a:p>
             <a:pPr algn="ctr"/>
+            <a:endParaRPr/>
           </a:p>
         </p:txBody>
       </p:sp>
@@ -16593,6 +16803,7 @@
           <a:lstStyle/>
           <a:p>
             <a:pPr algn="ctr"/>
+            <a:endParaRPr/>
           </a:p>
         </p:txBody>
       </p:sp>
@@ -16636,6 +16847,7 @@
           <a:lstStyle/>
           <a:p>
             <a:pPr algn="ctr"/>
+            <a:endParaRPr/>
           </a:p>
         </p:txBody>
       </p:sp>
@@ -16679,6 +16891,7 @@
           <a:lstStyle/>
           <a:p>
             <a:pPr algn="ctr"/>
+            <a:endParaRPr/>
           </a:p>
         </p:txBody>
       </p:sp>
@@ -16722,6 +16935,7 @@
           <a:lstStyle/>
           <a:p>
             <a:pPr algn="ctr"/>
+            <a:endParaRPr/>
           </a:p>
         </p:txBody>
       </p:sp>
@@ -16765,6 +16979,7 @@
           <a:lstStyle/>
           <a:p>
             <a:pPr algn="ctr"/>
+            <a:endParaRPr/>
           </a:p>
         </p:txBody>
       </p:sp>
@@ -16913,6 +17128,7 @@
           <a:lstStyle/>
           <a:p>
             <a:pPr algn="ctr"/>
+            <a:endParaRPr/>
           </a:p>
         </p:txBody>
       </p:sp>
@@ -17026,6 +17242,7 @@
           <a:lstStyle/>
           <a:p>
             <a:pPr algn="ctr"/>
+            <a:endParaRPr/>
           </a:p>
         </p:txBody>
       </p:sp>
@@ -17069,6 +17286,7 @@
           <a:lstStyle/>
           <a:p>
             <a:pPr algn="ctr"/>
+            <a:endParaRPr/>
           </a:p>
         </p:txBody>
       </p:sp>
@@ -17112,6 +17330,7 @@
           <a:lstStyle/>
           <a:p>
             <a:pPr algn="ctr"/>
+            <a:endParaRPr/>
           </a:p>
         </p:txBody>
       </p:sp>
@@ -17155,6 +17374,7 @@
           <a:lstStyle/>
           <a:p>
             <a:pPr algn="ctr"/>
+            <a:endParaRPr/>
           </a:p>
         </p:txBody>
       </p:sp>
@@ -17176,7 +17396,7 @@
         </p:spPr>
         <p:txBody>
           <a:bodyPr wrap="square">
-            <a:normAutofit/>
+            <a:normAutofit fontScale="92500" lnSpcReduction="10000"/>
           </a:bodyPr>
           <a:lstStyle/>
           <a:p>
@@ -17211,7 +17431,7 @@
         </p:spPr>
         <p:txBody>
           <a:bodyPr wrap="square">
-            <a:normAutofit/>
+            <a:normAutofit fontScale="92500" lnSpcReduction="10000"/>
           </a:bodyPr>
           <a:lstStyle/>
           <a:p>
@@ -17268,6 +17488,7 @@
           <a:lstStyle/>
           <a:p>
             <a:pPr algn="ctr"/>
+            <a:endParaRPr/>
           </a:p>
         </p:txBody>
       </p:sp>
@@ -17289,7 +17510,7 @@
         </p:spPr>
         <p:txBody>
           <a:bodyPr wrap="square">
-            <a:normAutofit/>
+            <a:normAutofit fontScale="92500" lnSpcReduction="10000"/>
           </a:bodyPr>
           <a:lstStyle/>
           <a:p>
@@ -17346,6 +17567,7 @@
           <a:lstStyle/>
           <a:p>
             <a:pPr algn="ctr"/>
+            <a:endParaRPr/>
           </a:p>
         </p:txBody>
       </p:sp>
@@ -17389,6 +17611,7 @@
           <a:lstStyle/>
           <a:p>
             <a:pPr algn="ctr"/>
+            <a:endParaRPr/>
           </a:p>
         </p:txBody>
       </p:sp>
@@ -17502,6 +17725,7 @@
           <a:lstStyle/>
           <a:p>
             <a:pPr algn="ctr"/>
+            <a:endParaRPr/>
           </a:p>
         </p:txBody>
       </p:sp>
@@ -17545,6 +17769,7 @@
           <a:lstStyle/>
           <a:p>
             <a:pPr algn="ctr"/>
+            <a:endParaRPr/>
           </a:p>
         </p:txBody>
       </p:sp>
@@ -17658,6 +17883,7 @@
           <a:lstStyle/>
           <a:p>
             <a:pPr algn="ctr"/>
+            <a:endParaRPr/>
           </a:p>
         </p:txBody>
       </p:sp>
@@ -17701,6 +17927,7 @@
           <a:lstStyle/>
           <a:p>
             <a:pPr algn="ctr"/>
+            <a:endParaRPr/>
           </a:p>
         </p:txBody>
       </p:sp>
@@ -17814,6 +18041,7 @@
           <a:lstStyle/>
           <a:p>
             <a:pPr algn="ctr"/>
+            <a:endParaRPr/>
           </a:p>
         </p:txBody>
       </p:sp>
@@ -17835,7 +18063,7 @@
         </p:spPr>
         <p:txBody>
           <a:bodyPr wrap="square">
-            <a:normAutofit/>
+            <a:normAutofit fontScale="92500" lnSpcReduction="10000"/>
           </a:bodyPr>
           <a:lstStyle/>
           <a:p>
@@ -17892,6 +18120,7 @@
           <a:lstStyle/>
           <a:p>
             <a:pPr algn="ctr"/>
+            <a:endParaRPr/>
           </a:p>
         </p:txBody>
       </p:sp>
@@ -17935,6 +18164,7 @@
           <a:lstStyle/>
           <a:p>
             <a:pPr algn="ctr"/>
+            <a:endParaRPr/>
           </a:p>
         </p:txBody>
       </p:sp>
@@ -18048,6 +18278,7 @@
           <a:lstStyle/>
           <a:p>
             <a:pPr algn="ctr"/>
+            <a:endParaRPr/>
           </a:p>
         </p:txBody>
       </p:sp>
@@ -18091,6 +18322,7 @@
           <a:lstStyle/>
           <a:p>
             <a:pPr algn="ctr"/>
+            <a:endParaRPr/>
           </a:p>
         </p:txBody>
       </p:sp>
@@ -18204,6 +18436,7 @@
           <a:lstStyle/>
           <a:p>
             <a:pPr algn="ctr"/>
+            <a:endParaRPr/>
           </a:p>
         </p:txBody>
       </p:sp>
@@ -18247,6 +18480,7 @@
           <a:lstStyle/>
           <a:p>
             <a:pPr algn="ctr"/>
+            <a:endParaRPr/>
           </a:p>
         </p:txBody>
       </p:sp>
@@ -18360,6 +18594,7 @@
           <a:lstStyle/>
           <a:p>
             <a:pPr algn="ctr"/>
+            <a:endParaRPr/>
           </a:p>
         </p:txBody>
       </p:sp>
@@ -18442,7 +18677,7 @@
 </file>
 
 <file path=ppt/slides/slide7.xml><?xml version="1.0" encoding="utf-8"?>
-<p:sld xmlns:a="http://schemas.openxmlformats.org/drawingml/2006/main" xmlns:p="http://schemas.openxmlformats.org/presentationml/2006/main" xmlns:r="http://schemas.openxmlformats.org/officeDocument/2006/relationships">
+<p:sld xmlns:a="http://schemas.openxmlformats.org/drawingml/2006/main" xmlns:r="http://schemas.openxmlformats.org/officeDocument/2006/relationships" xmlns:p="http://schemas.openxmlformats.org/presentationml/2006/main">
   <p:cSld>
     <p:bg>
       <p:bgPr>
@@ -18458,7 +18693,14 @@
         <p:cNvGrpSpPr/>
         <p:nvPr/>
       </p:nvGrpSpPr>
-      <p:grpSpPr/>
+      <p:grpSpPr>
+        <a:xfrm>
+          <a:off x="0" y="0"/>
+          <a:ext cx="0" cy="0"/>
+          <a:chOff x="0" y="0"/>
+          <a:chExt cx="0" cy="0"/>
+        </a:xfrm>
+      </p:grpSpPr>
       <p:sp>
         <p:nvSpPr>
           <p:cNvPr id="2" name="Rectangle 1"/>
@@ -18499,6 +18741,7 @@
           <a:lstStyle/>
           <a:p>
             <a:pPr algn="ctr"/>
+            <a:endParaRPr/>
           </a:p>
         </p:txBody>
       </p:sp>
@@ -18542,6 +18785,7 @@
           <a:lstStyle/>
           <a:p>
             <a:pPr algn="ctr"/>
+            <a:endParaRPr/>
           </a:p>
         </p:txBody>
       </p:sp>
@@ -18623,7 +18867,7 @@
         </p:nvSpPr>
         <p:spPr>
           <a:xfrm>
-            <a:off x="237744" y="1645920"/>
+            <a:off x="237744" y="1465072"/>
             <a:ext cx="11704320" cy="25400"/>
           </a:xfrm>
           <a:prstGeom prst="rect">
@@ -18655,6 +18899,7 @@
           <a:lstStyle/>
           <a:p>
             <a:pPr algn="ctr"/>
+            <a:endParaRPr/>
           </a:p>
         </p:txBody>
       </p:sp>
@@ -18698,6 +18943,7 @@
           <a:lstStyle/>
           <a:p>
             <a:pPr algn="ctr"/>
+            <a:endParaRPr/>
           </a:p>
         </p:txBody>
       </p:sp>
@@ -18741,6 +18987,7 @@
           <a:lstStyle/>
           <a:p>
             <a:pPr algn="ctr"/>
+            <a:endParaRPr/>
           </a:p>
         </p:txBody>
       </p:sp>
@@ -18762,7 +19009,7 @@
         </p:spPr>
         <p:txBody>
           <a:bodyPr wrap="square">
-            <a:normAutofit/>
+            <a:normAutofit lnSpcReduction="10000"/>
           </a:bodyPr>
           <a:lstStyle/>
           <a:p>
@@ -18819,6 +19066,7 @@
           <a:lstStyle/>
           <a:p>
             <a:pPr algn="ctr"/>
+            <a:endParaRPr/>
           </a:p>
         </p:txBody>
       </p:sp>
@@ -18840,7 +19088,7 @@
         </p:spPr>
         <p:txBody>
           <a:bodyPr wrap="square">
-            <a:normAutofit/>
+            <a:normAutofit lnSpcReduction="10000"/>
           </a:bodyPr>
           <a:lstStyle/>
           <a:p>
@@ -18875,7 +19123,7 @@
         </p:spPr>
         <p:txBody>
           <a:bodyPr wrap="square">
-            <a:normAutofit/>
+            <a:normAutofit lnSpcReduction="10000"/>
           </a:bodyPr>
           <a:lstStyle/>
           <a:p>
@@ -18945,7 +19193,7 @@
         </p:spPr>
         <p:txBody>
           <a:bodyPr wrap="square">
-            <a:normAutofit/>
+            <a:normAutofit lnSpcReduction="10000"/>
           </a:bodyPr>
           <a:lstStyle/>
           <a:p>
@@ -18980,7 +19228,7 @@
         </p:spPr>
         <p:txBody>
           <a:bodyPr wrap="square">
-            <a:normAutofit/>
+            <a:normAutofit lnSpcReduction="10000"/>
           </a:bodyPr>
           <a:lstStyle/>
           <a:p>
@@ -19072,6 +19320,7 @@
           <a:lstStyle/>
           <a:p>
             <a:pPr algn="ctr"/>
+            <a:endParaRPr/>
           </a:p>
         </p:txBody>
       </p:sp>
@@ -19115,6 +19364,7 @@
           <a:lstStyle/>
           <a:p>
             <a:pPr algn="ctr"/>
+            <a:endParaRPr/>
           </a:p>
         </p:txBody>
       </p:sp>
@@ -19136,7 +19386,7 @@
         </p:spPr>
         <p:txBody>
           <a:bodyPr wrap="square">
-            <a:normAutofit/>
+            <a:normAutofit lnSpcReduction="10000"/>
           </a:bodyPr>
           <a:lstStyle/>
           <a:p>
@@ -19193,6 +19443,7 @@
           <a:lstStyle/>
           <a:p>
             <a:pPr algn="ctr"/>
+            <a:endParaRPr/>
           </a:p>
         </p:txBody>
       </p:sp>
@@ -19214,7 +19465,7 @@
         </p:spPr>
         <p:txBody>
           <a:bodyPr wrap="square">
-            <a:normAutofit/>
+            <a:normAutofit lnSpcReduction="10000"/>
           </a:bodyPr>
           <a:lstStyle/>
           <a:p>
@@ -19249,7 +19500,7 @@
         </p:spPr>
         <p:txBody>
           <a:bodyPr wrap="square">
-            <a:normAutofit/>
+            <a:normAutofit lnSpcReduction="10000"/>
           </a:bodyPr>
           <a:lstStyle/>
           <a:p>
@@ -19319,7 +19570,7 @@
         </p:spPr>
         <p:txBody>
           <a:bodyPr wrap="square">
-            <a:normAutofit/>
+            <a:normAutofit lnSpcReduction="10000"/>
           </a:bodyPr>
           <a:lstStyle/>
           <a:p>
@@ -19354,7 +19605,7 @@
         </p:spPr>
         <p:txBody>
           <a:bodyPr wrap="square">
-            <a:normAutofit/>
+            <a:normAutofit lnSpcReduction="10000"/>
           </a:bodyPr>
           <a:lstStyle/>
           <a:p>
@@ -19446,6 +19697,7 @@
           <a:lstStyle/>
           <a:p>
             <a:pPr algn="ctr"/>
+            <a:endParaRPr/>
           </a:p>
         </p:txBody>
       </p:sp>
@@ -19489,6 +19741,7 @@
           <a:lstStyle/>
           <a:p>
             <a:pPr algn="ctr"/>
+            <a:endParaRPr/>
           </a:p>
         </p:txBody>
       </p:sp>
@@ -19510,7 +19763,7 @@
         </p:spPr>
         <p:txBody>
           <a:bodyPr wrap="square">
-            <a:normAutofit/>
+            <a:normAutofit lnSpcReduction="10000"/>
           </a:bodyPr>
           <a:lstStyle/>
           <a:p>
@@ -19567,6 +19820,7 @@
           <a:lstStyle/>
           <a:p>
             <a:pPr algn="ctr"/>
+            <a:endParaRPr/>
           </a:p>
         </p:txBody>
       </p:sp>
@@ -19588,7 +19842,7 @@
         </p:spPr>
         <p:txBody>
           <a:bodyPr wrap="square">
-            <a:normAutofit/>
+            <a:normAutofit lnSpcReduction="10000"/>
           </a:bodyPr>
           <a:lstStyle/>
           <a:p>
@@ -19623,7 +19877,7 @@
         </p:spPr>
         <p:txBody>
           <a:bodyPr wrap="square">
-            <a:normAutofit/>
+            <a:normAutofit lnSpcReduction="10000"/>
           </a:bodyPr>
           <a:lstStyle/>
           <a:p>
@@ -19693,7 +19947,7 @@
         </p:spPr>
         <p:txBody>
           <a:bodyPr wrap="square">
-            <a:normAutofit/>
+            <a:normAutofit lnSpcReduction="10000"/>
           </a:bodyPr>
           <a:lstStyle/>
           <a:p>
@@ -19728,7 +19982,7 @@
         </p:spPr>
         <p:txBody>
           <a:bodyPr wrap="square">
-            <a:normAutofit/>
+            <a:normAutofit lnSpcReduction="10000"/>
           </a:bodyPr>
           <a:lstStyle/>
           <a:p>
@@ -19820,6 +20074,7 @@
           <a:lstStyle/>
           <a:p>
             <a:pPr algn="ctr"/>
+            <a:endParaRPr/>
           </a:p>
         </p:txBody>
       </p:sp>
@@ -19863,6 +20118,7 @@
           <a:lstStyle/>
           <a:p>
             <a:pPr algn="ctr"/>
+            <a:endParaRPr/>
           </a:p>
         </p:txBody>
       </p:sp>
@@ -19941,6 +20197,7 @@
           <a:lstStyle/>
           <a:p>
             <a:pPr algn="ctr"/>
+            <a:endParaRPr/>
           </a:p>
         </p:txBody>
       </p:sp>
@@ -19962,7 +20219,7 @@
         </p:spPr>
         <p:txBody>
           <a:bodyPr wrap="square">
-            <a:normAutofit/>
+            <a:normAutofit lnSpcReduction="10000"/>
           </a:bodyPr>
           <a:lstStyle/>
           <a:p>
@@ -20019,6 +20276,7 @@
           <a:lstStyle/>
           <a:p>
             <a:pPr algn="ctr"/>
+            <a:endParaRPr/>
           </a:p>
         </p:txBody>
       </p:sp>
@@ -20062,6 +20320,7 @@
           <a:lstStyle/>
           <a:p>
             <a:pPr algn="ctr"/>
+            <a:endParaRPr/>
           </a:p>
         </p:txBody>
       </p:sp>
@@ -20083,7 +20342,7 @@
         </p:spPr>
         <p:txBody>
           <a:bodyPr wrap="square">
-            <a:normAutofit/>
+            <a:normAutofit lnSpcReduction="10000"/>
           </a:bodyPr>
           <a:lstStyle/>
           <a:p>
@@ -20140,6 +20399,7 @@
           <a:lstStyle/>
           <a:p>
             <a:pPr algn="ctr"/>
+            <a:endParaRPr/>
           </a:p>
         </p:txBody>
       </p:sp>
@@ -20222,7 +20482,7 @@
 </file>
 
 <file path=ppt/slides/slide8.xml><?xml version="1.0" encoding="utf-8"?>
-<p:sld xmlns:a="http://schemas.openxmlformats.org/drawingml/2006/main" xmlns:p="http://schemas.openxmlformats.org/presentationml/2006/main" xmlns:r="http://schemas.openxmlformats.org/officeDocument/2006/relationships">
+<p:sld xmlns:a="http://schemas.openxmlformats.org/drawingml/2006/main" xmlns:r="http://schemas.openxmlformats.org/officeDocument/2006/relationships" xmlns:p="http://schemas.openxmlformats.org/presentationml/2006/main">
   <p:cSld>
     <p:bg>
       <p:bgPr>
@@ -20238,7 +20498,14 @@
         <p:cNvGrpSpPr/>
         <p:nvPr/>
       </p:nvGrpSpPr>
-      <p:grpSpPr/>
+      <p:grpSpPr>
+        <a:xfrm>
+          <a:off x="0" y="0"/>
+          <a:ext cx="0" cy="0"/>
+          <a:chOff x="0" y="0"/>
+          <a:chExt cx="0" cy="0"/>
+        </a:xfrm>
+      </p:grpSpPr>
       <p:sp>
         <p:nvSpPr>
           <p:cNvPr id="2" name="Rectangle 1"/>
@@ -20279,6 +20546,7 @@
           <a:lstStyle/>
           <a:p>
             <a:pPr algn="ctr"/>
+            <a:endParaRPr/>
           </a:p>
         </p:txBody>
       </p:sp>
@@ -20322,6 +20590,7 @@
           <a:lstStyle/>
           <a:p>
             <a:pPr algn="ctr"/>
+            <a:endParaRPr/>
           </a:p>
         </p:txBody>
       </p:sp>
@@ -20403,7 +20672,7 @@
         </p:nvSpPr>
         <p:spPr>
           <a:xfrm>
-            <a:off x="237744" y="1645920"/>
+            <a:off x="237744" y="1486916"/>
             <a:ext cx="11704320" cy="25400"/>
           </a:xfrm>
           <a:prstGeom prst="rect">
@@ -20435,6 +20704,7 @@
           <a:lstStyle/>
           <a:p>
             <a:pPr algn="ctr"/>
+            <a:endParaRPr/>
           </a:p>
         </p:txBody>
       </p:sp>
@@ -20478,6 +20748,7 @@
           <a:lstStyle/>
           <a:p>
             <a:pPr algn="ctr"/>
+            <a:endParaRPr/>
           </a:p>
         </p:txBody>
       </p:sp>
@@ -20499,7 +20770,7 @@
         </p:spPr>
         <p:txBody>
           <a:bodyPr wrap="square">
-            <a:normAutofit/>
+            <a:normAutofit fontScale="92500" lnSpcReduction="10000"/>
           </a:bodyPr>
           <a:lstStyle/>
           <a:p>
@@ -20556,6 +20827,7 @@
           <a:lstStyle/>
           <a:p>
             <a:pPr algn="ctr"/>
+            <a:endParaRPr/>
           </a:p>
         </p:txBody>
       </p:sp>
@@ -20577,7 +20849,7 @@
         </p:spPr>
         <p:txBody>
           <a:bodyPr wrap="square">
-            <a:normAutofit/>
+            <a:normAutofit fontScale="92500" lnSpcReduction="10000"/>
           </a:bodyPr>
           <a:lstStyle/>
           <a:p>
@@ -20634,6 +20906,7 @@
           <a:lstStyle/>
           <a:p>
             <a:pPr algn="ctr"/>
+            <a:endParaRPr/>
           </a:p>
         </p:txBody>
       </p:sp>
@@ -20655,7 +20928,7 @@
         </p:spPr>
         <p:txBody>
           <a:bodyPr wrap="square">
-            <a:normAutofit/>
+            <a:normAutofit fontScale="92500" lnSpcReduction="10000"/>
           </a:bodyPr>
           <a:lstStyle/>
           <a:p>
@@ -20712,6 +20985,7 @@
           <a:lstStyle/>
           <a:p>
             <a:pPr algn="ctr"/>
+            <a:endParaRPr/>
           </a:p>
         </p:txBody>
       </p:sp>
@@ -20733,7 +21007,7 @@
         </p:spPr>
         <p:txBody>
           <a:bodyPr wrap="square">
-            <a:normAutofit/>
+            <a:normAutofit fontScale="92500" lnSpcReduction="10000"/>
           </a:bodyPr>
           <a:lstStyle/>
           <a:p>
@@ -20790,6 +21064,7 @@
           <a:lstStyle/>
           <a:p>
             <a:pPr algn="ctr"/>
+            <a:endParaRPr/>
           </a:p>
         </p:txBody>
       </p:sp>
@@ -20833,6 +21108,7 @@
           <a:lstStyle/>
           <a:p>
             <a:pPr algn="ctr"/>
+            <a:endParaRPr/>
           </a:p>
         </p:txBody>
       </p:sp>
@@ -20876,6 +21152,7 @@
           <a:lstStyle/>
           <a:p>
             <a:pPr algn="ctr"/>
+            <a:endParaRPr/>
           </a:p>
         </p:txBody>
       </p:sp>
@@ -20919,6 +21196,7 @@
           <a:lstStyle/>
           <a:p>
             <a:pPr algn="ctr"/>
+            <a:endParaRPr/>
           </a:p>
         </p:txBody>
       </p:sp>
@@ -20962,6 +21240,7 @@
           <a:lstStyle/>
           <a:p>
             <a:pPr algn="ctr"/>
+            <a:endParaRPr/>
           </a:p>
         </p:txBody>
       </p:sp>
@@ -21088,7 +21367,7 @@
         </p:spPr>
         <p:txBody>
           <a:bodyPr wrap="square">
-            <a:normAutofit/>
+            <a:normAutofit fontScale="85000" lnSpcReduction="20000"/>
           </a:bodyPr>
           <a:lstStyle/>
           <a:p>
@@ -21123,7 +21402,7 @@
         </p:spPr>
         <p:txBody>
           <a:bodyPr wrap="square">
-            <a:normAutofit/>
+            <a:normAutofit fontScale="85000" lnSpcReduction="20000"/>
           </a:bodyPr>
           <a:lstStyle/>
           <a:p>
@@ -21180,6 +21459,7 @@
           <a:lstStyle/>
           <a:p>
             <a:pPr algn="ctr"/>
+            <a:endParaRPr/>
           </a:p>
         </p:txBody>
       </p:sp>
@@ -21223,6 +21503,7 @@
           <a:lstStyle/>
           <a:p>
             <a:pPr algn="ctr"/>
+            <a:endParaRPr/>
           </a:p>
         </p:txBody>
       </p:sp>
@@ -21266,6 +21547,7 @@
           <a:lstStyle/>
           <a:p>
             <a:pPr algn="ctr"/>
+            <a:endParaRPr/>
           </a:p>
         </p:txBody>
       </p:sp>
@@ -21309,6 +21591,7 @@
           <a:lstStyle/>
           <a:p>
             <a:pPr algn="ctr"/>
+            <a:endParaRPr/>
           </a:p>
         </p:txBody>
       </p:sp>
@@ -21352,6 +21635,7 @@
           <a:lstStyle/>
           <a:p>
             <a:pPr algn="ctr"/>
+            <a:endParaRPr/>
           </a:p>
         </p:txBody>
       </p:sp>
@@ -21548,7 +21832,7 @@
         </p:spPr>
         <p:txBody>
           <a:bodyPr wrap="square">
-            <a:normAutofit/>
+            <a:normAutofit fontScale="85000" lnSpcReduction="20000"/>
           </a:bodyPr>
           <a:lstStyle/>
           <a:p>
@@ -21605,6 +21889,7 @@
           <a:lstStyle/>
           <a:p>
             <a:pPr algn="ctr"/>
+            <a:endParaRPr/>
           </a:p>
         </p:txBody>
       </p:sp>
@@ -21648,6 +21933,7 @@
           <a:lstStyle/>
           <a:p>
             <a:pPr algn="ctr"/>
+            <a:endParaRPr/>
           </a:p>
         </p:txBody>
       </p:sp>
@@ -21691,6 +21977,7 @@
           <a:lstStyle/>
           <a:p>
             <a:pPr algn="ctr"/>
+            <a:endParaRPr/>
           </a:p>
         </p:txBody>
       </p:sp>
@@ -21734,6 +22021,7 @@
           <a:lstStyle/>
           <a:p>
             <a:pPr algn="ctr"/>
+            <a:endParaRPr/>
           </a:p>
         </p:txBody>
       </p:sp>
@@ -21777,6 +22065,7 @@
           <a:lstStyle/>
           <a:p>
             <a:pPr algn="ctr"/>
+            <a:endParaRPr/>
           </a:p>
         </p:txBody>
       </p:sp>
@@ -22065,6 +22354,7 @@
           <a:lstStyle/>
           <a:p>
             <a:pPr algn="ctr"/>
+            <a:endParaRPr/>
           </a:p>
         </p:txBody>
       </p:sp>
@@ -22108,6 +22398,7 @@
           <a:lstStyle/>
           <a:p>
             <a:pPr algn="ctr"/>
+            <a:endParaRPr/>
           </a:p>
         </p:txBody>
       </p:sp>
@@ -22151,6 +22442,7 @@
           <a:lstStyle/>
           <a:p>
             <a:pPr algn="ctr"/>
+            <a:endParaRPr/>
           </a:p>
         </p:txBody>
       </p:sp>
@@ -22194,6 +22486,7 @@
           <a:lstStyle/>
           <a:p>
             <a:pPr algn="ctr"/>
+            <a:endParaRPr/>
           </a:p>
         </p:txBody>
       </p:sp>
@@ -22215,7 +22508,7 @@
         </p:spPr>
         <p:txBody>
           <a:bodyPr wrap="square">
-            <a:normAutofit/>
+            <a:normAutofit lnSpcReduction="10000"/>
           </a:bodyPr>
           <a:lstStyle/>
           <a:p>
@@ -22250,7 +22543,7 @@
         </p:spPr>
         <p:txBody>
           <a:bodyPr wrap="square">
-            <a:normAutofit/>
+            <a:normAutofit lnSpcReduction="10000"/>
           </a:bodyPr>
           <a:lstStyle/>
           <a:p>
@@ -22285,7 +22578,7 @@
         </p:spPr>
         <p:txBody>
           <a:bodyPr wrap="square">
-            <a:normAutofit/>
+            <a:normAutofit lnSpcReduction="10000"/>
           </a:bodyPr>
           <a:lstStyle/>
           <a:p>
@@ -22320,7 +22613,7 @@
         </p:spPr>
         <p:txBody>
           <a:bodyPr wrap="square">
-            <a:normAutofit/>
+            <a:normAutofit lnSpcReduction="10000"/>
           </a:bodyPr>
           <a:lstStyle/>
           <a:p>
@@ -22377,6 +22670,7 @@
           <a:lstStyle/>
           <a:p>
             <a:pPr algn="ctr"/>
+            <a:endParaRPr/>
           </a:p>
         </p:txBody>
       </p:sp>
@@ -22420,6 +22714,7 @@
           <a:lstStyle/>
           <a:p>
             <a:pPr algn="ctr"/>
+            <a:endParaRPr/>
           </a:p>
         </p:txBody>
       </p:sp>
@@ -22441,7 +22736,7 @@
         </p:spPr>
         <p:txBody>
           <a:bodyPr wrap="square">
-            <a:normAutofit/>
+            <a:normAutofit fontScale="85000" lnSpcReduction="20000"/>
           </a:bodyPr>
           <a:lstStyle/>
           <a:p>
@@ -22498,6 +22793,7 @@
           <a:lstStyle/>
           <a:p>
             <a:pPr algn="ctr"/>
+            <a:endParaRPr/>
           </a:p>
         </p:txBody>
       </p:sp>
@@ -22519,7 +22815,7 @@
         </p:spPr>
         <p:txBody>
           <a:bodyPr wrap="square">
-            <a:normAutofit/>
+            <a:normAutofit fontScale="92500" lnSpcReduction="10000"/>
           </a:bodyPr>
           <a:lstStyle/>
           <a:p>
@@ -22576,6 +22872,7 @@
           <a:lstStyle/>
           <a:p>
             <a:pPr algn="ctr"/>
+            <a:endParaRPr/>
           </a:p>
         </p:txBody>
       </p:sp>
@@ -22597,7 +22894,7 @@
         </p:spPr>
         <p:txBody>
           <a:bodyPr wrap="square">
-            <a:normAutofit/>
+            <a:normAutofit fontScale="92500" lnSpcReduction="10000"/>
           </a:bodyPr>
           <a:lstStyle/>
           <a:p>
@@ -22654,6 +22951,7 @@
           <a:lstStyle/>
           <a:p>
             <a:pPr algn="ctr"/>
+            <a:endParaRPr/>
           </a:p>
         </p:txBody>
       </p:sp>
@@ -22675,7 +22973,7 @@
         </p:spPr>
         <p:txBody>
           <a:bodyPr wrap="square">
-            <a:normAutofit/>
+            <a:normAutofit fontScale="92500" lnSpcReduction="10000"/>
           </a:bodyPr>
           <a:lstStyle/>
           <a:p>
@@ -22732,6 +23030,7 @@
           <a:lstStyle/>
           <a:p>
             <a:pPr algn="ctr"/>
+            <a:endParaRPr/>
           </a:p>
         </p:txBody>
       </p:sp>
@@ -22814,7 +23113,7 @@
 </file>
 
 <file path=ppt/slides/slide9.xml><?xml version="1.0" encoding="utf-8"?>
-<p:sld xmlns:a="http://schemas.openxmlformats.org/drawingml/2006/main" xmlns:p="http://schemas.openxmlformats.org/presentationml/2006/main" xmlns:r="http://schemas.openxmlformats.org/officeDocument/2006/relationships">
+<p:sld xmlns:a="http://schemas.openxmlformats.org/drawingml/2006/main" xmlns:r="http://schemas.openxmlformats.org/officeDocument/2006/relationships" xmlns:p="http://schemas.openxmlformats.org/presentationml/2006/main">
   <p:cSld>
     <p:bg>
       <p:bgPr>
@@ -22830,7 +23129,14 @@
         <p:cNvGrpSpPr/>
         <p:nvPr/>
       </p:nvGrpSpPr>
-      <p:grpSpPr/>
+      <p:grpSpPr>
+        <a:xfrm>
+          <a:off x="0" y="0"/>
+          <a:ext cx="0" cy="0"/>
+          <a:chOff x="0" y="0"/>
+          <a:chExt cx="0" cy="0"/>
+        </a:xfrm>
+      </p:grpSpPr>
       <p:sp>
         <p:nvSpPr>
           <p:cNvPr id="2" name="Rectangle 1"/>
@@ -22871,6 +23177,7 @@
           <a:lstStyle/>
           <a:p>
             <a:pPr algn="ctr"/>
+            <a:endParaRPr/>
           </a:p>
         </p:txBody>
       </p:sp>
@@ -22914,6 +23221,7 @@
           <a:lstStyle/>
           <a:p>
             <a:pPr algn="ctr"/>
+            <a:endParaRPr/>
           </a:p>
         </p:txBody>
       </p:sp>
@@ -22995,7 +23303,7 @@
         </p:nvSpPr>
         <p:spPr>
           <a:xfrm>
-            <a:off x="237744" y="1645920"/>
+            <a:off x="256032" y="1465523"/>
             <a:ext cx="11704320" cy="25400"/>
           </a:xfrm>
           <a:prstGeom prst="rect">
@@ -23027,6 +23335,7 @@
           <a:lstStyle/>
           <a:p>
             <a:pPr algn="ctr"/>
+            <a:endParaRPr/>
           </a:p>
         </p:txBody>
       </p:sp>
@@ -23070,6 +23379,7 @@
           <a:lstStyle/>
           <a:p>
             <a:pPr algn="ctr"/>
+            <a:endParaRPr/>
           </a:p>
         </p:txBody>
       </p:sp>
@@ -23113,6 +23423,7 @@
           <a:lstStyle/>
           <a:p>
             <a:pPr algn="ctr"/>
+            <a:endParaRPr/>
           </a:p>
         </p:txBody>
       </p:sp>
@@ -23134,7 +23445,7 @@
         </p:spPr>
         <p:txBody>
           <a:bodyPr wrap="square">
-            <a:normAutofit/>
+            <a:normAutofit fontScale="92500" lnSpcReduction="10000"/>
           </a:bodyPr>
           <a:lstStyle/>
           <a:p>
@@ -23191,6 +23502,7 @@
           <a:lstStyle/>
           <a:p>
             <a:pPr algn="ctr"/>
+            <a:endParaRPr/>
           </a:p>
         </p:txBody>
       </p:sp>
@@ -23212,7 +23524,7 @@
         </p:spPr>
         <p:txBody>
           <a:bodyPr wrap="square">
-            <a:normAutofit/>
+            <a:normAutofit fontScale="92500" lnSpcReduction="10000"/>
           </a:bodyPr>
           <a:lstStyle/>
           <a:p>
@@ -23269,6 +23581,7 @@
           <a:lstStyle/>
           <a:p>
             <a:pPr algn="ctr"/>
+            <a:endParaRPr/>
           </a:p>
         </p:txBody>
       </p:sp>
@@ -23290,7 +23603,7 @@
         </p:spPr>
         <p:txBody>
           <a:bodyPr wrap="square">
-            <a:normAutofit/>
+            <a:normAutofit fontScale="92500" lnSpcReduction="10000"/>
           </a:bodyPr>
           <a:lstStyle/>
           <a:p>
@@ -23347,6 +23660,7 @@
           <a:lstStyle/>
           <a:p>
             <a:pPr algn="ctr"/>
+            <a:endParaRPr/>
           </a:p>
         </p:txBody>
       </p:sp>
@@ -23368,7 +23682,7 @@
         </p:spPr>
         <p:txBody>
           <a:bodyPr wrap="square">
-            <a:normAutofit/>
+            <a:normAutofit fontScale="92500" lnSpcReduction="10000"/>
           </a:bodyPr>
           <a:lstStyle/>
           <a:p>
@@ -23425,6 +23739,7 @@
           <a:lstStyle/>
           <a:p>
             <a:pPr algn="ctr"/>
+            <a:endParaRPr/>
           </a:p>
         </p:txBody>
       </p:sp>
@@ -23446,7 +23761,7 @@
         </p:spPr>
         <p:txBody>
           <a:bodyPr wrap="square">
-            <a:normAutofit/>
+            <a:normAutofit fontScale="92500" lnSpcReduction="10000"/>
           </a:bodyPr>
           <a:lstStyle/>
           <a:p>
@@ -23503,6 +23818,7 @@
           <a:lstStyle/>
           <a:p>
             <a:pPr algn="ctr"/>
+            <a:endParaRPr/>
           </a:p>
         </p:txBody>
       </p:sp>
@@ -23546,6 +23862,7 @@
           <a:lstStyle/>
           <a:p>
             <a:pPr algn="ctr"/>
+            <a:endParaRPr/>
           </a:p>
         </p:txBody>
       </p:sp>
@@ -23589,6 +23906,7 @@
           <a:lstStyle/>
           <a:p>
             <a:pPr algn="ctr"/>
+            <a:endParaRPr/>
           </a:p>
         </p:txBody>
       </p:sp>
@@ -23632,6 +23950,7 @@
           <a:lstStyle/>
           <a:p>
             <a:pPr algn="ctr"/>
+            <a:endParaRPr/>
           </a:p>
         </p:txBody>
       </p:sp>
@@ -23675,6 +23994,7 @@
           <a:lstStyle/>
           <a:p>
             <a:pPr algn="ctr"/>
+            <a:endParaRPr/>
           </a:p>
         </p:txBody>
       </p:sp>
@@ -23696,7 +24016,7 @@
         </p:spPr>
         <p:txBody>
           <a:bodyPr wrap="square">
-            <a:normAutofit/>
+            <a:normAutofit fontScale="70000" lnSpcReduction="20000"/>
           </a:bodyPr>
           <a:lstStyle/>
           <a:p>
@@ -23731,7 +24051,7 @@
         </p:spPr>
         <p:txBody>
           <a:bodyPr wrap="square">
-            <a:normAutofit/>
+            <a:normAutofit fontScale="70000" lnSpcReduction="20000"/>
           </a:bodyPr>
           <a:lstStyle/>
           <a:p>
@@ -23766,7 +24086,7 @@
         </p:spPr>
         <p:txBody>
           <a:bodyPr wrap="square">
-            <a:normAutofit/>
+            <a:normAutofit fontScale="70000" lnSpcReduction="20000"/>
           </a:bodyPr>
           <a:lstStyle/>
           <a:p>
@@ -23801,7 +24121,7 @@
         </p:spPr>
         <p:txBody>
           <a:bodyPr wrap="square">
-            <a:normAutofit/>
+            <a:normAutofit fontScale="70000" lnSpcReduction="20000"/>
           </a:bodyPr>
           <a:lstStyle/>
           <a:p>
@@ -23858,6 +24178,7 @@
           <a:lstStyle/>
           <a:p>
             <a:pPr algn="ctr"/>
+            <a:endParaRPr/>
           </a:p>
         </p:txBody>
       </p:sp>
@@ -23901,6 +24222,7 @@
           <a:lstStyle/>
           <a:p>
             <a:pPr algn="ctr"/>
+            <a:endParaRPr/>
           </a:p>
         </p:txBody>
       </p:sp>
@@ -23944,6 +24266,7 @@
           <a:lstStyle/>
           <a:p>
             <a:pPr algn="ctr"/>
+            <a:endParaRPr/>
           </a:p>
         </p:txBody>
       </p:sp>
@@ -23987,6 +24310,7 @@
           <a:lstStyle/>
           <a:p>
             <a:pPr algn="ctr"/>
+            <a:endParaRPr/>
           </a:p>
         </p:txBody>
       </p:sp>
@@ -24030,6 +24354,7 @@
           <a:lstStyle/>
           <a:p>
             <a:pPr algn="ctr"/>
+            <a:endParaRPr/>
           </a:p>
         </p:txBody>
       </p:sp>
@@ -24051,7 +24376,7 @@
         </p:spPr>
         <p:txBody>
           <a:bodyPr wrap="square">
-            <a:normAutofit/>
+            <a:normAutofit fontScale="70000" lnSpcReduction="20000"/>
           </a:bodyPr>
           <a:lstStyle/>
           <a:p>
@@ -24086,7 +24411,7 @@
         </p:spPr>
         <p:txBody>
           <a:bodyPr wrap="square">
-            <a:normAutofit/>
+            <a:normAutofit fontScale="70000" lnSpcReduction="20000"/>
           </a:bodyPr>
           <a:lstStyle/>
           <a:p>
@@ -24121,7 +24446,7 @@
         </p:spPr>
         <p:txBody>
           <a:bodyPr wrap="square">
-            <a:normAutofit/>
+            <a:normAutofit fontScale="70000" lnSpcReduction="20000"/>
           </a:bodyPr>
           <a:lstStyle/>
           <a:p>
@@ -24156,7 +24481,7 @@
         </p:spPr>
         <p:txBody>
           <a:bodyPr wrap="square">
-            <a:normAutofit/>
+            <a:normAutofit fontScale="70000" lnSpcReduction="20000"/>
           </a:bodyPr>
           <a:lstStyle/>
           <a:p>
@@ -24213,6 +24538,7 @@
           <a:lstStyle/>
           <a:p>
             <a:pPr algn="ctr"/>
+            <a:endParaRPr/>
           </a:p>
         </p:txBody>
       </p:sp>
@@ -24256,6 +24582,7 @@
           <a:lstStyle/>
           <a:p>
             <a:pPr algn="ctr"/>
+            <a:endParaRPr/>
           </a:p>
         </p:txBody>
       </p:sp>
@@ -24299,6 +24626,7 @@
           <a:lstStyle/>
           <a:p>
             <a:pPr algn="ctr"/>
+            <a:endParaRPr/>
           </a:p>
         </p:txBody>
       </p:sp>
@@ -24342,6 +24670,7 @@
           <a:lstStyle/>
           <a:p>
             <a:pPr algn="ctr"/>
+            <a:endParaRPr/>
           </a:p>
         </p:txBody>
       </p:sp>
@@ -24385,6 +24714,7 @@
           <a:lstStyle/>
           <a:p>
             <a:pPr algn="ctr"/>
+            <a:endParaRPr/>
           </a:p>
         </p:txBody>
       </p:sp>
@@ -24406,7 +24736,7 @@
         </p:spPr>
         <p:txBody>
           <a:bodyPr wrap="square">
-            <a:normAutofit/>
+            <a:normAutofit fontScale="70000" lnSpcReduction="20000"/>
           </a:bodyPr>
           <a:lstStyle/>
           <a:p>
@@ -24441,7 +24771,7 @@
         </p:spPr>
         <p:txBody>
           <a:bodyPr wrap="square">
-            <a:normAutofit/>
+            <a:normAutofit fontScale="70000" lnSpcReduction="20000"/>
           </a:bodyPr>
           <a:lstStyle/>
           <a:p>
@@ -24476,7 +24806,7 @@
         </p:spPr>
         <p:txBody>
           <a:bodyPr wrap="square">
-            <a:normAutofit/>
+            <a:normAutofit fontScale="70000" lnSpcReduction="20000"/>
           </a:bodyPr>
           <a:lstStyle/>
           <a:p>
@@ -24511,7 +24841,7 @@
         </p:spPr>
         <p:txBody>
           <a:bodyPr wrap="square">
-            <a:normAutofit/>
+            <a:normAutofit fontScale="70000" lnSpcReduction="20000"/>
           </a:bodyPr>
           <a:lstStyle/>
           <a:p>
@@ -24568,6 +24898,7 @@
           <a:lstStyle/>
           <a:p>
             <a:pPr algn="ctr"/>
+            <a:endParaRPr/>
           </a:p>
         </p:txBody>
       </p:sp>
@@ -24611,6 +24942,7 @@
           <a:lstStyle/>
           <a:p>
             <a:pPr algn="ctr"/>
+            <a:endParaRPr/>
           </a:p>
         </p:txBody>
       </p:sp>
@@ -24654,6 +24986,7 @@
           <a:lstStyle/>
           <a:p>
             <a:pPr algn="ctr"/>
+            <a:endParaRPr/>
           </a:p>
         </p:txBody>
       </p:sp>
@@ -24697,6 +25030,7 @@
           <a:lstStyle/>
           <a:p>
             <a:pPr algn="ctr"/>
+            <a:endParaRPr/>
           </a:p>
         </p:txBody>
       </p:sp>
@@ -24740,6 +25074,7 @@
           <a:lstStyle/>
           <a:p>
             <a:pPr algn="ctr"/>
+            <a:endParaRPr/>
           </a:p>
         </p:txBody>
       </p:sp>
@@ -24761,7 +25096,7 @@
         </p:spPr>
         <p:txBody>
           <a:bodyPr wrap="square">
-            <a:normAutofit/>
+            <a:normAutofit fontScale="70000" lnSpcReduction="20000"/>
           </a:bodyPr>
           <a:lstStyle/>
           <a:p>
@@ -24796,7 +25131,7 @@
         </p:spPr>
         <p:txBody>
           <a:bodyPr wrap="square">
-            <a:normAutofit/>
+            <a:normAutofit fontScale="70000" lnSpcReduction="20000"/>
           </a:bodyPr>
           <a:lstStyle/>
           <a:p>
@@ -24831,7 +25166,7 @@
         </p:spPr>
         <p:txBody>
           <a:bodyPr wrap="square">
-            <a:normAutofit/>
+            <a:normAutofit fontScale="70000" lnSpcReduction="20000"/>
           </a:bodyPr>
           <a:lstStyle/>
           <a:p>
@@ -24866,7 +25201,7 @@
         </p:spPr>
         <p:txBody>
           <a:bodyPr wrap="square">
-            <a:normAutofit/>
+            <a:normAutofit fontScale="70000" lnSpcReduction="20000"/>
           </a:bodyPr>
           <a:lstStyle/>
           <a:p>
@@ -24923,6 +25258,7 @@
           <a:lstStyle/>
           <a:p>
             <a:pPr algn="ctr"/>
+            <a:endParaRPr/>
           </a:p>
         </p:txBody>
       </p:sp>
@@ -24966,6 +25302,7 @@
           <a:lstStyle/>
           <a:p>
             <a:pPr algn="ctr"/>
+            <a:endParaRPr/>
           </a:p>
         </p:txBody>
       </p:sp>
@@ -25009,6 +25346,7 @@
           <a:lstStyle/>
           <a:p>
             <a:pPr algn="ctr"/>
+            <a:endParaRPr/>
           </a:p>
         </p:txBody>
       </p:sp>
@@ -25052,6 +25390,7 @@
           <a:lstStyle/>
           <a:p>
             <a:pPr algn="ctr"/>
+            <a:endParaRPr/>
           </a:p>
         </p:txBody>
       </p:sp>
@@ -25095,6 +25434,7 @@
           <a:lstStyle/>
           <a:p>
             <a:pPr algn="ctr"/>
+            <a:endParaRPr/>
           </a:p>
         </p:txBody>
       </p:sp>
@@ -25116,7 +25456,7 @@
         </p:spPr>
         <p:txBody>
           <a:bodyPr wrap="square">
-            <a:normAutofit/>
+            <a:normAutofit fontScale="70000" lnSpcReduction="20000"/>
           </a:bodyPr>
           <a:lstStyle/>
           <a:p>
@@ -25151,7 +25491,7 @@
         </p:spPr>
         <p:txBody>
           <a:bodyPr wrap="square">
-            <a:normAutofit/>
+            <a:normAutofit fontScale="70000" lnSpcReduction="20000"/>
           </a:bodyPr>
           <a:lstStyle/>
           <a:p>
@@ -25186,7 +25526,7 @@
         </p:spPr>
         <p:txBody>
           <a:bodyPr wrap="square">
-            <a:normAutofit/>
+            <a:normAutofit fontScale="70000" lnSpcReduction="20000"/>
           </a:bodyPr>
           <a:lstStyle/>
           <a:p>
@@ -25221,7 +25561,7 @@
         </p:spPr>
         <p:txBody>
           <a:bodyPr wrap="square">
-            <a:normAutofit/>
+            <a:normAutofit fontScale="70000" lnSpcReduction="20000"/>
           </a:bodyPr>
           <a:lstStyle/>
           <a:p>
@@ -25278,6 +25618,7 @@
           <a:lstStyle/>
           <a:p>
             <a:pPr algn="ctr"/>
+            <a:endParaRPr/>
           </a:p>
         </p:txBody>
       </p:sp>
@@ -25321,6 +25662,7 @@
           <a:lstStyle/>
           <a:p>
             <a:pPr algn="ctr"/>
+            <a:endParaRPr/>
           </a:p>
         </p:txBody>
       </p:sp>
@@ -25364,6 +25706,7 @@
           <a:lstStyle/>
           <a:p>
             <a:pPr algn="ctr"/>
+            <a:endParaRPr/>
           </a:p>
         </p:txBody>
       </p:sp>
@@ -25407,6 +25750,7 @@
           <a:lstStyle/>
           <a:p>
             <a:pPr algn="ctr"/>
+            <a:endParaRPr/>
           </a:p>
         </p:txBody>
       </p:sp>
@@ -25450,6 +25794,7 @@
           <a:lstStyle/>
           <a:p>
             <a:pPr algn="ctr"/>
+            <a:endParaRPr/>
           </a:p>
         </p:txBody>
       </p:sp>
@@ -25471,7 +25816,7 @@
         </p:spPr>
         <p:txBody>
           <a:bodyPr wrap="square">
-            <a:normAutofit/>
+            <a:normAutofit fontScale="70000" lnSpcReduction="20000"/>
           </a:bodyPr>
           <a:lstStyle/>
           <a:p>
@@ -25506,7 +25851,7 @@
         </p:spPr>
         <p:txBody>
           <a:bodyPr wrap="square">
-            <a:normAutofit/>
+            <a:normAutofit fontScale="70000" lnSpcReduction="20000"/>
           </a:bodyPr>
           <a:lstStyle/>
           <a:p>
@@ -25541,7 +25886,7 @@
         </p:spPr>
         <p:txBody>
           <a:bodyPr wrap="square">
-            <a:normAutofit/>
+            <a:normAutofit fontScale="70000" lnSpcReduction="20000"/>
           </a:bodyPr>
           <a:lstStyle/>
           <a:p>
@@ -25576,7 +25921,7 @@
         </p:spPr>
         <p:txBody>
           <a:bodyPr wrap="square">
-            <a:normAutofit/>
+            <a:normAutofit fontScale="70000" lnSpcReduction="20000"/>
           </a:bodyPr>
           <a:lstStyle/>
           <a:p>
@@ -25633,6 +25978,7 @@
           <a:lstStyle/>
           <a:p>
             <a:pPr algn="ctr"/>
+            <a:endParaRPr/>
           </a:p>
         </p:txBody>
       </p:sp>
@@ -25676,6 +26022,7 @@
           <a:lstStyle/>
           <a:p>
             <a:pPr algn="ctr"/>
+            <a:endParaRPr/>
           </a:p>
         </p:txBody>
       </p:sp>
@@ -25697,7 +26044,7 @@
         </p:spPr>
         <p:txBody>
           <a:bodyPr wrap="square">
-            <a:normAutofit/>
+            <a:normAutofit lnSpcReduction="10000"/>
           </a:bodyPr>
           <a:lstStyle/>
           <a:p>
@@ -25754,6 +26101,7 @@
           <a:lstStyle/>
           <a:p>
             <a:pPr algn="ctr"/>
+            <a:endParaRPr/>
           </a:p>
         </p:txBody>
       </p:sp>
@@ -25797,6 +26145,7 @@
           <a:lstStyle/>
           <a:p>
             <a:pPr algn="ctr"/>
+            <a:endParaRPr/>
           </a:p>
         </p:txBody>
       </p:sp>
@@ -25818,7 +26167,7 @@
         </p:spPr>
         <p:txBody>
           <a:bodyPr wrap="square">
-            <a:normAutofit/>
+            <a:normAutofit fontScale="85000" lnSpcReduction="20000"/>
           </a:bodyPr>
           <a:lstStyle/>
           <a:p>
@@ -25875,6 +26224,7 @@
           <a:lstStyle/>
           <a:p>
             <a:pPr algn="ctr"/>
+            <a:endParaRPr/>
           </a:p>
         </p:txBody>
       </p:sp>
@@ -25896,7 +26246,7 @@
         </p:spPr>
         <p:txBody>
           <a:bodyPr wrap="square">
-            <a:normAutofit/>
+            <a:normAutofit fontScale="92500" lnSpcReduction="20000"/>
           </a:bodyPr>
           <a:lstStyle/>
           <a:p>
@@ -25953,6 +26303,7 @@
           <a:lstStyle/>
           <a:p>
             <a:pPr algn="ctr"/>
+            <a:endParaRPr/>
           </a:p>
         </p:txBody>
       </p:sp>
@@ -25974,7 +26325,7 @@
         </p:spPr>
         <p:txBody>
           <a:bodyPr wrap="square">
-            <a:normAutofit/>
+            <a:normAutofit fontScale="92500" lnSpcReduction="20000"/>
           </a:bodyPr>
           <a:lstStyle/>
           <a:p>
@@ -26031,6 +26382,7 @@
           <a:lstStyle/>
           <a:p>
             <a:pPr algn="ctr"/>
+            <a:endParaRPr/>
           </a:p>
         </p:txBody>
       </p:sp>
@@ -26052,7 +26404,7 @@
         </p:spPr>
         <p:txBody>
           <a:bodyPr wrap="square">
-            <a:normAutofit/>
+            <a:normAutofit fontScale="92500" lnSpcReduction="20000"/>
           </a:bodyPr>
           <a:lstStyle/>
           <a:p>
@@ -26109,6 +26461,7 @@
           <a:lstStyle/>
           <a:p>
             <a:pPr algn="ctr"/>
+            <a:endParaRPr/>
           </a:p>
         </p:txBody>
       </p:sp>
@@ -26130,7 +26483,7 @@
         </p:spPr>
         <p:txBody>
           <a:bodyPr wrap="square">
-            <a:normAutofit/>
+            <a:normAutofit fontScale="92500" lnSpcReduction="20000"/>
           </a:bodyPr>
           <a:lstStyle/>
           <a:p>
@@ -26187,6 +26540,7 @@
           <a:lstStyle/>
           <a:p>
             <a:pPr algn="ctr"/>
+            <a:endParaRPr/>
           </a:p>
         </p:txBody>
       </p:sp>

</xml_diff>